<commit_message>
Replace quizzes with short exercises and add PDFs
</commit_message>
<xml_diff>
--- a/raw/utama-en/00-Slide-Kuliah/01-computers-and-operating-systems.pptx
+++ b/raw/utama-en/00-Slide-Kuliah/01-computers-and-operating-systems.pptx
@@ -5,24 +5,24 @@
     <p:sldMasterId id="2147483648" r:id="rId1"/>
   </p:sldMasterIdLst>
   <p:notesMasterIdLst>
-    <p:notesMasterId r:id="rId17"/>
+    <p:notesMasterId r:id="rId30"/>
   </p:notesMasterIdLst>
   <p:sldIdLst>
-    <p:sldId id="256" r:id="rId2"/>
-    <p:sldId id="257" r:id="rId3"/>
-    <p:sldId id="258" r:id="rId4"/>
-    <p:sldId id="259" r:id="rId5"/>
-    <p:sldId id="260" r:id="rId6"/>
-    <p:sldId id="261" r:id="rId7"/>
-    <p:sldId id="262" r:id="rId8"/>
-    <p:sldId id="263" r:id="rId9"/>
-    <p:sldId id="264" r:id="rId10"/>
-    <p:sldId id="265" r:id="rId11"/>
-    <p:sldId id="266" r:id="rId12"/>
-    <p:sldId id="267" r:id="rId13"/>
-    <p:sldId id="268" r:id="rId14"/>
-    <p:sldId id="269" r:id="rId15"/>
-    <p:sldId id="270" r:id="rId16"/>
+    <p:sldId id="256" r:id="rId9"/>
+    <p:sldId id="257" r:id="rId10"/>
+    <p:sldId id="258" r:id="rId11"/>
+    <p:sldId id="259" r:id="rId12"/>
+    <p:sldId id="260" r:id="rId13"/>
+    <p:sldId id="261" r:id="rId14"/>
+    <p:sldId id="262" r:id="rId15"/>
+    <p:sldId id="263" r:id="rId16"/>
+    <p:sldId id="264" r:id="rId17"/>
+    <p:sldId id="265" r:id="rId18"/>
+    <p:sldId id="266" r:id="rId19"/>
+    <p:sldId id="267" r:id="rId20"/>
+    <p:sldId id="268" r:id="rId21"/>
+    <p:sldId id="269" r:id="rId22"/>
+    <p:sldId id="270" r:id="rId23"/>
   </p:sldIdLst>
   <p:sldSz cx="9144000" cy="5143500" type="screen16x9"/>
   <p:notesSz cx="9144000" cy="5143500"/>
@@ -50,37 +50,29 @@
 </p:presentation>
 </file>
 
+<file path=ppt/revisionInfo.xml><?xml version="1.0" encoding="utf-8"?>
+<p1510:revInfo xmlns:a="http://schemas.openxmlformats.org/drawingml/2006/main" xmlns:r="http://schemas.openxmlformats.org/officeDocument/2006/relationships" xmlns:p1510="http://schemas.microsoft.com/office/powerpoint/2015/10/main">
+  <p1510:revLst>
+    <p1510:client id="{5B041275-210B-4BBC-9987-5E828E75D554}" v="61" dt="2026-08-23T17:26:28.233"/>
+  </p1510:revLst>
+</p1510:revInfo>
+</file>
+
 <file path=ppt/changesInfos/changesInfo1.xml><?xml version="1.0" encoding="utf-8"?>
 <pc:chgInfo xmlns:a="http://schemas.openxmlformats.org/drawingml/2006/main" xmlns:r="http://schemas.openxmlformats.org/officeDocument/2006/relationships" xmlns:ac="http://schemas.microsoft.com/office/drawing/2013/main/command" xmlns:pc="http://schemas.microsoft.com/office/powerpoint/2013/main/command">
   <pc:docChgLst>
     <pc:chgData name="Vempi Satriya" userId="c28fa87cdebdc656" providerId="LiveId" clId="{63E91B12-6D81-43DC-90EF-03735CFC9BF7}"/>
     <pc:docChg chg="undo custSel addSld delSld modSld sldOrd">
-      <pc:chgData name="Vempi Satriya" userId="c28fa87cdebdc656" providerId="LiveId" clId="{63E91B12-6D81-43DC-90EF-03735CFC9BF7}" dt="2026-08-26T21:59:42.415" v="854" actId="1076"/>
+      <pc:chgData name="Vempi Satriya" userId="c28fa87cdebdc656" providerId="LiveId" clId="{63E91B12-6D81-43DC-90EF-03735CFC9BF7}" dt="2026-08-23T17:26:28.223" v="846"/>
       <pc:docMkLst>
         <pc:docMk/>
       </pc:docMkLst>
-      <pc:sldChg chg="addSp delSp modSp del mod">
-        <pc:chgData name="Vempi Satriya" userId="c28fa87cdebdc656" providerId="LiveId" clId="{63E91B12-6D81-43DC-90EF-03735CFC9BF7}" dt="2026-08-26T21:59:42.415" v="854" actId="1076"/>
+      <pc:sldChg chg="del">
+        <pc:chgData name="Vempi Satriya" userId="c28fa87cdebdc656" providerId="LiveId" clId="{63E91B12-6D81-43DC-90EF-03735CFC9BF7}" dt="2026-08-22T23:47:00.588" v="142" actId="47"/>
         <pc:sldMkLst>
           <pc:docMk/>
           <pc:sldMk cId="0" sldId="256"/>
         </pc:sldMkLst>
-        <pc:spChg chg="mod">
-          <ac:chgData name="Vempi Satriya" userId="c28fa87cdebdc656" providerId="LiveId" clId="{63E91B12-6D81-43DC-90EF-03735CFC9BF7}" dt="2026-08-26T21:59:42.415" v="854" actId="1076"/>
-          <ac:spMkLst>
-            <pc:docMk/>
-            <pc:sldMk cId="0" sldId="256"/>
-            <ac:spMk id="2" creationId="{00000000-0000-0000-0000-000000000000}"/>
-          </ac:spMkLst>
-        </pc:spChg>
-        <pc:spChg chg="add del">
-          <ac:chgData name="Vempi Satriya" userId="c28fa87cdebdc656" providerId="LiveId" clId="{63E91B12-6D81-43DC-90EF-03735CFC9BF7}" dt="2026-08-26T21:59:39.745" v="853" actId="22"/>
-          <ac:spMkLst>
-            <pc:docMk/>
-            <pc:sldMk cId="0" sldId="256"/>
-            <ac:spMk id="8" creationId="{C8B9DF3D-EAAF-4E54-8009-9FB396177C30}"/>
-          </ac:spMkLst>
-        </pc:spChg>
       </pc:sldChg>
       <pc:sldChg chg="addSp delSp modSp add del mod">
         <pc:chgData name="Vempi Satriya" userId="c28fa87cdebdc656" providerId="LiveId" clId="{63E91B12-6D81-43DC-90EF-03735CFC9BF7}" dt="2026-08-22T23:50:29.627" v="213" actId="47"/>
@@ -104,6 +96,22 @@
             <ac:spMk id="3" creationId="{00000000-0000-0000-0000-000000000000}"/>
           </ac:spMkLst>
         </pc:spChg>
+        <pc:spChg chg="mod">
+          <ac:chgData name="Vempi Satriya" userId="c28fa87cdebdc656" providerId="LiveId" clId="{63E91B12-6D81-43DC-90EF-03735CFC9BF7}" dt="2026-08-22T23:49:48.407" v="194"/>
+          <ac:spMkLst>
+            <pc:docMk/>
+            <pc:sldMk cId="0" sldId="257"/>
+            <ac:spMk id="4" creationId="{00000000-0000-0000-0000-000000000000}"/>
+          </ac:spMkLst>
+        </pc:spChg>
+        <pc:spChg chg="add mod">
+          <ac:chgData name="Vempi Satriya" userId="c28fa87cdebdc656" providerId="LiveId" clId="{63E91B12-6D81-43DC-90EF-03735CFC9BF7}" dt="2026-08-22T23:50:18.022" v="209" actId="21"/>
+          <ac:spMkLst>
+            <pc:docMk/>
+            <pc:sldMk cId="0" sldId="257"/>
+            <ac:spMk id="6" creationId="{4F21724E-5EC7-7A0F-E1AD-1D0D6939DB77}"/>
+          </ac:spMkLst>
+        </pc:spChg>
       </pc:sldChg>
       <pc:sldChg chg="addSp delSp modSp add del mod ord">
         <pc:chgData name="Vempi Satriya" userId="c28fa87cdebdc656" providerId="LiveId" clId="{63E91B12-6D81-43DC-90EF-03735CFC9BF7}" dt="2026-08-22T23:54:10.580" v="288" actId="47"/>
@@ -119,6 +127,22 @@
             <ac:spMk id="3" creationId="{00000000-0000-0000-0000-000000000000}"/>
           </ac:spMkLst>
         </pc:spChg>
+        <pc:spChg chg="mod">
+          <ac:chgData name="Vempi Satriya" userId="c28fa87cdebdc656" providerId="LiveId" clId="{63E91B12-6D81-43DC-90EF-03735CFC9BF7}" dt="2026-08-22T23:49:48.407" v="194"/>
+          <ac:spMkLst>
+            <pc:docMk/>
+            <pc:sldMk cId="0" sldId="258"/>
+            <ac:spMk id="4" creationId="{00000000-0000-0000-0000-000000000000}"/>
+          </ac:spMkLst>
+        </pc:spChg>
+        <pc:spChg chg="add mod">
+          <ac:chgData name="Vempi Satriya" userId="c28fa87cdebdc656" providerId="LiveId" clId="{63E91B12-6D81-43DC-90EF-03735CFC9BF7}" dt="2026-08-22T23:52:53.802" v="262" actId="21"/>
+          <ac:spMkLst>
+            <pc:docMk/>
+            <pc:sldMk cId="0" sldId="258"/>
+            <ac:spMk id="5" creationId="{82A91E94-5C68-A392-A0BA-F94EB5CFFB66}"/>
+          </ac:spMkLst>
+        </pc:spChg>
       </pc:sldChg>
       <pc:sldChg chg="addSp delSp modSp add del mod">
         <pc:chgData name="Vempi Satriya" userId="c28fa87cdebdc656" providerId="LiveId" clId="{63E91B12-6D81-43DC-90EF-03735CFC9BF7}" dt="2026-08-22T23:52:43.930" v="260" actId="47"/>
@@ -134,6 +158,38 @@
             <ac:spMk id="3" creationId="{00000000-0000-0000-0000-000000000000}"/>
           </ac:spMkLst>
         </pc:spChg>
+        <pc:spChg chg="add mod">
+          <ac:chgData name="Vempi Satriya" userId="c28fa87cdebdc656" providerId="LiveId" clId="{63E91B12-6D81-43DC-90EF-03735CFC9BF7}" dt="2026-08-22T23:51:11.562" v="226" actId="21"/>
+          <ac:spMkLst>
+            <pc:docMk/>
+            <pc:sldMk cId="0" sldId="259"/>
+            <ac:spMk id="4" creationId="{BF008B27-362A-037D-80BB-D20324568829}"/>
+          </ac:spMkLst>
+        </pc:spChg>
+        <pc:spChg chg="mod">
+          <ac:chgData name="Vempi Satriya" userId="c28fa87cdebdc656" providerId="LiveId" clId="{63E91B12-6D81-43DC-90EF-03735CFC9BF7}" dt="2026-08-22T23:49:48.407" v="194"/>
+          <ac:spMkLst>
+            <pc:docMk/>
+            <pc:sldMk cId="0" sldId="259"/>
+            <ac:spMk id="8" creationId="{00000000-0000-0000-0000-000000000000}"/>
+          </ac:spMkLst>
+        </pc:spChg>
+        <pc:graphicFrameChg chg="del">
+          <ac:chgData name="Vempi Satriya" userId="c28fa87cdebdc656" providerId="LiveId" clId="{63E91B12-6D81-43DC-90EF-03735CFC9BF7}" dt="2026-08-22T23:51:11.562" v="226" actId="21"/>
+          <ac:graphicFrameMkLst>
+            <pc:docMk/>
+            <pc:sldMk cId="0" sldId="259"/>
+            <ac:graphicFrameMk id="1025" creationId="{00000000-0000-0000-0000-000000000000}"/>
+          </ac:graphicFrameMkLst>
+        </pc:graphicFrameChg>
+        <pc:graphicFrameChg chg="del">
+          <ac:chgData name="Vempi Satriya" userId="c28fa87cdebdc656" providerId="LiveId" clId="{63E91B12-6D81-43DC-90EF-03735CFC9BF7}" dt="2026-08-22T23:51:11.562" v="226" actId="21"/>
+          <ac:graphicFrameMkLst>
+            <pc:docMk/>
+            <pc:sldMk cId="0" sldId="259"/>
+            <ac:graphicFrameMk id="1027" creationId="{00000000-0000-0000-0000-000000000000}"/>
+          </ac:graphicFrameMkLst>
+        </pc:graphicFrameChg>
       </pc:sldChg>
       <pc:sldChg chg="addSp delSp modSp add del mod">
         <pc:chgData name="Vempi Satriya" userId="c28fa87cdebdc656" providerId="LiveId" clId="{63E91B12-6D81-43DC-90EF-03735CFC9BF7}" dt="2026-08-22T23:52:43.930" v="260" actId="47"/>
@@ -149,6 +205,30 @@
             <ac:spMk id="3" creationId="{00000000-0000-0000-0000-000000000000}"/>
           </ac:spMkLst>
         </pc:spChg>
+        <pc:spChg chg="add mod">
+          <ac:chgData name="Vempi Satriya" userId="c28fa87cdebdc656" providerId="LiveId" clId="{63E91B12-6D81-43DC-90EF-03735CFC9BF7}" dt="2026-08-22T23:52:00.696" v="241" actId="21"/>
+          <ac:spMkLst>
+            <pc:docMk/>
+            <pc:sldMk cId="0" sldId="260"/>
+            <ac:spMk id="4" creationId="{9C618F0B-60EA-1AEB-B565-ABFB35DDFADB}"/>
+          </ac:spMkLst>
+        </pc:spChg>
+        <pc:spChg chg="mod">
+          <ac:chgData name="Vempi Satriya" userId="c28fa87cdebdc656" providerId="LiveId" clId="{63E91B12-6D81-43DC-90EF-03735CFC9BF7}" dt="2026-08-22T23:49:48.407" v="194"/>
+          <ac:spMkLst>
+            <pc:docMk/>
+            <pc:sldMk cId="0" sldId="260"/>
+            <ac:spMk id="7" creationId="{00000000-0000-0000-0000-000000000000}"/>
+          </ac:spMkLst>
+        </pc:spChg>
+        <pc:graphicFrameChg chg="del mod">
+          <ac:chgData name="Vempi Satriya" userId="c28fa87cdebdc656" providerId="LiveId" clId="{63E91B12-6D81-43DC-90EF-03735CFC9BF7}" dt="2026-08-22T23:52:00.696" v="241" actId="21"/>
+          <ac:graphicFrameMkLst>
+            <pc:docMk/>
+            <pc:sldMk cId="0" sldId="260"/>
+            <ac:graphicFrameMk id="17409" creationId="{00000000-0000-0000-0000-000000000000}"/>
+          </ac:graphicFrameMkLst>
+        </pc:graphicFrameChg>
       </pc:sldChg>
       <pc:sldChg chg="addSp delSp modSp add del mod">
         <pc:chgData name="Vempi Satriya" userId="c28fa87cdebdc656" providerId="LiveId" clId="{63E91B12-6D81-43DC-90EF-03735CFC9BF7}" dt="2026-08-22T23:54:10.580" v="288" actId="47"/>
@@ -164,6 +244,86 @@
             <ac:spMk id="3" creationId="{00000000-0000-0000-0000-000000000000}"/>
           </ac:spMkLst>
         </pc:spChg>
+        <pc:spChg chg="add mod">
+          <ac:chgData name="Vempi Satriya" userId="c28fa87cdebdc656" providerId="LiveId" clId="{63E91B12-6D81-43DC-90EF-03735CFC9BF7}" dt="2026-08-22T23:53:16.608" v="271" actId="21"/>
+          <ac:spMkLst>
+            <pc:docMk/>
+            <pc:sldMk cId="0" sldId="262"/>
+            <ac:spMk id="4" creationId="{1D6E5FCF-6776-D3D4-197B-C3F7130CF43A}"/>
+          </ac:spMkLst>
+        </pc:spChg>
+        <pc:spChg chg="del">
+          <ac:chgData name="Vempi Satriya" userId="c28fa87cdebdc656" providerId="LiveId" clId="{63E91B12-6D81-43DC-90EF-03735CFC9BF7}" dt="2026-08-22T23:53:16.608" v="271" actId="21"/>
+          <ac:spMkLst>
+            <pc:docMk/>
+            <pc:sldMk cId="0" sldId="262"/>
+            <ac:spMk id="14" creationId="{00000000-0000-0000-0000-000000000000}"/>
+          </ac:spMkLst>
+        </pc:spChg>
+        <pc:spChg chg="del">
+          <ac:chgData name="Vempi Satriya" userId="c28fa87cdebdc656" providerId="LiveId" clId="{63E91B12-6D81-43DC-90EF-03735CFC9BF7}" dt="2026-08-22T23:53:16.608" v="271" actId="21"/>
+          <ac:spMkLst>
+            <pc:docMk/>
+            <pc:sldMk cId="0" sldId="262"/>
+            <ac:spMk id="17" creationId="{00000000-0000-0000-0000-000000000000}"/>
+          </ac:spMkLst>
+        </pc:spChg>
+        <pc:spChg chg="del">
+          <ac:chgData name="Vempi Satriya" userId="c28fa87cdebdc656" providerId="LiveId" clId="{63E91B12-6D81-43DC-90EF-03735CFC9BF7}" dt="2026-08-22T23:53:16.608" v="271" actId="21"/>
+          <ac:spMkLst>
+            <pc:docMk/>
+            <pc:sldMk cId="0" sldId="262"/>
+            <ac:spMk id="26" creationId="{00000000-0000-0000-0000-000000000000}"/>
+          </ac:spMkLst>
+        </pc:spChg>
+        <pc:spChg chg="del">
+          <ac:chgData name="Vempi Satriya" userId="c28fa87cdebdc656" providerId="LiveId" clId="{63E91B12-6D81-43DC-90EF-03735CFC9BF7}" dt="2026-08-22T23:53:16.608" v="271" actId="21"/>
+          <ac:spMkLst>
+            <pc:docMk/>
+            <pc:sldMk cId="0" sldId="262"/>
+            <ac:spMk id="27" creationId="{00000000-0000-0000-0000-000000000000}"/>
+          </ac:spMkLst>
+        </pc:spChg>
+        <pc:spChg chg="del">
+          <ac:chgData name="Vempi Satriya" userId="c28fa87cdebdc656" providerId="LiveId" clId="{63E91B12-6D81-43DC-90EF-03735CFC9BF7}" dt="2026-08-22T23:53:16.608" v="271" actId="21"/>
+          <ac:spMkLst>
+            <pc:docMk/>
+            <pc:sldMk cId="0" sldId="262"/>
+            <ac:spMk id="28" creationId="{00000000-0000-0000-0000-000000000000}"/>
+          </ac:spMkLst>
+        </pc:spChg>
+        <pc:spChg chg="mod">
+          <ac:chgData name="Vempi Satriya" userId="c28fa87cdebdc656" providerId="LiveId" clId="{63E91B12-6D81-43DC-90EF-03735CFC9BF7}" dt="2026-08-22T23:49:48.407" v="194"/>
+          <ac:spMkLst>
+            <pc:docMk/>
+            <pc:sldMk cId="0" sldId="262"/>
+            <ac:spMk id="32" creationId="{00000000-0000-0000-0000-000000000000}"/>
+          </ac:spMkLst>
+        </pc:spChg>
+        <pc:cxnChg chg="del">
+          <ac:chgData name="Vempi Satriya" userId="c28fa87cdebdc656" providerId="LiveId" clId="{63E91B12-6D81-43DC-90EF-03735CFC9BF7}" dt="2026-08-22T23:53:16.608" v="271" actId="21"/>
+          <ac:cxnSpMkLst>
+            <pc:docMk/>
+            <pc:sldMk cId="0" sldId="262"/>
+            <ac:cxnSpMk id="7" creationId="{00000000-0000-0000-0000-000000000000}"/>
+          </ac:cxnSpMkLst>
+        </pc:cxnChg>
+        <pc:cxnChg chg="del">
+          <ac:chgData name="Vempi Satriya" userId="c28fa87cdebdc656" providerId="LiveId" clId="{63E91B12-6D81-43DC-90EF-03735CFC9BF7}" dt="2026-08-22T23:53:16.608" v="271" actId="21"/>
+          <ac:cxnSpMkLst>
+            <pc:docMk/>
+            <pc:sldMk cId="0" sldId="262"/>
+            <ac:cxnSpMk id="25" creationId="{00000000-0000-0000-0000-000000000000}"/>
+          </ac:cxnSpMkLst>
+        </pc:cxnChg>
+        <pc:cxnChg chg="del">
+          <ac:chgData name="Vempi Satriya" userId="c28fa87cdebdc656" providerId="LiveId" clId="{63E91B12-6D81-43DC-90EF-03735CFC9BF7}" dt="2026-08-22T23:53:16.608" v="271" actId="21"/>
+          <ac:cxnSpMkLst>
+            <pc:docMk/>
+            <pc:sldMk cId="0" sldId="262"/>
+            <ac:cxnSpMk id="30" creationId="{00000000-0000-0000-0000-000000000000}"/>
+          </ac:cxnSpMkLst>
+        </pc:cxnChg>
       </pc:sldChg>
       <pc:sldChg chg="addSp delSp modSp add del mod">
         <pc:chgData name="Vempi Satriya" userId="c28fa87cdebdc656" providerId="LiveId" clId="{63E91B12-6D81-43DC-90EF-03735CFC9BF7}" dt="2026-08-22T23:54:54.513" v="305" actId="47"/>
@@ -179,6 +339,22 @@
             <ac:spMk id="3" creationId="{00000000-0000-0000-0000-000000000000}"/>
           </ac:spMkLst>
         </pc:spChg>
+        <pc:spChg chg="mod">
+          <ac:chgData name="Vempi Satriya" userId="c28fa87cdebdc656" providerId="LiveId" clId="{63E91B12-6D81-43DC-90EF-03735CFC9BF7}" dt="2026-08-22T23:49:48.407" v="194"/>
+          <ac:spMkLst>
+            <pc:docMk/>
+            <pc:sldMk cId="0" sldId="263"/>
+            <ac:spMk id="4" creationId="{00000000-0000-0000-0000-000000000000}"/>
+          </ac:spMkLst>
+        </pc:spChg>
+        <pc:spChg chg="add mod">
+          <ac:chgData name="Vempi Satriya" userId="c28fa87cdebdc656" providerId="LiveId" clId="{63E91B12-6D81-43DC-90EF-03735CFC9BF7}" dt="2026-08-22T23:54:16.158" v="290" actId="21"/>
+          <ac:spMkLst>
+            <pc:docMk/>
+            <pc:sldMk cId="0" sldId="263"/>
+            <ac:spMk id="5" creationId="{F29EF79E-8E7B-F9C8-9CAA-65AFCD92BDEE}"/>
+          </ac:spMkLst>
+        </pc:spChg>
       </pc:sldChg>
       <pc:sldChg chg="delSp modSp add del mod">
         <pc:chgData name="Vempi Satriya" userId="c28fa87cdebdc656" providerId="LiveId" clId="{63E91B12-6D81-43DC-90EF-03735CFC9BF7}" dt="2026-08-22T23:56:07.941" v="318" actId="47"/>
@@ -186,6 +362,22 @@
           <pc:docMk/>
           <pc:sldMk cId="0" sldId="264"/>
         </pc:sldMkLst>
+        <pc:spChg chg="mod">
+          <ac:chgData name="Vempi Satriya" userId="c28fa87cdebdc656" providerId="LiveId" clId="{63E91B12-6D81-43DC-90EF-03735CFC9BF7}" dt="2026-08-22T23:49:48.407" v="194"/>
+          <ac:spMkLst>
+            <pc:docMk/>
+            <pc:sldMk cId="0" sldId="264"/>
+            <ac:spMk id="9" creationId="{00000000-0000-0000-0000-000000000000}"/>
+          </ac:spMkLst>
+        </pc:spChg>
+        <pc:graphicFrameChg chg="del">
+          <ac:chgData name="Vempi Satriya" userId="c28fa87cdebdc656" providerId="LiveId" clId="{63E91B12-6D81-43DC-90EF-03735CFC9BF7}" dt="2026-08-22T23:55:20.379" v="311" actId="21"/>
+          <ac:graphicFrameMkLst>
+            <pc:docMk/>
+            <pc:sldMk cId="0" sldId="264"/>
+            <ac:graphicFrameMk id="19457" creationId="{00000000-0000-0000-0000-000000000000}"/>
+          </ac:graphicFrameMkLst>
+        </pc:graphicFrameChg>
       </pc:sldChg>
       <pc:sldChg chg="addSp delSp modSp add del mod">
         <pc:chgData name="Vempi Satriya" userId="c28fa87cdebdc656" providerId="LiveId" clId="{63E91B12-6D81-43DC-90EF-03735CFC9BF7}" dt="2026-08-23T17:26:28.223" v="846"/>
@@ -201,6 +393,30 @@
             <ac:spMk id="3" creationId="{00000000-0000-0000-0000-000000000000}"/>
           </ac:spMkLst>
         </pc:spChg>
+        <pc:spChg chg="mod">
+          <ac:chgData name="Vempi Satriya" userId="c28fa87cdebdc656" providerId="LiveId" clId="{63E91B12-6D81-43DC-90EF-03735CFC9BF7}" dt="2026-08-22T23:49:48.407" v="194"/>
+          <ac:spMkLst>
+            <pc:docMk/>
+            <pc:sldMk cId="0" sldId="265"/>
+            <ac:spMk id="5" creationId="{00000000-0000-0000-0000-000000000000}"/>
+          </ac:spMkLst>
+        </pc:spChg>
+        <pc:spChg chg="add mod">
+          <ac:chgData name="Vempi Satriya" userId="c28fa87cdebdc656" providerId="LiveId" clId="{63E91B12-6D81-43DC-90EF-03735CFC9BF7}" dt="2026-08-22T23:56:20.733" v="324" actId="21"/>
+          <ac:spMkLst>
+            <pc:docMk/>
+            <pc:sldMk cId="0" sldId="265"/>
+            <ac:spMk id="6" creationId="{D9A69558-33EB-CD18-3199-3DEA3DDEC009}"/>
+          </ac:spMkLst>
+        </pc:spChg>
+        <pc:graphicFrameChg chg="del">
+          <ac:chgData name="Vempi Satriya" userId="c28fa87cdebdc656" providerId="LiveId" clId="{63E91B12-6D81-43DC-90EF-03735CFC9BF7}" dt="2026-08-22T23:56:20.733" v="324" actId="21"/>
+          <ac:graphicFrameMkLst>
+            <pc:docMk/>
+            <pc:sldMk cId="0" sldId="265"/>
+            <ac:graphicFrameMk id="4" creationId="{00000000-0000-0000-0000-000000000000}"/>
+          </ac:graphicFrameMkLst>
+        </pc:graphicFrameChg>
       </pc:sldChg>
       <pc:sldChg chg="addSp delSp modSp add del mod">
         <pc:chgData name="Vempi Satriya" userId="c28fa87cdebdc656" providerId="LiveId" clId="{63E91B12-6D81-43DC-90EF-03735CFC9BF7}" dt="2026-08-22T23:59:23.798" v="389" actId="47"/>
@@ -216,6 +432,54 @@
             <ac:spMk id="3" creationId="{00000000-0000-0000-0000-000000000000}"/>
           </ac:spMkLst>
         </pc:spChg>
+        <pc:spChg chg="add mod">
+          <ac:chgData name="Vempi Satriya" userId="c28fa87cdebdc656" providerId="LiveId" clId="{63E91B12-6D81-43DC-90EF-03735CFC9BF7}" dt="2026-08-22T23:57:44.002" v="351" actId="21"/>
+          <ac:spMkLst>
+            <pc:docMk/>
+            <pc:sldMk cId="0" sldId="266"/>
+            <ac:spMk id="4" creationId="{0725DACA-B6D9-5D03-9A72-150BD8011FE6}"/>
+          </ac:spMkLst>
+        </pc:spChg>
+        <pc:spChg chg="del">
+          <ac:chgData name="Vempi Satriya" userId="c28fa87cdebdc656" providerId="LiveId" clId="{63E91B12-6D81-43DC-90EF-03735CFC9BF7}" dt="2026-08-22T23:57:44.002" v="351" actId="21"/>
+          <ac:spMkLst>
+            <pc:docMk/>
+            <pc:sldMk cId="0" sldId="266"/>
+            <ac:spMk id="7" creationId="{00000000-0000-0000-0000-000000000000}"/>
+          </ac:spMkLst>
+        </pc:spChg>
+        <pc:spChg chg="del">
+          <ac:chgData name="Vempi Satriya" userId="c28fa87cdebdc656" providerId="LiveId" clId="{63E91B12-6D81-43DC-90EF-03735CFC9BF7}" dt="2026-08-22T23:58:06.744" v="355" actId="21"/>
+          <ac:spMkLst>
+            <pc:docMk/>
+            <pc:sldMk cId="0" sldId="266"/>
+            <ac:spMk id="10" creationId="{00000000-0000-0000-0000-000000000000}"/>
+          </ac:spMkLst>
+        </pc:spChg>
+        <pc:spChg chg="mod">
+          <ac:chgData name="Vempi Satriya" userId="c28fa87cdebdc656" providerId="LiveId" clId="{63E91B12-6D81-43DC-90EF-03735CFC9BF7}" dt="2026-08-22T23:49:48.407" v="194"/>
+          <ac:spMkLst>
+            <pc:docMk/>
+            <pc:sldMk cId="0" sldId="266"/>
+            <ac:spMk id="12" creationId="{00000000-0000-0000-0000-000000000000}"/>
+          </ac:spMkLst>
+        </pc:spChg>
+        <pc:graphicFrameChg chg="del">
+          <ac:chgData name="Vempi Satriya" userId="c28fa87cdebdc656" providerId="LiveId" clId="{63E91B12-6D81-43DC-90EF-03735CFC9BF7}" dt="2026-08-22T23:57:44.002" v="351" actId="21"/>
+          <ac:graphicFrameMkLst>
+            <pc:docMk/>
+            <pc:sldMk cId="0" sldId="266"/>
+            <ac:graphicFrameMk id="23554" creationId="{00000000-0000-0000-0000-000000000000}"/>
+          </ac:graphicFrameMkLst>
+        </pc:graphicFrameChg>
+        <pc:graphicFrameChg chg="del">
+          <ac:chgData name="Vempi Satriya" userId="c28fa87cdebdc656" providerId="LiveId" clId="{63E91B12-6D81-43DC-90EF-03735CFC9BF7}" dt="2026-08-22T23:57:44.002" v="351" actId="21"/>
+          <ac:graphicFrameMkLst>
+            <pc:docMk/>
+            <pc:sldMk cId="0" sldId="266"/>
+            <ac:graphicFrameMk id="23556" creationId="{00000000-0000-0000-0000-000000000000}"/>
+          </ac:graphicFrameMkLst>
+        </pc:graphicFrameChg>
       </pc:sldChg>
       <pc:sldChg chg="addSp delSp modSp add del mod">
         <pc:chgData name="Vempi Satriya" userId="c28fa87cdebdc656" providerId="LiveId" clId="{63E91B12-6D81-43DC-90EF-03735CFC9BF7}" dt="2026-08-22T23:57:32.455" v="348" actId="47"/>
@@ -231,6 +495,70 @@
             <ac:spMk id="3" creationId="{00000000-0000-0000-0000-000000000000}"/>
           </ac:spMkLst>
         </pc:spChg>
+        <pc:spChg chg="add mod">
+          <ac:chgData name="Vempi Satriya" userId="c28fa87cdebdc656" providerId="LiveId" clId="{63E91B12-6D81-43DC-90EF-03735CFC9BF7}" dt="2026-08-22T23:57:09.136" v="342" actId="21"/>
+          <ac:spMkLst>
+            <pc:docMk/>
+            <pc:sldMk cId="0" sldId="268"/>
+            <ac:spMk id="4" creationId="{9877008E-A874-F3DE-FA7F-30A5A3C869E8}"/>
+          </ac:spMkLst>
+        </pc:spChg>
+        <pc:spChg chg="mod">
+          <ac:chgData name="Vempi Satriya" userId="c28fa87cdebdc656" providerId="LiveId" clId="{63E91B12-6D81-43DC-90EF-03735CFC9BF7}" dt="2026-08-22T23:49:48.407" v="194"/>
+          <ac:spMkLst>
+            <pc:docMk/>
+            <pc:sldMk cId="0" sldId="268"/>
+            <ac:spMk id="10" creationId="{00000000-0000-0000-0000-000000000000}"/>
+          </ac:spMkLst>
+        </pc:spChg>
+        <pc:spChg chg="del">
+          <ac:chgData name="Vempi Satriya" userId="c28fa87cdebdc656" providerId="LiveId" clId="{63E91B12-6D81-43DC-90EF-03735CFC9BF7}" dt="2026-08-22T23:57:09.136" v="342" actId="21"/>
+          <ac:spMkLst>
+            <pc:docMk/>
+            <pc:sldMk cId="0" sldId="268"/>
+            <ac:spMk id="18434" creationId="{00000000-0000-0000-0000-000000000000}"/>
+          </ac:spMkLst>
+        </pc:spChg>
+        <pc:spChg chg="del">
+          <ac:chgData name="Vempi Satriya" userId="c28fa87cdebdc656" providerId="LiveId" clId="{63E91B12-6D81-43DC-90EF-03735CFC9BF7}" dt="2026-08-22T23:57:09.136" v="342" actId="21"/>
+          <ac:spMkLst>
+            <pc:docMk/>
+            <pc:sldMk cId="0" sldId="268"/>
+            <ac:spMk id="18438" creationId="{00000000-0000-0000-0000-000000000000}"/>
+          </ac:spMkLst>
+        </pc:spChg>
+        <pc:spChg chg="del">
+          <ac:chgData name="Vempi Satriya" userId="c28fa87cdebdc656" providerId="LiveId" clId="{63E91B12-6D81-43DC-90EF-03735CFC9BF7}" dt="2026-08-22T23:57:09.136" v="342" actId="21"/>
+          <ac:spMkLst>
+            <pc:docMk/>
+            <pc:sldMk cId="0" sldId="268"/>
+            <ac:spMk id="18440" creationId="{00000000-0000-0000-0000-000000000000}"/>
+          </ac:spMkLst>
+        </pc:spChg>
+        <pc:graphicFrameChg chg="del">
+          <ac:chgData name="Vempi Satriya" userId="c28fa87cdebdc656" providerId="LiveId" clId="{63E91B12-6D81-43DC-90EF-03735CFC9BF7}" dt="2026-08-22T23:57:09.136" v="342" actId="21"/>
+          <ac:graphicFrameMkLst>
+            <pc:docMk/>
+            <pc:sldMk cId="0" sldId="268"/>
+            <ac:graphicFrameMk id="18437" creationId="{00000000-0000-0000-0000-000000000000}"/>
+          </ac:graphicFrameMkLst>
+        </pc:graphicFrameChg>
+        <pc:graphicFrameChg chg="del">
+          <ac:chgData name="Vempi Satriya" userId="c28fa87cdebdc656" providerId="LiveId" clId="{63E91B12-6D81-43DC-90EF-03735CFC9BF7}" dt="2026-08-22T23:57:09.136" v="342" actId="21"/>
+          <ac:graphicFrameMkLst>
+            <pc:docMk/>
+            <pc:sldMk cId="0" sldId="268"/>
+            <ac:graphicFrameMk id="18439" creationId="{00000000-0000-0000-0000-000000000000}"/>
+          </ac:graphicFrameMkLst>
+        </pc:graphicFrameChg>
+        <pc:graphicFrameChg chg="del">
+          <ac:chgData name="Vempi Satriya" userId="c28fa87cdebdc656" providerId="LiveId" clId="{63E91B12-6D81-43DC-90EF-03735CFC9BF7}" dt="2026-08-22T23:57:09.136" v="342" actId="21"/>
+          <ac:graphicFrameMkLst>
+            <pc:docMk/>
+            <pc:sldMk cId="0" sldId="268"/>
+            <ac:graphicFrameMk id="18446" creationId="{00000000-0000-0000-0000-000000000000}"/>
+          </ac:graphicFrameMkLst>
+        </pc:graphicFrameChg>
       </pc:sldChg>
       <pc:sldChg chg="addSp delSp modSp add del mod">
         <pc:chgData name="Vempi Satriya" userId="c28fa87cdebdc656" providerId="LiveId" clId="{63E91B12-6D81-43DC-90EF-03735CFC9BF7}" dt="2026-08-22T23:59:23.798" v="389" actId="47"/>
@@ -246,6 +574,22 @@
             <ac:spMk id="3" creationId="{00000000-0000-0000-0000-000000000000}"/>
           </ac:spMkLst>
         </pc:spChg>
+        <pc:spChg chg="mod">
+          <ac:chgData name="Vempi Satriya" userId="c28fa87cdebdc656" providerId="LiveId" clId="{63E91B12-6D81-43DC-90EF-03735CFC9BF7}" dt="2026-08-22T23:49:48.407" v="194"/>
+          <ac:spMkLst>
+            <pc:docMk/>
+            <pc:sldMk cId="0" sldId="269"/>
+            <ac:spMk id="4" creationId="{00000000-0000-0000-0000-000000000000}"/>
+          </ac:spMkLst>
+        </pc:spChg>
+        <pc:spChg chg="add mod">
+          <ac:chgData name="Vempi Satriya" userId="c28fa87cdebdc656" providerId="LiveId" clId="{63E91B12-6D81-43DC-90EF-03735CFC9BF7}" dt="2026-08-22T23:59:07.369" v="381" actId="21"/>
+          <ac:spMkLst>
+            <pc:docMk/>
+            <pc:sldMk cId="0" sldId="269"/>
+            <ac:spMk id="5" creationId="{DDE82A72-69F9-0234-AEB2-FFADE0F5E603}"/>
+          </ac:spMkLst>
+        </pc:spChg>
       </pc:sldChg>
       <pc:sldChg chg="addSp delSp modSp add del mod">
         <pc:chgData name="Vempi Satriya" userId="c28fa87cdebdc656" providerId="LiveId" clId="{63E91B12-6D81-43DC-90EF-03735CFC9BF7}" dt="2026-08-23T00:00:30.447" v="413" actId="47"/>
@@ -259,6 +603,2279 @@
             <pc:docMk/>
             <pc:sldMk cId="0" sldId="270"/>
             <ac:spMk id="3" creationId="{00000000-0000-0000-0000-000000000000}"/>
+          </ac:spMkLst>
+        </pc:spChg>
+        <pc:spChg chg="mod">
+          <ac:chgData name="Vempi Satriya" userId="c28fa87cdebdc656" providerId="LiveId" clId="{63E91B12-6D81-43DC-90EF-03735CFC9BF7}" dt="2026-08-22T23:49:48.407" v="194"/>
+          <ac:spMkLst>
+            <pc:docMk/>
+            <pc:sldMk cId="0" sldId="270"/>
+            <ac:spMk id="4" creationId="{00000000-0000-0000-0000-000000000000}"/>
+          </ac:spMkLst>
+        </pc:spChg>
+        <pc:spChg chg="add mod">
+          <ac:chgData name="Vempi Satriya" userId="c28fa87cdebdc656" providerId="LiveId" clId="{63E91B12-6D81-43DC-90EF-03735CFC9BF7}" dt="2026-08-23T00:00:23.165" v="409" actId="21"/>
+          <ac:spMkLst>
+            <pc:docMk/>
+            <pc:sldMk cId="0" sldId="270"/>
+            <ac:spMk id="5" creationId="{69942EE0-6067-A393-2204-44700D6BC256}"/>
+          </ac:spMkLst>
+        </pc:spChg>
+      </pc:sldChg>
+      <pc:sldChg chg="addSp delSp modSp add del mod">
+        <pc:chgData name="Vempi Satriya" userId="c28fa87cdebdc656" providerId="LiveId" clId="{63E91B12-6D81-43DC-90EF-03735CFC9BF7}" dt="2026-08-23T00:00:30.447" v="413" actId="47"/>
+        <pc:sldMkLst>
+          <pc:docMk/>
+          <pc:sldMk cId="0" sldId="271"/>
+        </pc:sldMkLst>
+        <pc:spChg chg="del">
+          <ac:chgData name="Vempi Satriya" userId="c28fa87cdebdc656" providerId="LiveId" clId="{63E91B12-6D81-43DC-90EF-03735CFC9BF7}" dt="2026-08-22T23:59:30.734" v="391" actId="21"/>
+          <ac:spMkLst>
+            <pc:docMk/>
+            <pc:sldMk cId="0" sldId="271"/>
+            <ac:spMk id="3" creationId="{00000000-0000-0000-0000-000000000000}"/>
+          </ac:spMkLst>
+        </pc:spChg>
+        <pc:spChg chg="add mod">
+          <ac:chgData name="Vempi Satriya" userId="c28fa87cdebdc656" providerId="LiveId" clId="{63E91B12-6D81-43DC-90EF-03735CFC9BF7}" dt="2026-08-22T23:59:30.734" v="391" actId="21"/>
+          <ac:spMkLst>
+            <pc:docMk/>
+            <pc:sldMk cId="0" sldId="271"/>
+            <ac:spMk id="4" creationId="{3932C043-1BAD-FC92-DD41-64499E34BF67}"/>
+          </ac:spMkLst>
+        </pc:spChg>
+        <pc:spChg chg="mod">
+          <ac:chgData name="Vempi Satriya" userId="c28fa87cdebdc656" providerId="LiveId" clId="{63E91B12-6D81-43DC-90EF-03735CFC9BF7}" dt="2026-08-22T23:49:48.407" v="194"/>
+          <ac:spMkLst>
+            <pc:docMk/>
+            <pc:sldMk cId="0" sldId="271"/>
+            <ac:spMk id="6" creationId="{00000000-0000-0000-0000-000000000000}"/>
+          </ac:spMkLst>
+        </pc:spChg>
+        <pc:graphicFrameChg chg="del">
+          <ac:chgData name="Vempi Satriya" userId="c28fa87cdebdc656" providerId="LiveId" clId="{63E91B12-6D81-43DC-90EF-03735CFC9BF7}" dt="2026-08-22T23:59:30.734" v="391" actId="21"/>
+          <ac:graphicFrameMkLst>
+            <pc:docMk/>
+            <pc:sldMk cId="0" sldId="271"/>
+            <ac:graphicFrameMk id="25602" creationId="{00000000-0000-0000-0000-000000000000}"/>
+          </ac:graphicFrameMkLst>
+        </pc:graphicFrameChg>
+        <pc:graphicFrameChg chg="del">
+          <ac:chgData name="Vempi Satriya" userId="c28fa87cdebdc656" providerId="LiveId" clId="{63E91B12-6D81-43DC-90EF-03735CFC9BF7}" dt="2026-08-22T23:59:30.734" v="391" actId="21"/>
+          <ac:graphicFrameMkLst>
+            <pc:docMk/>
+            <pc:sldMk cId="0" sldId="271"/>
+            <ac:graphicFrameMk id="25603" creationId="{00000000-0000-0000-0000-000000000000}"/>
+          </ac:graphicFrameMkLst>
+        </pc:graphicFrameChg>
+      </pc:sldChg>
+      <pc:sldChg chg="addSp delSp modSp add del mod">
+        <pc:chgData name="Vempi Satriya" userId="c28fa87cdebdc656" providerId="LiveId" clId="{63E91B12-6D81-43DC-90EF-03735CFC9BF7}" dt="2026-08-23T00:01:48.827" v="441" actId="47"/>
+        <pc:sldMkLst>
+          <pc:docMk/>
+          <pc:sldMk cId="0" sldId="272"/>
+        </pc:sldMkLst>
+        <pc:spChg chg="del mod">
+          <ac:chgData name="Vempi Satriya" userId="c28fa87cdebdc656" providerId="LiveId" clId="{63E91B12-6D81-43DC-90EF-03735CFC9BF7}" dt="2026-08-23T00:00:43.369" v="417" actId="21"/>
+          <ac:spMkLst>
+            <pc:docMk/>
+            <pc:sldMk cId="0" sldId="272"/>
+            <ac:spMk id="3" creationId="{00000000-0000-0000-0000-000000000000}"/>
+          </ac:spMkLst>
+        </pc:spChg>
+        <pc:spChg chg="mod">
+          <ac:chgData name="Vempi Satriya" userId="c28fa87cdebdc656" providerId="LiveId" clId="{63E91B12-6D81-43DC-90EF-03735CFC9BF7}" dt="2026-08-22T23:49:48.407" v="194"/>
+          <ac:spMkLst>
+            <pc:docMk/>
+            <pc:sldMk cId="0" sldId="272"/>
+            <ac:spMk id="4" creationId="{00000000-0000-0000-0000-000000000000}"/>
+          </ac:spMkLst>
+        </pc:spChg>
+        <pc:spChg chg="add mod">
+          <ac:chgData name="Vempi Satriya" userId="c28fa87cdebdc656" providerId="LiveId" clId="{63E91B12-6D81-43DC-90EF-03735CFC9BF7}" dt="2026-08-23T00:00:43.369" v="417" actId="21"/>
+          <ac:spMkLst>
+            <pc:docMk/>
+            <pc:sldMk cId="0" sldId="272"/>
+            <ac:spMk id="5" creationId="{167A00F3-A0C8-712E-E7AE-382608E28C4D}"/>
+          </ac:spMkLst>
+        </pc:spChg>
+      </pc:sldChg>
+      <pc:sldChg chg="addSp delSp modSp add del mod">
+        <pc:chgData name="Vempi Satriya" userId="c28fa87cdebdc656" providerId="LiveId" clId="{63E91B12-6D81-43DC-90EF-03735CFC9BF7}" dt="2026-08-23T00:02:45.857" v="461" actId="47"/>
+        <pc:sldMkLst>
+          <pc:docMk/>
+          <pc:sldMk cId="0" sldId="273"/>
+        </pc:sldMkLst>
+        <pc:spChg chg="del">
+          <ac:chgData name="Vempi Satriya" userId="c28fa87cdebdc656" providerId="LiveId" clId="{63E91B12-6D81-43DC-90EF-03735CFC9BF7}" dt="2026-08-23T00:01:50.782" v="442" actId="21"/>
+          <ac:spMkLst>
+            <pc:docMk/>
+            <pc:sldMk cId="0" sldId="273"/>
+            <ac:spMk id="3" creationId="{00000000-0000-0000-0000-000000000000}"/>
+          </ac:spMkLst>
+        </pc:spChg>
+        <pc:spChg chg="mod">
+          <ac:chgData name="Vempi Satriya" userId="c28fa87cdebdc656" providerId="LiveId" clId="{63E91B12-6D81-43DC-90EF-03735CFC9BF7}" dt="2026-08-22T23:49:48.407" v="194"/>
+          <ac:spMkLst>
+            <pc:docMk/>
+            <pc:sldMk cId="0" sldId="273"/>
+            <ac:spMk id="4" creationId="{00000000-0000-0000-0000-000000000000}"/>
+          </ac:spMkLst>
+        </pc:spChg>
+        <pc:spChg chg="add mod">
+          <ac:chgData name="Vempi Satriya" userId="c28fa87cdebdc656" providerId="LiveId" clId="{63E91B12-6D81-43DC-90EF-03735CFC9BF7}" dt="2026-08-23T00:01:50.782" v="442" actId="21"/>
+          <ac:spMkLst>
+            <pc:docMk/>
+            <pc:sldMk cId="0" sldId="273"/>
+            <ac:spMk id="5" creationId="{BF09C53C-568D-084E-F21A-30B3F7313E8E}"/>
+          </ac:spMkLst>
+        </pc:spChg>
+      </pc:sldChg>
+      <pc:sldChg chg="addSp delSp modSp add del mod">
+        <pc:chgData name="Vempi Satriya" userId="c28fa87cdebdc656" providerId="LiveId" clId="{63E91B12-6D81-43DC-90EF-03735CFC9BF7}" dt="2026-08-23T00:02:45.857" v="461" actId="47"/>
+        <pc:sldMkLst>
+          <pc:docMk/>
+          <pc:sldMk cId="0" sldId="274"/>
+        </pc:sldMkLst>
+        <pc:spChg chg="mod">
+          <ac:chgData name="Vempi Satriya" userId="c28fa87cdebdc656" providerId="LiveId" clId="{63E91B12-6D81-43DC-90EF-03735CFC9BF7}" dt="2026-08-23T00:02:25.666" v="451" actId="27636"/>
+          <ac:spMkLst>
+            <pc:docMk/>
+            <pc:sldMk cId="0" sldId="274"/>
+            <ac:spMk id="2" creationId="{00000000-0000-0000-0000-000000000000}"/>
+          </ac:spMkLst>
+        </pc:spChg>
+        <pc:spChg chg="del">
+          <ac:chgData name="Vempi Satriya" userId="c28fa87cdebdc656" providerId="LiveId" clId="{63E91B12-6D81-43DC-90EF-03735CFC9BF7}" dt="2026-08-23T00:02:37.372" v="457" actId="21"/>
+          <ac:spMkLst>
+            <pc:docMk/>
+            <pc:sldMk cId="0" sldId="274"/>
+            <ac:spMk id="3" creationId="{00000000-0000-0000-0000-000000000000}"/>
+          </ac:spMkLst>
+        </pc:spChg>
+        <pc:spChg chg="mod">
+          <ac:chgData name="Vempi Satriya" userId="c28fa87cdebdc656" providerId="LiveId" clId="{63E91B12-6D81-43DC-90EF-03735CFC9BF7}" dt="2026-08-22T23:49:48.407" v="194"/>
+          <ac:spMkLst>
+            <pc:docMk/>
+            <pc:sldMk cId="0" sldId="274"/>
+            <ac:spMk id="4" creationId="{00000000-0000-0000-0000-000000000000}"/>
+          </ac:spMkLst>
+        </pc:spChg>
+        <pc:spChg chg="add mod">
+          <ac:chgData name="Vempi Satriya" userId="c28fa87cdebdc656" providerId="LiveId" clId="{63E91B12-6D81-43DC-90EF-03735CFC9BF7}" dt="2026-08-23T00:02:37.372" v="457" actId="21"/>
+          <ac:spMkLst>
+            <pc:docMk/>
+            <pc:sldMk cId="0" sldId="274"/>
+            <ac:spMk id="6" creationId="{183FD28A-1994-C26E-A196-12F415C98054}"/>
+          </ac:spMkLst>
+        </pc:spChg>
+        <pc:graphicFrameChg chg="del">
+          <ac:chgData name="Vempi Satriya" userId="c28fa87cdebdc656" providerId="LiveId" clId="{63E91B12-6D81-43DC-90EF-03735CFC9BF7}" dt="2026-08-23T00:02:37.372" v="457" actId="21"/>
+          <ac:graphicFrameMkLst>
+            <pc:docMk/>
+            <pc:sldMk cId="0" sldId="274"/>
+            <ac:graphicFrameMk id="26625" creationId="{00000000-0000-0000-0000-000000000000}"/>
+          </ac:graphicFrameMkLst>
+        </pc:graphicFrameChg>
+      </pc:sldChg>
+      <pc:sldChg chg="addSp delSp modSp add mod modClrScheme chgLayout">
+        <pc:chgData name="Vempi Satriya" userId="c28fa87cdebdc656" providerId="LiveId" clId="{63E91B12-6D81-43DC-90EF-03735CFC9BF7}" dt="2026-08-23T13:44:06.696" v="752" actId="20577"/>
+        <pc:sldMkLst>
+          <pc:docMk/>
+          <pc:sldMk cId="0" sldId="275"/>
+        </pc:sldMkLst>
+        <pc:spChg chg="add del mod ord">
+          <ac:chgData name="Vempi Satriya" userId="c28fa87cdebdc656" providerId="LiveId" clId="{63E91B12-6D81-43DC-90EF-03735CFC9BF7}" dt="2026-08-23T00:02:56.045" v="463" actId="700"/>
+          <ac:spMkLst>
+            <pc:docMk/>
+            <pc:sldMk cId="0" sldId="275"/>
+            <ac:spMk id="2" creationId="{DA5FF4CF-113F-8E5E-6C39-ADF75097EFC1}"/>
+          </ac:spMkLst>
+        </pc:spChg>
+        <pc:spChg chg="mod ord">
+          <ac:chgData name="Vempi Satriya" userId="c28fa87cdebdc656" providerId="LiveId" clId="{63E91B12-6D81-43DC-90EF-03735CFC9BF7}" dt="2026-08-23T13:44:06.696" v="752" actId="20577"/>
+          <ac:spMkLst>
+            <pc:docMk/>
+            <pc:sldMk cId="0" sldId="275"/>
+            <ac:spMk id="3" creationId="{00000000-0000-0000-0000-000000000000}"/>
+          </ac:spMkLst>
+        </pc:spChg>
+        <pc:spChg chg="mod ord">
+          <ac:chgData name="Vempi Satriya" userId="c28fa87cdebdc656" providerId="LiveId" clId="{63E91B12-6D81-43DC-90EF-03735CFC9BF7}" dt="2026-08-23T00:02:59.023" v="464" actId="700"/>
+          <ac:spMkLst>
+            <pc:docMk/>
+            <pc:sldMk cId="0" sldId="275"/>
+            <ac:spMk id="4" creationId="{00000000-0000-0000-0000-000000000000}"/>
+          </ac:spMkLst>
+        </pc:spChg>
+        <pc:spChg chg="add mod ord">
+          <ac:chgData name="Vempi Satriya" userId="c28fa87cdebdc656" providerId="LiveId" clId="{63E91B12-6D81-43DC-90EF-03735CFC9BF7}" dt="2026-08-23T00:03:32.657" v="475" actId="20577"/>
+          <ac:spMkLst>
+            <pc:docMk/>
+            <pc:sldMk cId="0" sldId="275"/>
+            <ac:spMk id="5" creationId="{046D7527-E928-C5A1-9CAD-339A6BFF004A}"/>
+          </ac:spMkLst>
+        </pc:spChg>
+      </pc:sldChg>
+      <pc:sldChg chg="addSp delSp modSp add mod modClrScheme chgLayout">
+        <pc:chgData name="Vempi Satriya" userId="c28fa87cdebdc656" providerId="LiveId" clId="{63E91B12-6D81-43DC-90EF-03735CFC9BF7}" dt="2026-08-23T00:03:35.314" v="478" actId="20577"/>
+        <pc:sldMkLst>
+          <pc:docMk/>
+          <pc:sldMk cId="0" sldId="276"/>
+        </pc:sldMkLst>
+        <pc:spChg chg="add del mod ord">
+          <ac:chgData name="Vempi Satriya" userId="c28fa87cdebdc656" providerId="LiveId" clId="{63E91B12-6D81-43DC-90EF-03735CFC9BF7}" dt="2026-08-23T00:02:56.045" v="463" actId="700"/>
+          <ac:spMkLst>
+            <pc:docMk/>
+            <pc:sldMk cId="0" sldId="276"/>
+            <ac:spMk id="2" creationId="{1E185C70-1AD1-8444-FEE4-3D692CD02825}"/>
+          </ac:spMkLst>
+        </pc:spChg>
+        <pc:spChg chg="mod ord">
+          <ac:chgData name="Vempi Satriya" userId="c28fa87cdebdc656" providerId="LiveId" clId="{63E91B12-6D81-43DC-90EF-03735CFC9BF7}" dt="2026-08-23T00:02:59.023" v="464" actId="700"/>
+          <ac:spMkLst>
+            <pc:docMk/>
+            <pc:sldMk cId="0" sldId="276"/>
+            <ac:spMk id="3" creationId="{00000000-0000-0000-0000-000000000000}"/>
+          </ac:spMkLst>
+        </pc:spChg>
+        <pc:spChg chg="mod ord">
+          <ac:chgData name="Vempi Satriya" userId="c28fa87cdebdc656" providerId="LiveId" clId="{63E91B12-6D81-43DC-90EF-03735CFC9BF7}" dt="2026-08-23T00:02:59.023" v="464" actId="700"/>
+          <ac:spMkLst>
+            <pc:docMk/>
+            <pc:sldMk cId="0" sldId="276"/>
+            <ac:spMk id="4" creationId="{00000000-0000-0000-0000-000000000000}"/>
+          </ac:spMkLst>
+        </pc:spChg>
+        <pc:spChg chg="add mod ord">
+          <ac:chgData name="Vempi Satriya" userId="c28fa87cdebdc656" providerId="LiveId" clId="{63E91B12-6D81-43DC-90EF-03735CFC9BF7}" dt="2026-08-23T00:03:35.314" v="478" actId="20577"/>
+          <ac:spMkLst>
+            <pc:docMk/>
+            <pc:sldMk cId="0" sldId="276"/>
+            <ac:spMk id="5" creationId="{776C20D9-67C1-C613-0ADD-EF5425FA7A2E}"/>
+          </ac:spMkLst>
+        </pc:spChg>
+      </pc:sldChg>
+      <pc:sldChg chg="addSp delSp modSp add mod modClrScheme chgLayout">
+        <pc:chgData name="Vempi Satriya" userId="c28fa87cdebdc656" providerId="LiveId" clId="{63E91B12-6D81-43DC-90EF-03735CFC9BF7}" dt="2026-08-23T00:03:37.800" v="481" actId="20577"/>
+        <pc:sldMkLst>
+          <pc:docMk/>
+          <pc:sldMk cId="0" sldId="277"/>
+        </pc:sldMkLst>
+        <pc:spChg chg="add del mod ord">
+          <ac:chgData name="Vempi Satriya" userId="c28fa87cdebdc656" providerId="LiveId" clId="{63E91B12-6D81-43DC-90EF-03735CFC9BF7}" dt="2026-08-23T00:02:56.045" v="463" actId="700"/>
+          <ac:spMkLst>
+            <pc:docMk/>
+            <pc:sldMk cId="0" sldId="277"/>
+            <ac:spMk id="2" creationId="{59C541FC-9D85-F09A-B50B-B460E63BCC4A}"/>
+          </ac:spMkLst>
+        </pc:spChg>
+        <pc:spChg chg="mod ord">
+          <ac:chgData name="Vempi Satriya" userId="c28fa87cdebdc656" providerId="LiveId" clId="{63E91B12-6D81-43DC-90EF-03735CFC9BF7}" dt="2026-08-23T00:02:59.023" v="464" actId="700"/>
+          <ac:spMkLst>
+            <pc:docMk/>
+            <pc:sldMk cId="0" sldId="277"/>
+            <ac:spMk id="3" creationId="{00000000-0000-0000-0000-000000000000}"/>
+          </ac:spMkLst>
+        </pc:spChg>
+        <pc:spChg chg="mod ord">
+          <ac:chgData name="Vempi Satriya" userId="c28fa87cdebdc656" providerId="LiveId" clId="{63E91B12-6D81-43DC-90EF-03735CFC9BF7}" dt="2026-08-23T00:02:59.023" v="464" actId="700"/>
+          <ac:spMkLst>
+            <pc:docMk/>
+            <pc:sldMk cId="0" sldId="277"/>
+            <ac:spMk id="4" creationId="{00000000-0000-0000-0000-000000000000}"/>
+          </ac:spMkLst>
+        </pc:spChg>
+        <pc:spChg chg="add mod ord">
+          <ac:chgData name="Vempi Satriya" userId="c28fa87cdebdc656" providerId="LiveId" clId="{63E91B12-6D81-43DC-90EF-03735CFC9BF7}" dt="2026-08-23T00:03:37.800" v="481" actId="20577"/>
+          <ac:spMkLst>
+            <pc:docMk/>
+            <pc:sldMk cId="0" sldId="277"/>
+            <ac:spMk id="5" creationId="{93D4B5D0-F503-5824-DD69-620B2D2D6207}"/>
+          </ac:spMkLst>
+        </pc:spChg>
+      </pc:sldChg>
+      <pc:sldChg chg="addSp delSp modSp add mod modClrScheme chgLayout">
+        <pc:chgData name="Vempi Satriya" userId="c28fa87cdebdc656" providerId="LiveId" clId="{63E91B12-6D81-43DC-90EF-03735CFC9BF7}" dt="2026-08-23T13:44:20.666" v="753" actId="1076"/>
+        <pc:sldMkLst>
+          <pc:docMk/>
+          <pc:sldMk cId="0" sldId="278"/>
+        </pc:sldMkLst>
+        <pc:spChg chg="add del mod ord">
+          <ac:chgData name="Vempi Satriya" userId="c28fa87cdebdc656" providerId="LiveId" clId="{63E91B12-6D81-43DC-90EF-03735CFC9BF7}" dt="2026-08-23T00:02:56.045" v="463" actId="700"/>
+          <ac:spMkLst>
+            <pc:docMk/>
+            <pc:sldMk cId="0" sldId="278"/>
+            <ac:spMk id="2" creationId="{FF39F349-3B40-F8F4-1B8A-C1F83170347F}"/>
+          </ac:spMkLst>
+        </pc:spChg>
+        <pc:spChg chg="mod ord">
+          <ac:chgData name="Vempi Satriya" userId="c28fa87cdebdc656" providerId="LiveId" clId="{63E91B12-6D81-43DC-90EF-03735CFC9BF7}" dt="2026-08-23T00:02:59.023" v="464" actId="700"/>
+          <ac:spMkLst>
+            <pc:docMk/>
+            <pc:sldMk cId="0" sldId="278"/>
+            <ac:spMk id="3" creationId="{00000000-0000-0000-0000-000000000000}"/>
+          </ac:spMkLst>
+        </pc:spChg>
+        <pc:spChg chg="mod ord">
+          <ac:chgData name="Vempi Satriya" userId="c28fa87cdebdc656" providerId="LiveId" clId="{63E91B12-6D81-43DC-90EF-03735CFC9BF7}" dt="2026-08-23T00:02:59.023" v="464" actId="700"/>
+          <ac:spMkLst>
+            <pc:docMk/>
+            <pc:sldMk cId="0" sldId="278"/>
+            <ac:spMk id="4" creationId="{00000000-0000-0000-0000-000000000000}"/>
+          </ac:spMkLst>
+        </pc:spChg>
+        <pc:spChg chg="add mod ord">
+          <ac:chgData name="Vempi Satriya" userId="c28fa87cdebdc656" providerId="LiveId" clId="{63E91B12-6D81-43DC-90EF-03735CFC9BF7}" dt="2026-08-23T00:03:40.170" v="484" actId="20577"/>
+          <ac:spMkLst>
+            <pc:docMk/>
+            <pc:sldMk cId="0" sldId="278"/>
+            <ac:spMk id="5" creationId="{FDF0DF6B-0D5E-E786-6A5E-ED520BF6358F}"/>
+          </ac:spMkLst>
+        </pc:spChg>
+        <pc:graphicFrameChg chg="mod">
+          <ac:chgData name="Vempi Satriya" userId="c28fa87cdebdc656" providerId="LiveId" clId="{63E91B12-6D81-43DC-90EF-03735CFC9BF7}" dt="2026-08-23T13:44:20.666" v="753" actId="1076"/>
+          <ac:graphicFrameMkLst>
+            <pc:docMk/>
+            <pc:sldMk cId="0" sldId="278"/>
+            <ac:graphicFrameMk id="35841" creationId="{00000000-0000-0000-0000-000000000000}"/>
+          </ac:graphicFrameMkLst>
+        </pc:graphicFrameChg>
+      </pc:sldChg>
+      <pc:sldChg chg="addSp delSp modSp add mod modClrScheme chgLayout">
+        <pc:chgData name="Vempi Satriya" userId="c28fa87cdebdc656" providerId="LiveId" clId="{63E91B12-6D81-43DC-90EF-03735CFC9BF7}" dt="2026-08-23T00:03:44.004" v="487" actId="20577"/>
+        <pc:sldMkLst>
+          <pc:docMk/>
+          <pc:sldMk cId="0" sldId="279"/>
+        </pc:sldMkLst>
+        <pc:spChg chg="add del mod ord">
+          <ac:chgData name="Vempi Satriya" userId="c28fa87cdebdc656" providerId="LiveId" clId="{63E91B12-6D81-43DC-90EF-03735CFC9BF7}" dt="2026-08-23T00:02:56.045" v="463" actId="700"/>
+          <ac:spMkLst>
+            <pc:docMk/>
+            <pc:sldMk cId="0" sldId="279"/>
+            <ac:spMk id="2" creationId="{17CF3C50-1971-90A1-B5A0-77C7CAA8F1CA}"/>
+          </ac:spMkLst>
+        </pc:spChg>
+        <pc:spChg chg="mod ord">
+          <ac:chgData name="Vempi Satriya" userId="c28fa87cdebdc656" providerId="LiveId" clId="{63E91B12-6D81-43DC-90EF-03735CFC9BF7}" dt="2026-08-23T00:02:59.023" v="464" actId="700"/>
+          <ac:spMkLst>
+            <pc:docMk/>
+            <pc:sldMk cId="0" sldId="279"/>
+            <ac:spMk id="3" creationId="{00000000-0000-0000-0000-000000000000}"/>
+          </ac:spMkLst>
+        </pc:spChg>
+        <pc:spChg chg="mod ord">
+          <ac:chgData name="Vempi Satriya" userId="c28fa87cdebdc656" providerId="LiveId" clId="{63E91B12-6D81-43DC-90EF-03735CFC9BF7}" dt="2026-08-23T00:02:59.023" v="464" actId="700"/>
+          <ac:spMkLst>
+            <pc:docMk/>
+            <pc:sldMk cId="0" sldId="279"/>
+            <ac:spMk id="4" creationId="{00000000-0000-0000-0000-000000000000}"/>
+          </ac:spMkLst>
+        </pc:spChg>
+        <pc:spChg chg="add mod ord">
+          <ac:chgData name="Vempi Satriya" userId="c28fa87cdebdc656" providerId="LiveId" clId="{63E91B12-6D81-43DC-90EF-03735CFC9BF7}" dt="2026-08-23T00:03:44.004" v="487" actId="20577"/>
+          <ac:spMkLst>
+            <pc:docMk/>
+            <pc:sldMk cId="0" sldId="279"/>
+            <ac:spMk id="5" creationId="{D75CF340-AF4B-6822-92DC-28A4AFD10775}"/>
+          </ac:spMkLst>
+        </pc:spChg>
+      </pc:sldChg>
+      <pc:sldChg chg="addSp modSp add del mod modClrScheme chgLayout">
+        <pc:chgData name="Vempi Satriya" userId="c28fa87cdebdc656" providerId="LiveId" clId="{63E91B12-6D81-43DC-90EF-03735CFC9BF7}" dt="2026-08-23T00:03:20.333" v="469" actId="47"/>
+        <pc:sldMkLst>
+          <pc:docMk/>
+          <pc:sldMk cId="0" sldId="280"/>
+        </pc:sldMkLst>
+        <pc:spChg chg="mod ord">
+          <ac:chgData name="Vempi Satriya" userId="c28fa87cdebdc656" providerId="LiveId" clId="{63E91B12-6D81-43DC-90EF-03735CFC9BF7}" dt="2026-08-23T00:02:59.023" v="464" actId="700"/>
+          <ac:spMkLst>
+            <pc:docMk/>
+            <pc:sldMk cId="0" sldId="280"/>
+            <ac:spMk id="2" creationId="{00000000-0000-0000-0000-000000000000}"/>
+          </ac:spMkLst>
+        </pc:spChg>
+        <pc:spChg chg="mod ord">
+          <ac:chgData name="Vempi Satriya" userId="c28fa87cdebdc656" providerId="LiveId" clId="{63E91B12-6D81-43DC-90EF-03735CFC9BF7}" dt="2026-08-23T00:02:59.023" v="464" actId="700"/>
+          <ac:spMkLst>
+            <pc:docMk/>
+            <pc:sldMk cId="0" sldId="280"/>
+            <ac:spMk id="3" creationId="{00000000-0000-0000-0000-000000000000}"/>
+          </ac:spMkLst>
+        </pc:spChg>
+        <pc:spChg chg="mod ord">
+          <ac:chgData name="Vempi Satriya" userId="c28fa87cdebdc656" providerId="LiveId" clId="{63E91B12-6D81-43DC-90EF-03735CFC9BF7}" dt="2026-08-23T00:02:59.023" v="464" actId="700"/>
+          <ac:spMkLst>
+            <pc:docMk/>
+            <pc:sldMk cId="0" sldId="280"/>
+            <ac:spMk id="4" creationId="{00000000-0000-0000-0000-000000000000}"/>
+          </ac:spMkLst>
+        </pc:spChg>
+        <pc:spChg chg="add mod ord">
+          <ac:chgData name="Vempi Satriya" userId="c28fa87cdebdc656" providerId="LiveId" clId="{63E91B12-6D81-43DC-90EF-03735CFC9BF7}" dt="2026-08-23T00:02:59.023" v="464" actId="700"/>
+          <ac:spMkLst>
+            <pc:docMk/>
+            <pc:sldMk cId="0" sldId="280"/>
+            <ac:spMk id="5" creationId="{D7D26ACB-9DA4-C899-ED0A-445F3E6BE549}"/>
+          </ac:spMkLst>
+        </pc:spChg>
+      </pc:sldChg>
+      <pc:sldChg chg="addSp delSp modSp add del mod modClrScheme chgLayout">
+        <pc:chgData name="Vempi Satriya" userId="c28fa87cdebdc656" providerId="LiveId" clId="{63E91B12-6D81-43DC-90EF-03735CFC9BF7}" dt="2026-08-23T13:38:58.418" v="525" actId="2696"/>
+        <pc:sldMkLst>
+          <pc:docMk/>
+          <pc:sldMk cId="0" sldId="281"/>
+        </pc:sldMkLst>
+        <pc:spChg chg="del mod ord">
+          <ac:chgData name="Vempi Satriya" userId="c28fa87cdebdc656" providerId="LiveId" clId="{63E91B12-6D81-43DC-90EF-03735CFC9BF7}" dt="2026-08-23T00:03:26.636" v="472" actId="478"/>
+          <ac:spMkLst>
+            <pc:docMk/>
+            <pc:sldMk cId="0" sldId="281"/>
+            <ac:spMk id="2" creationId="{00000000-0000-0000-0000-000000000000}"/>
+          </ac:spMkLst>
+        </pc:spChg>
+        <pc:spChg chg="mod ord">
+          <ac:chgData name="Vempi Satriya" userId="c28fa87cdebdc656" providerId="LiveId" clId="{63E91B12-6D81-43DC-90EF-03735CFC9BF7}" dt="2026-08-23T13:38:47.692" v="523" actId="20577"/>
+          <ac:spMkLst>
+            <pc:docMk/>
+            <pc:sldMk cId="0" sldId="281"/>
+            <ac:spMk id="3" creationId="{00000000-0000-0000-0000-000000000000}"/>
+          </ac:spMkLst>
+        </pc:spChg>
+        <pc:spChg chg="mod ord">
+          <ac:chgData name="Vempi Satriya" userId="c28fa87cdebdc656" providerId="LiveId" clId="{63E91B12-6D81-43DC-90EF-03735CFC9BF7}" dt="2026-08-23T00:02:59.023" v="464" actId="700"/>
+          <ac:spMkLst>
+            <pc:docMk/>
+            <pc:sldMk cId="0" sldId="281"/>
+            <ac:spMk id="4" creationId="{00000000-0000-0000-0000-000000000000}"/>
+          </ac:spMkLst>
+        </pc:spChg>
+        <pc:spChg chg="add mod ord">
+          <ac:chgData name="Vempi Satriya" userId="c28fa87cdebdc656" providerId="LiveId" clId="{63E91B12-6D81-43DC-90EF-03735CFC9BF7}" dt="2026-08-23T13:38:55.905" v="524" actId="20577"/>
+          <ac:spMkLst>
+            <pc:docMk/>
+            <pc:sldMk cId="0" sldId="281"/>
+            <ac:spMk id="5" creationId="{B4328ECA-7F89-648A-4AC5-F6AD1E574BDB}"/>
+          </ac:spMkLst>
+        </pc:spChg>
+      </pc:sldChg>
+      <pc:sldChg chg="add">
+        <pc:chgData name="Vempi Satriya" userId="c28fa87cdebdc656" providerId="LiveId" clId="{63E91B12-6D81-43DC-90EF-03735CFC9BF7}" dt="2026-08-23T13:39:02.740" v="526"/>
+        <pc:sldMkLst>
+          <pc:docMk/>
+          <pc:sldMk cId="807675183" sldId="281"/>
+        </pc:sldMkLst>
+      </pc:sldChg>
+      <pc:sldChg chg="addSp delSp modSp add del mod modClrScheme chgLayout">
+        <pc:chgData name="Vempi Satriya" userId="c28fa87cdebdc656" providerId="LiveId" clId="{63E91B12-6D81-43DC-90EF-03735CFC9BF7}" dt="2026-08-23T00:03:17.041" v="468" actId="47"/>
+        <pc:sldMkLst>
+          <pc:docMk/>
+          <pc:sldMk cId="0" sldId="282"/>
+        </pc:sldMkLst>
+        <pc:spChg chg="del mod ord">
+          <ac:chgData name="Vempi Satriya" userId="c28fa87cdebdc656" providerId="LiveId" clId="{63E91B12-6D81-43DC-90EF-03735CFC9BF7}" dt="2026-08-23T00:03:13.061" v="467" actId="478"/>
+          <ac:spMkLst>
+            <pc:docMk/>
+            <pc:sldMk cId="0" sldId="282"/>
+            <ac:spMk id="2" creationId="{00000000-0000-0000-0000-000000000000}"/>
+          </ac:spMkLst>
+        </pc:spChg>
+        <pc:spChg chg="mod ord">
+          <ac:chgData name="Vempi Satriya" userId="c28fa87cdebdc656" providerId="LiveId" clId="{63E91B12-6D81-43DC-90EF-03735CFC9BF7}" dt="2026-08-23T00:02:59.023" v="464" actId="700"/>
+          <ac:spMkLst>
+            <pc:docMk/>
+            <pc:sldMk cId="0" sldId="282"/>
+            <ac:spMk id="3" creationId="{00000000-0000-0000-0000-000000000000}"/>
+          </ac:spMkLst>
+        </pc:spChg>
+        <pc:spChg chg="mod ord">
+          <ac:chgData name="Vempi Satriya" userId="c28fa87cdebdc656" providerId="LiveId" clId="{63E91B12-6D81-43DC-90EF-03735CFC9BF7}" dt="2026-08-23T00:02:59.023" v="464" actId="700"/>
+          <ac:spMkLst>
+            <pc:docMk/>
+            <pc:sldMk cId="0" sldId="282"/>
+            <ac:spMk id="4" creationId="{00000000-0000-0000-0000-000000000000}"/>
+          </ac:spMkLst>
+        </pc:spChg>
+        <pc:spChg chg="add mod ord">
+          <ac:chgData name="Vempi Satriya" userId="c28fa87cdebdc656" providerId="LiveId" clId="{63E91B12-6D81-43DC-90EF-03735CFC9BF7}" dt="2026-08-23T00:03:10.765" v="466"/>
+          <ac:spMkLst>
+            <pc:docMk/>
+            <pc:sldMk cId="0" sldId="282"/>
+            <ac:spMk id="5" creationId="{6AA807DB-5812-1715-B48E-9A593F972B2A}"/>
+          </ac:spMkLst>
+        </pc:spChg>
+      </pc:sldChg>
+      <pc:sldChg chg="modSp add mod ord">
+        <pc:chgData name="Vempi Satriya" userId="c28fa87cdebdc656" providerId="LiveId" clId="{63E91B12-6D81-43DC-90EF-03735CFC9BF7}" dt="2026-08-22T23:01:03.858" v="34" actId="20577"/>
+        <pc:sldMkLst>
+          <pc:docMk/>
+          <pc:sldMk cId="2786985036" sldId="446"/>
+        </pc:sldMkLst>
+        <pc:spChg chg="mod">
+          <ac:chgData name="Vempi Satriya" userId="c28fa87cdebdc656" providerId="LiveId" clId="{63E91B12-6D81-43DC-90EF-03735CFC9BF7}" dt="2026-08-22T23:00:56.286" v="26" actId="20577"/>
+          <ac:spMkLst>
+            <pc:docMk/>
+            <pc:sldMk cId="2786985036" sldId="446"/>
+            <ac:spMk id="2" creationId="{105EC2C9-4CD0-8366-D364-71406CA7BAB1}"/>
+          </ac:spMkLst>
+        </pc:spChg>
+        <pc:spChg chg="mod">
+          <ac:chgData name="Vempi Satriya" userId="c28fa87cdebdc656" providerId="LiveId" clId="{63E91B12-6D81-43DC-90EF-03735CFC9BF7}" dt="2026-08-22T23:01:03.858" v="34" actId="20577"/>
+          <ac:spMkLst>
+            <pc:docMk/>
+            <pc:sldMk cId="2786985036" sldId="446"/>
+            <ac:spMk id="10" creationId="{C380F36F-34CC-A3E2-C04F-283794511B5A}"/>
+          </ac:spMkLst>
+        </pc:spChg>
+      </pc:sldChg>
+      <pc:sldChg chg="modSp add mod ord">
+        <pc:chgData name="Vempi Satriya" userId="c28fa87cdebdc656" providerId="LiveId" clId="{63E91B12-6D81-43DC-90EF-03735CFC9BF7}" dt="2026-08-22T23:46:33.037" v="99" actId="20577"/>
+        <pc:sldMkLst>
+          <pc:docMk/>
+          <pc:sldMk cId="3369835165" sldId="447"/>
+        </pc:sldMkLst>
+        <pc:spChg chg="mod">
+          <ac:chgData name="Vempi Satriya" userId="c28fa87cdebdc656" providerId="LiveId" clId="{63E91B12-6D81-43DC-90EF-03735CFC9BF7}" dt="2026-08-22T23:46:33.037" v="99" actId="20577"/>
+          <ac:spMkLst>
+            <pc:docMk/>
+            <pc:sldMk cId="3369835165" sldId="447"/>
+            <ac:spMk id="9" creationId="{44447A6A-DE6B-F8FF-F2B7-8528FEA7DB6C}"/>
+          </ac:spMkLst>
+        </pc:spChg>
+      </pc:sldChg>
+      <pc:sldChg chg="modSp add mod ord">
+        <pc:chgData name="Vempi Satriya" userId="c28fa87cdebdc656" providerId="LiveId" clId="{63E91B12-6D81-43DC-90EF-03735CFC9BF7}" dt="2026-08-23T13:39:45.275" v="528"/>
+        <pc:sldMkLst>
+          <pc:docMk/>
+          <pc:sldMk cId="2295548169" sldId="466"/>
+        </pc:sldMkLst>
+        <pc:spChg chg="mod">
+          <ac:chgData name="Vempi Satriya" userId="c28fa87cdebdc656" providerId="LiveId" clId="{63E91B12-6D81-43DC-90EF-03735CFC9BF7}" dt="2026-08-23T13:39:45.275" v="528"/>
+          <ac:spMkLst>
+            <pc:docMk/>
+            <pc:sldMk cId="2295548169" sldId="466"/>
+            <ac:spMk id="2" creationId="{49F57B89-E735-2445-E211-2F43000213C9}"/>
+          </ac:spMkLst>
+        </pc:spChg>
+        <pc:spChg chg="mod">
+          <ac:chgData name="Vempi Satriya" userId="c28fa87cdebdc656" providerId="LiveId" clId="{63E91B12-6D81-43DC-90EF-03735CFC9BF7}" dt="2026-08-22T23:47:36.127" v="178" actId="1076"/>
+          <ac:spMkLst>
+            <pc:docMk/>
+            <pc:sldMk cId="2295548169" sldId="466"/>
+            <ac:spMk id="3" creationId="{D7BA2576-9F6B-24D0-0DD1-459B8B43B4BE}"/>
+          </ac:spMkLst>
+        </pc:spChg>
+      </pc:sldChg>
+      <pc:sldChg chg="modSp add mod ord">
+        <pc:chgData name="Vempi Satriya" userId="c28fa87cdebdc656" providerId="LiveId" clId="{63E91B12-6D81-43DC-90EF-03735CFC9BF7}" dt="2026-08-22T23:47:18.716" v="173" actId="20577"/>
+        <pc:sldMkLst>
+          <pc:docMk/>
+          <pc:sldMk cId="2704878614" sldId="508"/>
+        </pc:sldMkLst>
+        <pc:spChg chg="mod">
+          <ac:chgData name="Vempi Satriya" userId="c28fa87cdebdc656" providerId="LiveId" clId="{63E91B12-6D81-43DC-90EF-03735CFC9BF7}" dt="2026-08-22T23:47:18.716" v="173" actId="20577"/>
+          <ac:spMkLst>
+            <pc:docMk/>
+            <pc:sldMk cId="2704878614" sldId="508"/>
+            <ac:spMk id="7" creationId="{44E2F015-5FCA-585A-E3D4-0B031A511ABF}"/>
+          </ac:spMkLst>
+        </pc:spChg>
+      </pc:sldChg>
+      <pc:sldChg chg="modSp add mod ord">
+        <pc:chgData name="Vempi Satriya" userId="c28fa87cdebdc656" providerId="LiveId" clId="{63E91B12-6D81-43DC-90EF-03735CFC9BF7}" dt="2026-08-23T13:38:02.721" v="502" actId="20577"/>
+        <pc:sldMkLst>
+          <pc:docMk/>
+          <pc:sldMk cId="4138773860" sldId="587"/>
+        </pc:sldMkLst>
+        <pc:spChg chg="mod">
+          <ac:chgData name="Vempi Satriya" userId="c28fa87cdebdc656" providerId="LiveId" clId="{63E91B12-6D81-43DC-90EF-03735CFC9BF7}" dt="2026-08-23T13:38:02.721" v="502" actId="20577"/>
+          <ac:spMkLst>
+            <pc:docMk/>
+            <pc:sldMk cId="4138773860" sldId="587"/>
+            <ac:spMk id="2" creationId="{49F57B89-E735-2445-E211-2F43000213C9}"/>
+          </ac:spMkLst>
+        </pc:spChg>
+        <pc:spChg chg="mod">
+          <ac:chgData name="Vempi Satriya" userId="c28fa87cdebdc656" providerId="LiveId" clId="{63E91B12-6D81-43DC-90EF-03735CFC9BF7}" dt="2026-08-22T23:46:50.979" v="126" actId="20577"/>
+          <ac:spMkLst>
+            <pc:docMk/>
+            <pc:sldMk cId="4138773860" sldId="587"/>
+            <ac:spMk id="3" creationId="{D7BA2576-9F6B-24D0-0DD1-459B8B43B4BE}"/>
+          </ac:spMkLst>
+        </pc:spChg>
+      </pc:sldChg>
+      <pc:sldChg chg="addSp delSp modSp add del mod">
+        <pc:chgData name="Vempi Satriya" userId="c28fa87cdebdc656" providerId="LiveId" clId="{63E91B12-6D81-43DC-90EF-03735CFC9BF7}" dt="2026-08-23T13:39:04.185" v="527" actId="47"/>
+        <pc:sldMkLst>
+          <pc:docMk/>
+          <pc:sldMk cId="1502959050" sldId="588"/>
+        </pc:sldMkLst>
+        <pc:spChg chg="del">
+          <ac:chgData name="Vempi Satriya" userId="c28fa87cdebdc656" providerId="LiveId" clId="{63E91B12-6D81-43DC-90EF-03735CFC9BF7}" dt="2026-08-22T23:47:46.043" v="189" actId="478"/>
+          <ac:spMkLst>
+            <pc:docMk/>
+            <pc:sldMk cId="1502959050" sldId="588"/>
+            <ac:spMk id="2" creationId="{0471BFBF-FB20-63A9-068F-5E58DA43D841}"/>
+          </ac:spMkLst>
+        </pc:spChg>
+        <pc:spChg chg="mod">
+          <ac:chgData name="Vempi Satriya" userId="c28fa87cdebdc656" providerId="LiveId" clId="{63E91B12-6D81-43DC-90EF-03735CFC9BF7}" dt="2026-08-22T23:47:43.556" v="188" actId="20577"/>
+          <ac:spMkLst>
+            <pc:docMk/>
+            <pc:sldMk cId="1502959050" sldId="588"/>
+            <ac:spMk id="3" creationId="{9EE4C49F-F215-9AE5-C008-187C5F386DAB}"/>
+          </ac:spMkLst>
+        </pc:spChg>
+        <pc:spChg chg="add del mod">
+          <ac:chgData name="Vempi Satriya" userId="c28fa87cdebdc656" providerId="LiveId" clId="{63E91B12-6D81-43DC-90EF-03735CFC9BF7}" dt="2026-08-22T23:47:48.153" v="191" actId="478"/>
+          <ac:spMkLst>
+            <pc:docMk/>
+            <pc:sldMk cId="1502959050" sldId="588"/>
+            <ac:spMk id="6" creationId="{27821924-5C9B-CA2C-2FA9-A7AA530ED480}"/>
+          </ac:spMkLst>
+        </pc:spChg>
+        <pc:spChg chg="add">
+          <ac:chgData name="Vempi Satriya" userId="c28fa87cdebdc656" providerId="LiveId" clId="{63E91B12-6D81-43DC-90EF-03735CFC9BF7}" dt="2026-08-22T23:47:46.323" v="190" actId="22"/>
+          <ac:spMkLst>
+            <pc:docMk/>
+            <pc:sldMk cId="1502959050" sldId="588"/>
+            <ac:spMk id="8" creationId="{42F4F85F-CFEC-071D-B5EE-08A14CE960E1}"/>
+          </ac:spMkLst>
+        </pc:spChg>
+      </pc:sldChg>
+      <pc:sldChg chg="modSp add del">
+        <pc:chgData name="Vempi Satriya" userId="c28fa87cdebdc656" providerId="LiveId" clId="{63E91B12-6D81-43DC-90EF-03735CFC9BF7}" dt="2026-08-22T23:50:01.946" v="205"/>
+        <pc:sldMkLst>
+          <pc:docMk/>
+          <pc:sldMk cId="0" sldId="589"/>
+        </pc:sldMkLst>
+        <pc:spChg chg="mod">
+          <ac:chgData name="Vempi Satriya" userId="c28fa87cdebdc656" providerId="LiveId" clId="{63E91B12-6D81-43DC-90EF-03735CFC9BF7}" dt="2026-08-22T23:50:00.885" v="199"/>
+          <ac:spMkLst>
+            <pc:docMk/>
+            <pc:sldMk cId="0" sldId="589"/>
+            <ac:spMk id="4" creationId="{00000000-0000-0000-0000-000000000000}"/>
+          </ac:spMkLst>
+        </pc:spChg>
+      </pc:sldChg>
+      <pc:sldChg chg="addSp delSp modSp add mod">
+        <pc:chgData name="Vempi Satriya" userId="c28fa87cdebdc656" providerId="LiveId" clId="{63E91B12-6D81-43DC-90EF-03735CFC9BF7}" dt="2026-08-23T17:15:26.345" v="763" actId="1076"/>
+        <pc:sldMkLst>
+          <pc:docMk/>
+          <pc:sldMk cId="1006154732" sldId="589"/>
+        </pc:sldMkLst>
+        <pc:spChg chg="add mod">
+          <ac:chgData name="Vempi Satriya" userId="c28fa87cdebdc656" providerId="LiveId" clId="{63E91B12-6D81-43DC-90EF-03735CFC9BF7}" dt="2026-08-23T17:14:57.773" v="755" actId="20577"/>
+          <ac:spMkLst>
+            <pc:docMk/>
+            <pc:sldMk cId="1006154732" sldId="589"/>
+            <ac:spMk id="2" creationId="{00000000-0000-0000-0000-000000000000}"/>
+          </ac:spMkLst>
+        </pc:spChg>
+        <pc:spChg chg="mod">
+          <ac:chgData name="Vempi Satriya" userId="c28fa87cdebdc656" providerId="LiveId" clId="{63E91B12-6D81-43DC-90EF-03735CFC9BF7}" dt="2026-08-22T23:50:13.969" v="208"/>
+          <ac:spMkLst>
+            <pc:docMk/>
+            <pc:sldMk cId="1006154732" sldId="589"/>
+            <ac:spMk id="3" creationId="{EEA49EAD-CBA0-9AEE-A605-C46EDD67894B}"/>
+          </ac:spMkLst>
+        </pc:spChg>
+        <pc:spChg chg="del">
+          <ac:chgData name="Vempi Satriya" userId="c28fa87cdebdc656" providerId="LiveId" clId="{63E91B12-6D81-43DC-90EF-03735CFC9BF7}" dt="2026-08-22T23:50:22.550" v="210" actId="478"/>
+          <ac:spMkLst>
+            <pc:docMk/>
+            <pc:sldMk cId="1006154732" sldId="589"/>
+            <ac:spMk id="8" creationId="{5E6A358A-31D4-26F6-4C46-C6EA7EAE4FC7}"/>
+          </ac:spMkLst>
+        </pc:spChg>
+        <pc:picChg chg="add mod modCrop">
+          <ac:chgData name="Vempi Satriya" userId="c28fa87cdebdc656" providerId="LiveId" clId="{63E91B12-6D81-43DC-90EF-03735CFC9BF7}" dt="2026-08-23T17:15:26.345" v="763" actId="1076"/>
+          <ac:picMkLst>
+            <pc:docMk/>
+            <pc:sldMk cId="1006154732" sldId="589"/>
+            <ac:picMk id="6" creationId="{E86F0DE9-87F5-DBB7-03C0-6F3AB77C07AE}"/>
+          </ac:picMkLst>
+        </pc:picChg>
+      </pc:sldChg>
+      <pc:sldChg chg="modSp add del">
+        <pc:chgData name="Vempi Satriya" userId="c28fa87cdebdc656" providerId="LiveId" clId="{63E91B12-6D81-43DC-90EF-03735CFC9BF7}" dt="2026-08-22T23:50:01.946" v="205"/>
+        <pc:sldMkLst>
+          <pc:docMk/>
+          <pc:sldMk cId="0" sldId="590"/>
+        </pc:sldMkLst>
+        <pc:spChg chg="mod">
+          <ac:chgData name="Vempi Satriya" userId="c28fa87cdebdc656" providerId="LiveId" clId="{63E91B12-6D81-43DC-90EF-03735CFC9BF7}" dt="2026-08-22T23:50:00.885" v="199"/>
+          <ac:spMkLst>
+            <pc:docMk/>
+            <pc:sldMk cId="0" sldId="590"/>
+            <ac:spMk id="8" creationId="{00000000-0000-0000-0000-000000000000}"/>
+          </ac:spMkLst>
+        </pc:spChg>
+      </pc:sldChg>
+      <pc:sldChg chg="addSp delSp modSp add mod">
+        <pc:chgData name="Vempi Satriya" userId="c28fa87cdebdc656" providerId="LiveId" clId="{63E91B12-6D81-43DC-90EF-03735CFC9BF7}" dt="2026-08-23T13:40:12.133" v="553" actId="20577"/>
+        <pc:sldMkLst>
+          <pc:docMk/>
+          <pc:sldMk cId="615690030" sldId="590"/>
+        </pc:sldMkLst>
+        <pc:spChg chg="del">
+          <ac:chgData name="Vempi Satriya" userId="c28fa87cdebdc656" providerId="LiveId" clId="{63E91B12-6D81-43DC-90EF-03735CFC9BF7}" dt="2026-08-22T23:50:36.932" v="214" actId="478"/>
+          <ac:spMkLst>
+            <pc:docMk/>
+            <pc:sldMk cId="615690030" sldId="590"/>
+            <ac:spMk id="2" creationId="{F67CF085-25AA-09E6-F18C-640C810548D7}"/>
+          </ac:spMkLst>
+        </pc:spChg>
+        <pc:spChg chg="mod">
+          <ac:chgData name="Vempi Satriya" userId="c28fa87cdebdc656" providerId="LiveId" clId="{63E91B12-6D81-43DC-90EF-03735CFC9BF7}" dt="2026-08-23T13:40:12.133" v="553" actId="20577"/>
+          <ac:spMkLst>
+            <pc:docMk/>
+            <pc:sldMk cId="615690030" sldId="590"/>
+            <ac:spMk id="3" creationId="{DC4A9550-87C0-84D2-E740-E181B25AD907}"/>
+          </ac:spMkLst>
+        </pc:spChg>
+        <pc:spChg chg="add del mod">
+          <ac:chgData name="Vempi Satriya" userId="c28fa87cdebdc656" providerId="LiveId" clId="{63E91B12-6D81-43DC-90EF-03735CFC9BF7}" dt="2026-08-22T23:50:58.501" v="224" actId="478"/>
+          <ac:spMkLst>
+            <pc:docMk/>
+            <pc:sldMk cId="615690030" sldId="590"/>
+            <ac:spMk id="6" creationId="{BDD23740-1F9E-7069-6213-8E4E1CAE084E}"/>
+          </ac:spMkLst>
+        </pc:spChg>
+        <pc:spChg chg="add mod">
+          <ac:chgData name="Vempi Satriya" userId="c28fa87cdebdc656" providerId="LiveId" clId="{63E91B12-6D81-43DC-90EF-03735CFC9BF7}" dt="2026-08-22T23:50:47.931" v="216" actId="1076"/>
+          <ac:spMkLst>
+            <pc:docMk/>
+            <pc:sldMk cId="615690030" sldId="590"/>
+            <ac:spMk id="7" creationId="{FD923F25-4D84-78D9-C169-F5606D43EE17}"/>
+          </ac:spMkLst>
+        </pc:spChg>
+        <pc:spChg chg="add mod">
+          <ac:chgData name="Vempi Satriya" userId="c28fa87cdebdc656" providerId="LiveId" clId="{63E91B12-6D81-43DC-90EF-03735CFC9BF7}" dt="2026-08-22T23:50:47.931" v="216" actId="1076"/>
+          <ac:spMkLst>
+            <pc:docMk/>
+            <pc:sldMk cId="615690030" sldId="590"/>
+            <ac:spMk id="8" creationId="{673AD48D-9FC1-7B8C-DCDE-2A07B0EDFBBD}"/>
+          </ac:spMkLst>
+        </pc:spChg>
+        <pc:spChg chg="add mod">
+          <ac:chgData name="Vempi Satriya" userId="c28fa87cdebdc656" providerId="LiveId" clId="{63E91B12-6D81-43DC-90EF-03735CFC9BF7}" dt="2026-08-22T23:50:47.931" v="216" actId="1076"/>
+          <ac:spMkLst>
+            <pc:docMk/>
+            <pc:sldMk cId="615690030" sldId="590"/>
+            <ac:spMk id="10" creationId="{22663EE3-815B-60ED-8207-7384D83F2B05}"/>
+          </ac:spMkLst>
+        </pc:spChg>
+        <pc:spChg chg="add mod">
+          <ac:chgData name="Vempi Satriya" userId="c28fa87cdebdc656" providerId="LiveId" clId="{63E91B12-6D81-43DC-90EF-03735CFC9BF7}" dt="2026-08-22T23:50:47.931" v="216" actId="1076"/>
+          <ac:spMkLst>
+            <pc:docMk/>
+            <pc:sldMk cId="615690030" sldId="590"/>
+            <ac:spMk id="12" creationId="{050BE8F1-868B-5155-B963-CECAB4A17A42}"/>
+          </ac:spMkLst>
+        </pc:spChg>
+        <pc:graphicFrameChg chg="add mod">
+          <ac:chgData name="Vempi Satriya" userId="c28fa87cdebdc656" providerId="LiveId" clId="{63E91B12-6D81-43DC-90EF-03735CFC9BF7}" dt="2026-08-22T23:50:47.931" v="216" actId="1076"/>
+          <ac:graphicFrameMkLst>
+            <pc:docMk/>
+            <pc:sldMk cId="615690030" sldId="590"/>
+            <ac:graphicFrameMk id="9" creationId="{FB0E55DF-836D-A93D-12C2-DB1630F0D64D}"/>
+          </ac:graphicFrameMkLst>
+        </pc:graphicFrameChg>
+        <pc:graphicFrameChg chg="add mod">
+          <ac:chgData name="Vempi Satriya" userId="c28fa87cdebdc656" providerId="LiveId" clId="{63E91B12-6D81-43DC-90EF-03735CFC9BF7}" dt="2026-08-22T23:50:47.931" v="216" actId="1076"/>
+          <ac:graphicFrameMkLst>
+            <pc:docMk/>
+            <pc:sldMk cId="615690030" sldId="590"/>
+            <ac:graphicFrameMk id="11" creationId="{41F688D6-1A8E-77D8-76B0-6BA8EBA324C1}"/>
+          </ac:graphicFrameMkLst>
+        </pc:graphicFrameChg>
+      </pc:sldChg>
+      <pc:sldChg chg="modSp add del mod">
+        <pc:chgData name="Vempi Satriya" userId="c28fa87cdebdc656" providerId="LiveId" clId="{63E91B12-6D81-43DC-90EF-03735CFC9BF7}" dt="2026-08-22T23:50:01.946" v="205"/>
+        <pc:sldMkLst>
+          <pc:docMk/>
+          <pc:sldMk cId="0" sldId="591"/>
+        </pc:sldMkLst>
+        <pc:spChg chg="mod">
+          <ac:chgData name="Vempi Satriya" userId="c28fa87cdebdc656" providerId="LiveId" clId="{63E91B12-6D81-43DC-90EF-03735CFC9BF7}" dt="2026-08-22T23:50:01.946" v="205"/>
+          <ac:spMkLst>
+            <pc:docMk/>
+            <pc:sldMk cId="0" sldId="591"/>
+            <ac:spMk id="3" creationId="{00000000-0000-0000-0000-000000000000}"/>
+          </ac:spMkLst>
+        </pc:spChg>
+        <pc:spChg chg="mod">
+          <ac:chgData name="Vempi Satriya" userId="c28fa87cdebdc656" providerId="LiveId" clId="{63E91B12-6D81-43DC-90EF-03735CFC9BF7}" dt="2026-08-22T23:50:00.885" v="199"/>
+          <ac:spMkLst>
+            <pc:docMk/>
+            <pc:sldMk cId="0" sldId="591"/>
+            <ac:spMk id="7" creationId="{00000000-0000-0000-0000-000000000000}"/>
+          </ac:spMkLst>
+        </pc:spChg>
+      </pc:sldChg>
+      <pc:sldChg chg="add del">
+        <pc:chgData name="Vempi Satriya" userId="c28fa87cdebdc656" providerId="LiveId" clId="{63E91B12-6D81-43DC-90EF-03735CFC9BF7}" dt="2026-08-22T23:51:36.594" v="233" actId="2890"/>
+        <pc:sldMkLst>
+          <pc:docMk/>
+          <pc:sldMk cId="1244411423" sldId="591"/>
+        </pc:sldMkLst>
+      </pc:sldChg>
+      <pc:sldChg chg="addSp delSp modSp add mod">
+        <pc:chgData name="Vempi Satriya" userId="c28fa87cdebdc656" providerId="LiveId" clId="{63E91B12-6D81-43DC-90EF-03735CFC9BF7}" dt="2026-08-23T13:40:16.692" v="554"/>
+        <pc:sldMkLst>
+          <pc:docMk/>
+          <pc:sldMk cId="1412388728" sldId="591"/>
+        </pc:sldMkLst>
+        <pc:spChg chg="add mod">
+          <ac:chgData name="Vempi Satriya" userId="c28fa87cdebdc656" providerId="LiveId" clId="{63E91B12-6D81-43DC-90EF-03735CFC9BF7}" dt="2026-08-22T23:52:13.874" v="248"/>
+          <ac:spMkLst>
+            <pc:docMk/>
+            <pc:sldMk cId="1412388728" sldId="591"/>
+            <ac:spMk id="2" creationId="{00000000-0000-0000-0000-000000000000}"/>
+          </ac:spMkLst>
+        </pc:spChg>
+        <pc:spChg chg="mod">
+          <ac:chgData name="Vempi Satriya" userId="c28fa87cdebdc656" providerId="LiveId" clId="{63E91B12-6D81-43DC-90EF-03735CFC9BF7}" dt="2026-08-23T13:40:16.692" v="554"/>
+          <ac:spMkLst>
+            <pc:docMk/>
+            <pc:sldMk cId="1412388728" sldId="591"/>
+            <ac:spMk id="3" creationId="{3B8AC9D3-6622-159C-EA42-71C8C9D5916B}"/>
+          </ac:spMkLst>
+        </pc:spChg>
+        <pc:spChg chg="add mod">
+          <ac:chgData name="Vempi Satriya" userId="c28fa87cdebdc656" providerId="LiveId" clId="{63E91B12-6D81-43DC-90EF-03735CFC9BF7}" dt="2026-08-22T23:52:38.500" v="258" actId="1076"/>
+          <ac:spMkLst>
+            <pc:docMk/>
+            <pc:sldMk cId="1412388728" sldId="591"/>
+            <ac:spMk id="5" creationId="{6F819190-BA0E-5055-B438-C64475B63DA5}"/>
+          </ac:spMkLst>
+        </pc:spChg>
+        <pc:spChg chg="del">
+          <ac:chgData name="Vempi Satriya" userId="c28fa87cdebdc656" providerId="LiveId" clId="{63E91B12-6D81-43DC-90EF-03735CFC9BF7}" dt="2026-08-22T23:52:10.362" v="242" actId="478"/>
+          <ac:spMkLst>
+            <pc:docMk/>
+            <pc:sldMk cId="1412388728" sldId="591"/>
+            <ac:spMk id="7" creationId="{BADA7269-545C-E382-92A9-D47589FA0AB0}"/>
+          </ac:spMkLst>
+        </pc:spChg>
+        <pc:graphicFrameChg chg="add mod">
+          <ac:chgData name="Vempi Satriya" userId="c28fa87cdebdc656" providerId="LiveId" clId="{63E91B12-6D81-43DC-90EF-03735CFC9BF7}" dt="2026-08-22T23:52:40.580" v="259" actId="1076"/>
+          <ac:graphicFrameMkLst>
+            <pc:docMk/>
+            <pc:sldMk cId="1412388728" sldId="591"/>
+            <ac:graphicFrameMk id="6" creationId="{27D58C6D-832F-BC6B-9060-0404F32F0C59}"/>
+          </ac:graphicFrameMkLst>
+        </pc:graphicFrameChg>
+        <pc:graphicFrameChg chg="del">
+          <ac:chgData name="Vempi Satriya" userId="c28fa87cdebdc656" providerId="LiveId" clId="{63E91B12-6D81-43DC-90EF-03735CFC9BF7}" dt="2026-08-22T23:52:10.362" v="242" actId="478"/>
+          <ac:graphicFrameMkLst>
+            <pc:docMk/>
+            <pc:sldMk cId="1412388728" sldId="591"/>
+            <ac:graphicFrameMk id="9" creationId="{0C7B07DF-D317-6063-0DAD-683D028AEEBD}"/>
+          </ac:graphicFrameMkLst>
+        </pc:graphicFrameChg>
+        <pc:graphicFrameChg chg="del">
+          <ac:chgData name="Vempi Satriya" userId="c28fa87cdebdc656" providerId="LiveId" clId="{63E91B12-6D81-43DC-90EF-03735CFC9BF7}" dt="2026-08-22T23:52:10.362" v="242" actId="478"/>
+          <ac:graphicFrameMkLst>
+            <pc:docMk/>
+            <pc:sldMk cId="1412388728" sldId="591"/>
+            <ac:graphicFrameMk id="11" creationId="{9B4E55C6-EFA9-FA6B-EBA3-B139439CA0AA}"/>
+          </ac:graphicFrameMkLst>
+        </pc:graphicFrameChg>
+        <pc:graphicFrameChg chg="add mod">
+          <ac:chgData name="Vempi Satriya" userId="c28fa87cdebdc656" providerId="LiveId" clId="{63E91B12-6D81-43DC-90EF-03735CFC9BF7}" dt="2026-08-22T23:52:13.375" v="246" actId="1076"/>
+          <ac:graphicFrameMkLst>
+            <pc:docMk/>
+            <pc:sldMk cId="1412388728" sldId="591"/>
+            <ac:graphicFrameMk id="17409" creationId="{00000000-0000-0000-0000-000000000000}"/>
+          </ac:graphicFrameMkLst>
+        </pc:graphicFrameChg>
+      </pc:sldChg>
+      <pc:sldChg chg="addSp delSp modSp add del mod">
+        <pc:chgData name="Vempi Satriya" userId="c28fa87cdebdc656" providerId="LiveId" clId="{63E91B12-6D81-43DC-90EF-03735CFC9BF7}" dt="2026-08-22T23:51:41.229" v="235" actId="47"/>
+        <pc:sldMkLst>
+          <pc:docMk/>
+          <pc:sldMk cId="1865317046" sldId="591"/>
+        </pc:sldMkLst>
+        <pc:spChg chg="add mod">
+          <ac:chgData name="Vempi Satriya" userId="c28fa87cdebdc656" providerId="LiveId" clId="{63E91B12-6D81-43DC-90EF-03735CFC9BF7}" dt="2026-08-22T23:51:27.078" v="230" actId="1076"/>
+          <ac:spMkLst>
+            <pc:docMk/>
+            <pc:sldMk cId="1865317046" sldId="591"/>
+            <ac:spMk id="2" creationId="{00000000-0000-0000-0000-000000000000}"/>
+          </ac:spMkLst>
+        </pc:spChg>
+        <pc:spChg chg="del">
+          <ac:chgData name="Vempi Satriya" userId="c28fa87cdebdc656" providerId="LiveId" clId="{63E91B12-6D81-43DC-90EF-03735CFC9BF7}" dt="2026-08-22T23:51:19.401" v="227" actId="478"/>
+          <ac:spMkLst>
+            <pc:docMk/>
+            <pc:sldMk cId="1865317046" sldId="591"/>
+            <ac:spMk id="7" creationId="{337DCB6C-337A-9045-A4DB-77861984951B}"/>
+          </ac:spMkLst>
+        </pc:spChg>
+        <pc:graphicFrameChg chg="del">
+          <ac:chgData name="Vempi Satriya" userId="c28fa87cdebdc656" providerId="LiveId" clId="{63E91B12-6D81-43DC-90EF-03735CFC9BF7}" dt="2026-08-22T23:51:22.225" v="228" actId="478"/>
+          <ac:graphicFrameMkLst>
+            <pc:docMk/>
+            <pc:sldMk cId="1865317046" sldId="591"/>
+            <ac:graphicFrameMk id="9" creationId="{9DC228D4-A581-C658-7F8E-9DD070918553}"/>
+          </ac:graphicFrameMkLst>
+        </pc:graphicFrameChg>
+        <pc:graphicFrameChg chg="del">
+          <ac:chgData name="Vempi Satriya" userId="c28fa87cdebdc656" providerId="LiveId" clId="{63E91B12-6D81-43DC-90EF-03735CFC9BF7}" dt="2026-08-22T23:51:22.225" v="228" actId="478"/>
+          <ac:graphicFrameMkLst>
+            <pc:docMk/>
+            <pc:sldMk cId="1865317046" sldId="591"/>
+            <ac:graphicFrameMk id="11" creationId="{AE6DE0CD-5995-382A-53BD-0573339C710C}"/>
+          </ac:graphicFrameMkLst>
+        </pc:graphicFrameChg>
+        <pc:graphicFrameChg chg="add mod">
+          <ac:chgData name="Vempi Satriya" userId="c28fa87cdebdc656" providerId="LiveId" clId="{63E91B12-6D81-43DC-90EF-03735CFC9BF7}" dt="2026-08-22T23:51:27.078" v="230" actId="1076"/>
+          <ac:graphicFrameMkLst>
+            <pc:docMk/>
+            <pc:sldMk cId="1865317046" sldId="591"/>
+            <ac:graphicFrameMk id="1025" creationId="{00000000-0000-0000-0000-000000000000}"/>
+          </ac:graphicFrameMkLst>
+        </pc:graphicFrameChg>
+        <pc:graphicFrameChg chg="add mod">
+          <ac:chgData name="Vempi Satriya" userId="c28fa87cdebdc656" providerId="LiveId" clId="{63E91B12-6D81-43DC-90EF-03735CFC9BF7}" dt="2026-08-22T23:51:27.078" v="230" actId="1076"/>
+          <ac:graphicFrameMkLst>
+            <pc:docMk/>
+            <pc:sldMk cId="1865317046" sldId="591"/>
+            <ac:graphicFrameMk id="1027" creationId="{00000000-0000-0000-0000-000000000000}"/>
+          </ac:graphicFrameMkLst>
+        </pc:graphicFrameChg>
+      </pc:sldChg>
+      <pc:sldChg chg="modSp add del">
+        <pc:chgData name="Vempi Satriya" userId="c28fa87cdebdc656" providerId="LiveId" clId="{63E91B12-6D81-43DC-90EF-03735CFC9BF7}" dt="2026-08-22T23:50:01.946" v="205"/>
+        <pc:sldMkLst>
+          <pc:docMk/>
+          <pc:sldMk cId="0" sldId="592"/>
+        </pc:sldMkLst>
+        <pc:spChg chg="mod">
+          <ac:chgData name="Vempi Satriya" userId="c28fa87cdebdc656" providerId="LiveId" clId="{63E91B12-6D81-43DC-90EF-03735CFC9BF7}" dt="2026-08-22T23:50:00.885" v="199"/>
+          <ac:spMkLst>
+            <pc:docMk/>
+            <pc:sldMk cId="0" sldId="592"/>
+            <ac:spMk id="4" creationId="{00000000-0000-0000-0000-000000000000}"/>
+          </ac:spMkLst>
+        </pc:spChg>
+      </pc:sldChg>
+      <pc:sldChg chg="addSp delSp modSp add mod">
+        <pc:chgData name="Vempi Satriya" userId="c28fa87cdebdc656" providerId="LiveId" clId="{63E91B12-6D81-43DC-90EF-03735CFC9BF7}" dt="2026-08-23T17:18:12.144" v="793" actId="14100"/>
+        <pc:sldMkLst>
+          <pc:docMk/>
+          <pc:sldMk cId="2270252074" sldId="592"/>
+        </pc:sldMkLst>
+        <pc:spChg chg="add mod">
+          <ac:chgData name="Vempi Satriya" userId="c28fa87cdebdc656" providerId="LiveId" clId="{63E91B12-6D81-43DC-90EF-03735CFC9BF7}" dt="2026-08-23T17:18:12.144" v="793" actId="14100"/>
+          <ac:spMkLst>
+            <pc:docMk/>
+            <pc:sldMk cId="2270252074" sldId="592"/>
+            <ac:spMk id="2" creationId="{1E5EC3FB-CE26-4A92-4FCD-3CDAF9D518EF}"/>
+          </ac:spMkLst>
+        </pc:spChg>
+        <pc:spChg chg="del">
+          <ac:chgData name="Vempi Satriya" userId="c28fa87cdebdc656" providerId="LiveId" clId="{63E91B12-6D81-43DC-90EF-03735CFC9BF7}" dt="2026-08-22T23:52:56.814" v="263" actId="478"/>
+          <ac:spMkLst>
+            <pc:docMk/>
+            <pc:sldMk cId="2270252074" sldId="592"/>
+            <ac:spMk id="2" creationId="{CFD336C3-B0A1-F3CF-BFBD-B80B94C11744}"/>
+          </ac:spMkLst>
+        </pc:spChg>
+        <pc:spChg chg="mod">
+          <ac:chgData name="Vempi Satriya" userId="c28fa87cdebdc656" providerId="LiveId" clId="{63E91B12-6D81-43DC-90EF-03735CFC9BF7}" dt="2026-08-23T13:40:34.964" v="607" actId="20577"/>
+          <ac:spMkLst>
+            <pc:docMk/>
+            <pc:sldMk cId="2270252074" sldId="592"/>
+            <ac:spMk id="3" creationId="{2C71BF47-0B49-3568-742F-95C4E39B7641}"/>
+          </ac:spMkLst>
+        </pc:spChg>
+        <pc:spChg chg="add del mod">
+          <ac:chgData name="Vempi Satriya" userId="c28fa87cdebdc656" providerId="LiveId" clId="{63E91B12-6D81-43DC-90EF-03735CFC9BF7}" dt="2026-08-22T23:53:08.529" v="269" actId="478"/>
+          <ac:spMkLst>
+            <pc:docMk/>
+            <pc:sldMk cId="2270252074" sldId="592"/>
+            <ac:spMk id="6" creationId="{63072F6E-5CC3-E383-1378-4BFEAF5E7926}"/>
+          </ac:spMkLst>
+        </pc:spChg>
+        <pc:spChg chg="add mod">
+          <ac:chgData name="Vempi Satriya" userId="c28fa87cdebdc656" providerId="LiveId" clId="{63E91B12-6D81-43DC-90EF-03735CFC9BF7}" dt="2026-08-23T17:18:04.753" v="791" actId="1076"/>
+          <ac:spMkLst>
+            <pc:docMk/>
+            <pc:sldMk cId="2270252074" sldId="592"/>
+            <ac:spMk id="7" creationId="{00000000-0000-0000-0000-000000000000}"/>
+          </ac:spMkLst>
+        </pc:spChg>
+      </pc:sldChg>
+      <pc:sldChg chg="modSp add del">
+        <pc:chgData name="Vempi Satriya" userId="c28fa87cdebdc656" providerId="LiveId" clId="{63E91B12-6D81-43DC-90EF-03735CFC9BF7}" dt="2026-08-22T23:50:01.946" v="205"/>
+        <pc:sldMkLst>
+          <pc:docMk/>
+          <pc:sldMk cId="0" sldId="593"/>
+        </pc:sldMkLst>
+        <pc:spChg chg="mod">
+          <ac:chgData name="Vempi Satriya" userId="c28fa87cdebdc656" providerId="LiveId" clId="{63E91B12-6D81-43DC-90EF-03735CFC9BF7}" dt="2026-08-22T23:50:00.885" v="199"/>
+          <ac:spMkLst>
+            <pc:docMk/>
+            <pc:sldMk cId="0" sldId="593"/>
+            <ac:spMk id="32" creationId="{00000000-0000-0000-0000-000000000000}"/>
+          </ac:spMkLst>
+        </pc:spChg>
+      </pc:sldChg>
+      <pc:sldChg chg="addSp delSp modSp add mod">
+        <pc:chgData name="Vempi Satriya" userId="c28fa87cdebdc656" providerId="LiveId" clId="{63E91B12-6D81-43DC-90EF-03735CFC9BF7}" dt="2026-08-23T13:40:47.378" v="609" actId="1076"/>
+        <pc:sldMkLst>
+          <pc:docMk/>
+          <pc:sldMk cId="2700428872" sldId="593"/>
+        </pc:sldMkLst>
+        <pc:spChg chg="add mod">
+          <ac:chgData name="Vempi Satriya" userId="c28fa87cdebdc656" providerId="LiveId" clId="{63E91B12-6D81-43DC-90EF-03735CFC9BF7}" dt="2026-08-22T23:53:51.160" v="282" actId="20577"/>
+          <ac:spMkLst>
+            <pc:docMk/>
+            <pc:sldMk cId="2700428872" sldId="593"/>
+            <ac:spMk id="2" creationId="{00000000-0000-0000-0000-000000000000}"/>
+          </ac:spMkLst>
+        </pc:spChg>
+        <pc:spChg chg="mod">
+          <ac:chgData name="Vempi Satriya" userId="c28fa87cdebdc656" providerId="LiveId" clId="{63E91B12-6D81-43DC-90EF-03735CFC9BF7}" dt="2026-08-23T13:40:42.046" v="608"/>
+          <ac:spMkLst>
+            <pc:docMk/>
+            <pc:sldMk cId="2700428872" sldId="593"/>
+            <ac:spMk id="3" creationId="{5581F822-9578-8B71-BB1B-EB48ED9DDCCF}"/>
+          </ac:spMkLst>
+        </pc:spChg>
+        <pc:spChg chg="del">
+          <ac:chgData name="Vempi Satriya" userId="c28fa87cdebdc656" providerId="LiveId" clId="{63E91B12-6D81-43DC-90EF-03735CFC9BF7}" dt="2026-08-22T23:53:20.409" v="272" actId="478"/>
+          <ac:spMkLst>
+            <pc:docMk/>
+            <pc:sldMk cId="2700428872" sldId="593"/>
+            <ac:spMk id="7" creationId="{BB21FC73-1DC7-B96C-E980-39F233157D31}"/>
+          </ac:spMkLst>
+        </pc:spChg>
+        <pc:spChg chg="add mod">
+          <ac:chgData name="Vempi Satriya" userId="c28fa87cdebdc656" providerId="LiveId" clId="{63E91B12-6D81-43DC-90EF-03735CFC9BF7}" dt="2026-08-22T23:54:01.657" v="287" actId="20577"/>
+          <ac:spMkLst>
+            <pc:docMk/>
+            <pc:sldMk cId="2700428872" sldId="593"/>
+            <ac:spMk id="11" creationId="{62E9178E-B981-C094-EEED-90B408418064}"/>
+          </ac:spMkLst>
+        </pc:spChg>
+        <pc:spChg chg="add mod">
+          <ac:chgData name="Vempi Satriya" userId="c28fa87cdebdc656" providerId="LiveId" clId="{63E91B12-6D81-43DC-90EF-03735CFC9BF7}" dt="2026-08-23T13:40:47.378" v="609" actId="1076"/>
+          <ac:spMkLst>
+            <pc:docMk/>
+            <pc:sldMk cId="2700428872" sldId="593"/>
+            <ac:spMk id="14" creationId="{00000000-0000-0000-0000-000000000000}"/>
+          </ac:spMkLst>
+        </pc:spChg>
+        <pc:spChg chg="add mod">
+          <ac:chgData name="Vempi Satriya" userId="c28fa87cdebdc656" providerId="LiveId" clId="{63E91B12-6D81-43DC-90EF-03735CFC9BF7}" dt="2026-08-23T13:40:47.378" v="609" actId="1076"/>
+          <ac:spMkLst>
+            <pc:docMk/>
+            <pc:sldMk cId="2700428872" sldId="593"/>
+            <ac:spMk id="17" creationId="{00000000-0000-0000-0000-000000000000}"/>
+          </ac:spMkLst>
+        </pc:spChg>
+        <pc:spChg chg="add mod">
+          <ac:chgData name="Vempi Satriya" userId="c28fa87cdebdc656" providerId="LiveId" clId="{63E91B12-6D81-43DC-90EF-03735CFC9BF7}" dt="2026-08-23T13:40:47.378" v="609" actId="1076"/>
+          <ac:spMkLst>
+            <pc:docMk/>
+            <pc:sldMk cId="2700428872" sldId="593"/>
+            <ac:spMk id="26" creationId="{00000000-0000-0000-0000-000000000000}"/>
+          </ac:spMkLst>
+        </pc:spChg>
+        <pc:spChg chg="add mod">
+          <ac:chgData name="Vempi Satriya" userId="c28fa87cdebdc656" providerId="LiveId" clId="{63E91B12-6D81-43DC-90EF-03735CFC9BF7}" dt="2026-08-23T13:40:47.378" v="609" actId="1076"/>
+          <ac:spMkLst>
+            <pc:docMk/>
+            <pc:sldMk cId="2700428872" sldId="593"/>
+            <ac:spMk id="27" creationId="{00000000-0000-0000-0000-000000000000}"/>
+          </ac:spMkLst>
+        </pc:spChg>
+        <pc:spChg chg="add mod">
+          <ac:chgData name="Vempi Satriya" userId="c28fa87cdebdc656" providerId="LiveId" clId="{63E91B12-6D81-43DC-90EF-03735CFC9BF7}" dt="2026-08-23T13:40:47.378" v="609" actId="1076"/>
+          <ac:spMkLst>
+            <pc:docMk/>
+            <pc:sldMk cId="2700428872" sldId="593"/>
+            <ac:spMk id="28" creationId="{00000000-0000-0000-0000-000000000000}"/>
+          </ac:spMkLst>
+        </pc:spChg>
+        <pc:cxnChg chg="add mod">
+          <ac:chgData name="Vempi Satriya" userId="c28fa87cdebdc656" providerId="LiveId" clId="{63E91B12-6D81-43DC-90EF-03735CFC9BF7}" dt="2026-08-23T13:40:47.378" v="609" actId="1076"/>
+          <ac:cxnSpMkLst>
+            <pc:docMk/>
+            <pc:sldMk cId="2700428872" sldId="593"/>
+            <ac:cxnSpMk id="5" creationId="{00000000-0000-0000-0000-000000000000}"/>
+          </ac:cxnSpMkLst>
+        </pc:cxnChg>
+        <pc:cxnChg chg="add mod">
+          <ac:chgData name="Vempi Satriya" userId="c28fa87cdebdc656" providerId="LiveId" clId="{63E91B12-6D81-43DC-90EF-03735CFC9BF7}" dt="2026-08-23T13:40:47.378" v="609" actId="1076"/>
+          <ac:cxnSpMkLst>
+            <pc:docMk/>
+            <pc:sldMk cId="2700428872" sldId="593"/>
+            <ac:cxnSpMk id="24" creationId="{00000000-0000-0000-0000-000000000000}"/>
+          </ac:cxnSpMkLst>
+        </pc:cxnChg>
+        <pc:cxnChg chg="add mod">
+          <ac:chgData name="Vempi Satriya" userId="c28fa87cdebdc656" providerId="LiveId" clId="{63E91B12-6D81-43DC-90EF-03735CFC9BF7}" dt="2026-08-23T13:40:47.378" v="609" actId="1076"/>
+          <ac:cxnSpMkLst>
+            <pc:docMk/>
+            <pc:sldMk cId="2700428872" sldId="593"/>
+            <ac:cxnSpMk id="25" creationId="{00000000-0000-0000-0000-000000000000}"/>
+          </ac:cxnSpMkLst>
+        </pc:cxnChg>
+        <pc:cxnChg chg="add mod">
+          <ac:chgData name="Vempi Satriya" userId="c28fa87cdebdc656" providerId="LiveId" clId="{63E91B12-6D81-43DC-90EF-03735CFC9BF7}" dt="2026-08-23T13:40:47.378" v="609" actId="1076"/>
+          <ac:cxnSpMkLst>
+            <pc:docMk/>
+            <pc:sldMk cId="2700428872" sldId="593"/>
+            <ac:cxnSpMk id="30" creationId="{00000000-0000-0000-0000-000000000000}"/>
+          </ac:cxnSpMkLst>
+        </pc:cxnChg>
+      </pc:sldChg>
+      <pc:sldChg chg="modSp add del">
+        <pc:chgData name="Vempi Satriya" userId="c28fa87cdebdc656" providerId="LiveId" clId="{63E91B12-6D81-43DC-90EF-03735CFC9BF7}" dt="2026-08-22T23:50:01.946" v="205"/>
+        <pc:sldMkLst>
+          <pc:docMk/>
+          <pc:sldMk cId="0" sldId="594"/>
+        </pc:sldMkLst>
+        <pc:spChg chg="mod">
+          <ac:chgData name="Vempi Satriya" userId="c28fa87cdebdc656" providerId="LiveId" clId="{63E91B12-6D81-43DC-90EF-03735CFC9BF7}" dt="2026-08-22T23:50:00.885" v="199"/>
+          <ac:spMkLst>
+            <pc:docMk/>
+            <pc:sldMk cId="0" sldId="594"/>
+            <ac:spMk id="4" creationId="{00000000-0000-0000-0000-000000000000}"/>
+          </ac:spMkLst>
+        </pc:spChg>
+      </pc:sldChg>
+      <pc:sldChg chg="addSp delSp modSp add mod">
+        <pc:chgData name="Vempi Satriya" userId="c28fa87cdebdc656" providerId="LiveId" clId="{63E91B12-6D81-43DC-90EF-03735CFC9BF7}" dt="2026-08-23T13:41:16.840" v="633" actId="20577"/>
+        <pc:sldMkLst>
+          <pc:docMk/>
+          <pc:sldMk cId="3771053046" sldId="594"/>
+        </pc:sldMkLst>
+        <pc:spChg chg="del">
+          <ac:chgData name="Vempi Satriya" userId="c28fa87cdebdc656" providerId="LiveId" clId="{63E91B12-6D81-43DC-90EF-03735CFC9BF7}" dt="2026-08-22T23:54:22.930" v="292" actId="478"/>
+          <ac:spMkLst>
+            <pc:docMk/>
+            <pc:sldMk cId="3771053046" sldId="594"/>
+            <ac:spMk id="2" creationId="{59475B97-131F-F6F2-490A-46FCD5690A2F}"/>
+          </ac:spMkLst>
+        </pc:spChg>
+        <pc:spChg chg="mod">
+          <ac:chgData name="Vempi Satriya" userId="c28fa87cdebdc656" providerId="LiveId" clId="{63E91B12-6D81-43DC-90EF-03735CFC9BF7}" dt="2026-08-23T13:41:16.840" v="633" actId="20577"/>
+          <ac:spMkLst>
+            <pc:docMk/>
+            <pc:sldMk cId="3771053046" sldId="594"/>
+            <ac:spMk id="3" creationId="{EB09C404-2ECA-4BE4-74C2-B8761E84D6D0}"/>
+          </ac:spMkLst>
+        </pc:spChg>
+        <pc:spChg chg="add del mod">
+          <ac:chgData name="Vempi Satriya" userId="c28fa87cdebdc656" providerId="LiveId" clId="{63E91B12-6D81-43DC-90EF-03735CFC9BF7}" dt="2026-08-22T23:54:25.029" v="293" actId="478"/>
+          <ac:spMkLst>
+            <pc:docMk/>
+            <pc:sldMk cId="3771053046" sldId="594"/>
+            <ac:spMk id="7" creationId="{4E74A16A-5194-986F-CFE5-39C3B033B8D0}"/>
+          </ac:spMkLst>
+        </pc:spChg>
+        <pc:spChg chg="add mod">
+          <ac:chgData name="Vempi Satriya" userId="c28fa87cdebdc656" providerId="LiveId" clId="{63E91B12-6D81-43DC-90EF-03735CFC9BF7}" dt="2026-08-23T13:41:03.142" v="613" actId="113"/>
+          <ac:spMkLst>
+            <pc:docMk/>
+            <pc:sldMk cId="3771053046" sldId="594"/>
+            <ac:spMk id="8" creationId="{00000000-0000-0000-0000-000000000000}"/>
+          </ac:spMkLst>
+        </pc:spChg>
+        <pc:spChg chg="del">
+          <ac:chgData name="Vempi Satriya" userId="c28fa87cdebdc656" providerId="LiveId" clId="{63E91B12-6D81-43DC-90EF-03735CFC9BF7}" dt="2026-08-22T23:54:22.930" v="292" actId="478"/>
+          <ac:spMkLst>
+            <pc:docMk/>
+            <pc:sldMk cId="3771053046" sldId="594"/>
+            <ac:spMk id="11" creationId="{6CC7CA86-959D-1F8E-A41F-45A391CAA116}"/>
+          </ac:spMkLst>
+        </pc:spChg>
+        <pc:spChg chg="del">
+          <ac:chgData name="Vempi Satriya" userId="c28fa87cdebdc656" providerId="LiveId" clId="{63E91B12-6D81-43DC-90EF-03735CFC9BF7}" dt="2026-08-22T23:54:19.701" v="291" actId="478"/>
+          <ac:spMkLst>
+            <pc:docMk/>
+            <pc:sldMk cId="3771053046" sldId="594"/>
+            <ac:spMk id="14" creationId="{182E1A43-DD79-A9E6-DA46-39444A7B8995}"/>
+          </ac:spMkLst>
+        </pc:spChg>
+        <pc:spChg chg="del">
+          <ac:chgData name="Vempi Satriya" userId="c28fa87cdebdc656" providerId="LiveId" clId="{63E91B12-6D81-43DC-90EF-03735CFC9BF7}" dt="2026-08-22T23:54:19.701" v="291" actId="478"/>
+          <ac:spMkLst>
+            <pc:docMk/>
+            <pc:sldMk cId="3771053046" sldId="594"/>
+            <ac:spMk id="17" creationId="{97ADB963-2A17-2596-C74A-7DE6444B30C0}"/>
+          </ac:spMkLst>
+        </pc:spChg>
+        <pc:spChg chg="del">
+          <ac:chgData name="Vempi Satriya" userId="c28fa87cdebdc656" providerId="LiveId" clId="{63E91B12-6D81-43DC-90EF-03735CFC9BF7}" dt="2026-08-22T23:54:19.701" v="291" actId="478"/>
+          <ac:spMkLst>
+            <pc:docMk/>
+            <pc:sldMk cId="3771053046" sldId="594"/>
+            <ac:spMk id="26" creationId="{27D0C225-1A26-3CB3-366D-DCABA4967CBB}"/>
+          </ac:spMkLst>
+        </pc:spChg>
+        <pc:spChg chg="del">
+          <ac:chgData name="Vempi Satriya" userId="c28fa87cdebdc656" providerId="LiveId" clId="{63E91B12-6D81-43DC-90EF-03735CFC9BF7}" dt="2026-08-22T23:54:19.701" v="291" actId="478"/>
+          <ac:spMkLst>
+            <pc:docMk/>
+            <pc:sldMk cId="3771053046" sldId="594"/>
+            <ac:spMk id="27" creationId="{94A42EF7-CA49-3532-5652-5D40AE5191C6}"/>
+          </ac:spMkLst>
+        </pc:spChg>
+        <pc:spChg chg="del">
+          <ac:chgData name="Vempi Satriya" userId="c28fa87cdebdc656" providerId="LiveId" clId="{63E91B12-6D81-43DC-90EF-03735CFC9BF7}" dt="2026-08-22T23:54:19.701" v="291" actId="478"/>
+          <ac:spMkLst>
+            <pc:docMk/>
+            <pc:sldMk cId="3771053046" sldId="594"/>
+            <ac:spMk id="28" creationId="{0BE7AA15-5501-52C1-FD12-90317CB3119C}"/>
+          </ac:spMkLst>
+        </pc:spChg>
+        <pc:cxnChg chg="del">
+          <ac:chgData name="Vempi Satriya" userId="c28fa87cdebdc656" providerId="LiveId" clId="{63E91B12-6D81-43DC-90EF-03735CFC9BF7}" dt="2026-08-22T23:54:19.701" v="291" actId="478"/>
+          <ac:cxnSpMkLst>
+            <pc:docMk/>
+            <pc:sldMk cId="3771053046" sldId="594"/>
+            <ac:cxnSpMk id="5" creationId="{78C124D9-A025-6C44-52AF-A39DC3BE334B}"/>
+          </ac:cxnSpMkLst>
+        </pc:cxnChg>
+        <pc:cxnChg chg="del">
+          <ac:chgData name="Vempi Satriya" userId="c28fa87cdebdc656" providerId="LiveId" clId="{63E91B12-6D81-43DC-90EF-03735CFC9BF7}" dt="2026-08-22T23:54:19.701" v="291" actId="478"/>
+          <ac:cxnSpMkLst>
+            <pc:docMk/>
+            <pc:sldMk cId="3771053046" sldId="594"/>
+            <ac:cxnSpMk id="24" creationId="{135087CB-356A-B66B-FE0F-70A2D4037F1B}"/>
+          </ac:cxnSpMkLst>
+        </pc:cxnChg>
+        <pc:cxnChg chg="del">
+          <ac:chgData name="Vempi Satriya" userId="c28fa87cdebdc656" providerId="LiveId" clId="{63E91B12-6D81-43DC-90EF-03735CFC9BF7}" dt="2026-08-22T23:54:19.701" v="291" actId="478"/>
+          <ac:cxnSpMkLst>
+            <pc:docMk/>
+            <pc:sldMk cId="3771053046" sldId="594"/>
+            <ac:cxnSpMk id="25" creationId="{CF9484B8-28D2-75F0-6B80-259C0C1E6BE4}"/>
+          </ac:cxnSpMkLst>
+        </pc:cxnChg>
+        <pc:cxnChg chg="del">
+          <ac:chgData name="Vempi Satriya" userId="c28fa87cdebdc656" providerId="LiveId" clId="{63E91B12-6D81-43DC-90EF-03735CFC9BF7}" dt="2026-08-22T23:54:19.701" v="291" actId="478"/>
+          <ac:cxnSpMkLst>
+            <pc:docMk/>
+            <pc:sldMk cId="3771053046" sldId="594"/>
+            <ac:cxnSpMk id="30" creationId="{61B42C3D-12DF-496D-3301-97FD8F1AE900}"/>
+          </ac:cxnSpMkLst>
+        </pc:cxnChg>
+      </pc:sldChg>
+      <pc:sldChg chg="modSp add del">
+        <pc:chgData name="Vempi Satriya" userId="c28fa87cdebdc656" providerId="LiveId" clId="{63E91B12-6D81-43DC-90EF-03735CFC9BF7}" dt="2026-08-22T23:50:01.946" v="205"/>
+        <pc:sldMkLst>
+          <pc:docMk/>
+          <pc:sldMk cId="0" sldId="595"/>
+        </pc:sldMkLst>
+        <pc:spChg chg="mod">
+          <ac:chgData name="Vempi Satriya" userId="c28fa87cdebdc656" providerId="LiveId" clId="{63E91B12-6D81-43DC-90EF-03735CFC9BF7}" dt="2026-08-22T23:50:00.885" v="199"/>
+          <ac:spMkLst>
+            <pc:docMk/>
+            <pc:sldMk cId="0" sldId="595"/>
+            <ac:spMk id="9" creationId="{00000000-0000-0000-0000-000000000000}"/>
+          </ac:spMkLst>
+        </pc:spChg>
+      </pc:sldChg>
+      <pc:sldChg chg="addSp delSp modSp add mod">
+        <pc:chgData name="Vempi Satriya" userId="c28fa87cdebdc656" providerId="LiveId" clId="{63E91B12-6D81-43DC-90EF-03735CFC9BF7}" dt="2026-08-23T13:41:35.493" v="635" actId="207"/>
+        <pc:sldMkLst>
+          <pc:docMk/>
+          <pc:sldMk cId="794159262" sldId="595"/>
+        </pc:sldMkLst>
+        <pc:spChg chg="mod">
+          <ac:chgData name="Vempi Satriya" userId="c28fa87cdebdc656" providerId="LiveId" clId="{63E91B12-6D81-43DC-90EF-03735CFC9BF7}" dt="2026-08-23T13:41:35.493" v="635" actId="207"/>
+          <ac:spMkLst>
+            <pc:docMk/>
+            <pc:sldMk cId="794159262" sldId="595"/>
+            <ac:spMk id="3" creationId="{B9C3F354-D6D0-2772-0BEC-AF668D4A74ED}"/>
+          </ac:spMkLst>
+        </pc:spChg>
+        <pc:spChg chg="add del mod">
+          <ac:chgData name="Vempi Satriya" userId="c28fa87cdebdc656" providerId="LiveId" clId="{63E91B12-6D81-43DC-90EF-03735CFC9BF7}" dt="2026-08-22T23:55:15.312" v="310" actId="478"/>
+          <ac:spMkLst>
+            <pc:docMk/>
+            <pc:sldMk cId="794159262" sldId="595"/>
+            <ac:spMk id="5" creationId="{397DF05A-BD2C-AB25-D1BA-A11207F0812E}"/>
+          </ac:spMkLst>
+        </pc:spChg>
+        <pc:spChg chg="del">
+          <ac:chgData name="Vempi Satriya" userId="c28fa87cdebdc656" providerId="LiveId" clId="{63E91B12-6D81-43DC-90EF-03735CFC9BF7}" dt="2026-08-22T23:55:13.062" v="309" actId="478"/>
+          <ac:spMkLst>
+            <pc:docMk/>
+            <pc:sldMk cId="794159262" sldId="595"/>
+            <ac:spMk id="8" creationId="{D82C7F58-79AC-EE1B-CC4A-537261861CFD}"/>
+          </ac:spMkLst>
+        </pc:spChg>
+        <pc:spChg chg="add mod">
+          <ac:chgData name="Vempi Satriya" userId="c28fa87cdebdc656" providerId="LiveId" clId="{63E91B12-6D81-43DC-90EF-03735CFC9BF7}" dt="2026-08-22T23:56:00.737" v="317" actId="12"/>
+          <ac:spMkLst>
+            <pc:docMk/>
+            <pc:sldMk cId="794159262" sldId="595"/>
+            <ac:spMk id="9" creationId="{965D6C37-36F5-6EF3-9E9D-20B63792EB63}"/>
+          </ac:spMkLst>
+        </pc:spChg>
+        <pc:graphicFrameChg chg="add mod">
+          <ac:chgData name="Vempi Satriya" userId="c28fa87cdebdc656" providerId="LiveId" clId="{63E91B12-6D81-43DC-90EF-03735CFC9BF7}" dt="2026-08-22T23:55:26.652" v="314" actId="1076"/>
+          <ac:graphicFrameMkLst>
+            <pc:docMk/>
+            <pc:sldMk cId="794159262" sldId="595"/>
+            <ac:graphicFrameMk id="7" creationId="{FD318314-557D-08C1-48C6-F2FE92DF5888}"/>
+          </ac:graphicFrameMkLst>
+        </pc:graphicFrameChg>
+      </pc:sldChg>
+      <pc:sldChg chg="modSp add del">
+        <pc:chgData name="Vempi Satriya" userId="c28fa87cdebdc656" providerId="LiveId" clId="{63E91B12-6D81-43DC-90EF-03735CFC9BF7}" dt="2026-08-22T23:50:01.946" v="205"/>
+        <pc:sldMkLst>
+          <pc:docMk/>
+          <pc:sldMk cId="0" sldId="596"/>
+        </pc:sldMkLst>
+        <pc:spChg chg="mod">
+          <ac:chgData name="Vempi Satriya" userId="c28fa87cdebdc656" providerId="LiveId" clId="{63E91B12-6D81-43DC-90EF-03735CFC9BF7}" dt="2026-08-22T23:50:00.885" v="199"/>
+          <ac:spMkLst>
+            <pc:docMk/>
+            <pc:sldMk cId="0" sldId="596"/>
+            <ac:spMk id="5" creationId="{00000000-0000-0000-0000-000000000000}"/>
+          </ac:spMkLst>
+        </pc:spChg>
+      </pc:sldChg>
+      <pc:sldChg chg="addSp delSp modSp add mod ord">
+        <pc:chgData name="Vempi Satriya" userId="c28fa87cdebdc656" providerId="LiveId" clId="{63E91B12-6D81-43DC-90EF-03735CFC9BF7}" dt="2026-08-23T17:21:29.758" v="807" actId="1076"/>
+        <pc:sldMkLst>
+          <pc:docMk/>
+          <pc:sldMk cId="3163511732" sldId="596"/>
+        </pc:sldMkLst>
+        <pc:spChg chg="mod">
+          <ac:chgData name="Vempi Satriya" userId="c28fa87cdebdc656" providerId="LiveId" clId="{63E91B12-6D81-43DC-90EF-03735CFC9BF7}" dt="2026-08-23T13:41:50.920" v="665" actId="20577"/>
+          <ac:spMkLst>
+            <pc:docMk/>
+            <pc:sldMk cId="3163511732" sldId="596"/>
+            <ac:spMk id="3" creationId="{650B0D0A-296B-14BF-AC41-B6B820CF4DD4}"/>
+          </ac:spMkLst>
+        </pc:spChg>
+        <pc:spChg chg="add del mod">
+          <ac:chgData name="Vempi Satriya" userId="c28fa87cdebdc656" providerId="LiveId" clId="{63E91B12-6D81-43DC-90EF-03735CFC9BF7}" dt="2026-08-22T23:56:18.014" v="323" actId="478"/>
+          <ac:spMkLst>
+            <pc:docMk/>
+            <pc:sldMk cId="3163511732" sldId="596"/>
+            <ac:spMk id="5" creationId="{4CC6B574-BB93-4EBA-991C-EDB6ED19C067}"/>
+          </ac:spMkLst>
+        </pc:spChg>
+        <pc:spChg chg="add mod">
+          <ac:chgData name="Vempi Satriya" userId="c28fa87cdebdc656" providerId="LiveId" clId="{63E91B12-6D81-43DC-90EF-03735CFC9BF7}" dt="2026-08-22T23:56:33.716" v="328" actId="21"/>
+          <ac:spMkLst>
+            <pc:docMk/>
+            <pc:sldMk cId="3163511732" sldId="596"/>
+            <ac:spMk id="6" creationId="{00000000-0000-0000-0000-000000000000}"/>
+          </ac:spMkLst>
+        </pc:spChg>
+        <pc:spChg chg="del">
+          <ac:chgData name="Vempi Satriya" userId="c28fa87cdebdc656" providerId="LiveId" clId="{63E91B12-6D81-43DC-90EF-03735CFC9BF7}" dt="2026-08-22T23:56:17.215" v="322" actId="478"/>
+          <ac:spMkLst>
+            <pc:docMk/>
+            <pc:sldMk cId="3163511732" sldId="596"/>
+            <ac:spMk id="8" creationId="{7A36EE96-E945-AF8F-34AC-9394D1E83578}"/>
+          </ac:spMkLst>
+        </pc:spChg>
+        <pc:spChg chg="add mod">
+          <ac:chgData name="Vempi Satriya" userId="c28fa87cdebdc656" providerId="LiveId" clId="{63E91B12-6D81-43DC-90EF-03735CFC9BF7}" dt="2026-08-23T17:20:59.592" v="799" actId="1076"/>
+          <ac:spMkLst>
+            <pc:docMk/>
+            <pc:sldMk cId="3163511732" sldId="596"/>
+            <ac:spMk id="9" creationId="{8546C051-20B7-1638-FD6F-99791F594F46}"/>
+          </ac:spMkLst>
+        </pc:spChg>
+        <pc:graphicFrameChg chg="add mod modGraphic">
+          <ac:chgData name="Vempi Satriya" userId="c28fa87cdebdc656" providerId="LiveId" clId="{63E91B12-6D81-43DC-90EF-03735CFC9BF7}" dt="2026-08-23T17:21:22.980" v="803" actId="1076"/>
+          <ac:graphicFrameMkLst>
+            <pc:docMk/>
+            <pc:sldMk cId="3163511732" sldId="596"/>
+            <ac:graphicFrameMk id="7" creationId="{00000000-0000-0000-0000-000000000000}"/>
+          </ac:graphicFrameMkLst>
+        </pc:graphicFrameChg>
+        <pc:picChg chg="add mod">
+          <ac:chgData name="Vempi Satriya" userId="c28fa87cdebdc656" providerId="LiveId" clId="{63E91B12-6D81-43DC-90EF-03735CFC9BF7}" dt="2026-08-23T17:21:29.758" v="807" actId="1076"/>
+          <ac:picMkLst>
+            <pc:docMk/>
+            <pc:sldMk cId="3163511732" sldId="596"/>
+            <ac:picMk id="5" creationId="{A963AC32-1E67-F095-E7D7-4D2E449AD144}"/>
+          </ac:picMkLst>
+        </pc:picChg>
+      </pc:sldChg>
+      <pc:sldChg chg="modSp add del mod">
+        <pc:chgData name="Vempi Satriya" userId="c28fa87cdebdc656" providerId="LiveId" clId="{63E91B12-6D81-43DC-90EF-03735CFC9BF7}" dt="2026-08-22T23:50:01.946" v="205"/>
+        <pc:sldMkLst>
+          <pc:docMk/>
+          <pc:sldMk cId="0" sldId="597"/>
+        </pc:sldMkLst>
+        <pc:spChg chg="mod">
+          <ac:chgData name="Vempi Satriya" userId="c28fa87cdebdc656" providerId="LiveId" clId="{63E91B12-6D81-43DC-90EF-03735CFC9BF7}" dt="2026-08-22T23:50:01.946" v="205"/>
+          <ac:spMkLst>
+            <pc:docMk/>
+            <pc:sldMk cId="0" sldId="597"/>
+            <ac:spMk id="3" creationId="{00000000-0000-0000-0000-000000000000}"/>
+          </ac:spMkLst>
+        </pc:spChg>
+        <pc:spChg chg="mod">
+          <ac:chgData name="Vempi Satriya" userId="c28fa87cdebdc656" providerId="LiveId" clId="{63E91B12-6D81-43DC-90EF-03735CFC9BF7}" dt="2026-08-22T23:50:00.885" v="199"/>
+          <ac:spMkLst>
+            <pc:docMk/>
+            <pc:sldMk cId="0" sldId="597"/>
+            <ac:spMk id="10" creationId="{00000000-0000-0000-0000-000000000000}"/>
+          </ac:spMkLst>
+        </pc:spChg>
+      </pc:sldChg>
+      <pc:sldChg chg="addSp delSp modSp add mod">
+        <pc:chgData name="Vempi Satriya" userId="c28fa87cdebdc656" providerId="LiveId" clId="{63E91B12-6D81-43DC-90EF-03735CFC9BF7}" dt="2026-08-23T13:41:54.947" v="666"/>
+        <pc:sldMkLst>
+          <pc:docMk/>
+          <pc:sldMk cId="3965085750" sldId="597"/>
+        </pc:sldMkLst>
+        <pc:spChg chg="mod">
+          <ac:chgData name="Vempi Satriya" userId="c28fa87cdebdc656" providerId="LiveId" clId="{63E91B12-6D81-43DC-90EF-03735CFC9BF7}" dt="2026-08-23T13:41:54.947" v="666"/>
+          <ac:spMkLst>
+            <pc:docMk/>
+            <pc:sldMk cId="3965085750" sldId="597"/>
+            <ac:spMk id="3" creationId="{889E5B51-A084-D09A-F38D-A04C7789A028}"/>
+          </ac:spMkLst>
+        </pc:spChg>
+        <pc:spChg chg="add del mod">
+          <ac:chgData name="Vempi Satriya" userId="c28fa87cdebdc656" providerId="LiveId" clId="{63E91B12-6D81-43DC-90EF-03735CFC9BF7}" dt="2026-08-22T23:57:11.912" v="344" actId="478"/>
+          <ac:spMkLst>
+            <pc:docMk/>
+            <pc:sldMk cId="3965085750" sldId="597"/>
+            <ac:spMk id="5" creationId="{E56FE2F8-6ADC-5C1F-8600-5770F913304D}"/>
+          </ac:spMkLst>
+        </pc:spChg>
+        <pc:spChg chg="del">
+          <ac:chgData name="Vempi Satriya" userId="c28fa87cdebdc656" providerId="LiveId" clId="{63E91B12-6D81-43DC-90EF-03735CFC9BF7}" dt="2026-08-22T23:57:05.155" v="341" actId="478"/>
+          <ac:spMkLst>
+            <pc:docMk/>
+            <pc:sldMk cId="3965085750" sldId="597"/>
+            <ac:spMk id="6" creationId="{D92B48A8-1750-7BE7-EE84-944D8770AC8B}"/>
+          </ac:spMkLst>
+        </pc:spChg>
+        <pc:spChg chg="add mod">
+          <ac:chgData name="Vempi Satriya" userId="c28fa87cdebdc656" providerId="LiveId" clId="{63E91B12-6D81-43DC-90EF-03735CFC9BF7}" dt="2026-08-22T23:57:19.374" v="345" actId="1076"/>
+          <ac:spMkLst>
+            <pc:docMk/>
+            <pc:sldMk cId="3965085750" sldId="597"/>
+            <ac:spMk id="8" creationId="{00000000-0000-0000-0000-000000000000}"/>
+          </ac:spMkLst>
+        </pc:spChg>
+        <pc:spChg chg="del">
+          <ac:chgData name="Vempi Satriya" userId="c28fa87cdebdc656" providerId="LiveId" clId="{63E91B12-6D81-43DC-90EF-03735CFC9BF7}" dt="2026-08-22T23:57:02.406" v="340" actId="478"/>
+          <ac:spMkLst>
+            <pc:docMk/>
+            <pc:sldMk cId="3965085750" sldId="597"/>
+            <ac:spMk id="9" creationId="{B311A5E8-C446-D1B9-008F-7B00A8DAF51A}"/>
+          </ac:spMkLst>
+        </pc:spChg>
+        <pc:spChg chg="add mod">
+          <ac:chgData name="Vempi Satriya" userId="c28fa87cdebdc656" providerId="LiveId" clId="{63E91B12-6D81-43DC-90EF-03735CFC9BF7}" dt="2026-08-22T23:57:19.374" v="345" actId="1076"/>
+          <ac:spMkLst>
+            <pc:docMk/>
+            <pc:sldMk cId="3965085750" sldId="597"/>
+            <ac:spMk id="18434" creationId="{00000000-0000-0000-0000-000000000000}"/>
+          </ac:spMkLst>
+        </pc:spChg>
+        <pc:spChg chg="add mod">
+          <ac:chgData name="Vempi Satriya" userId="c28fa87cdebdc656" providerId="LiveId" clId="{63E91B12-6D81-43DC-90EF-03735CFC9BF7}" dt="2026-08-22T23:57:19.374" v="345" actId="1076"/>
+          <ac:spMkLst>
+            <pc:docMk/>
+            <pc:sldMk cId="3965085750" sldId="597"/>
+            <ac:spMk id="18438" creationId="{00000000-0000-0000-0000-000000000000}"/>
+          </ac:spMkLst>
+        </pc:spChg>
+        <pc:spChg chg="add mod">
+          <ac:chgData name="Vempi Satriya" userId="c28fa87cdebdc656" providerId="LiveId" clId="{63E91B12-6D81-43DC-90EF-03735CFC9BF7}" dt="2026-08-22T23:57:10.223" v="343"/>
+          <ac:spMkLst>
+            <pc:docMk/>
+            <pc:sldMk cId="3965085750" sldId="597"/>
+            <ac:spMk id="18440" creationId="{00000000-0000-0000-0000-000000000000}"/>
+          </ac:spMkLst>
+        </pc:spChg>
+        <pc:graphicFrameChg chg="del">
+          <ac:chgData name="Vempi Satriya" userId="c28fa87cdebdc656" providerId="LiveId" clId="{63E91B12-6D81-43DC-90EF-03735CFC9BF7}" dt="2026-08-22T23:57:02.406" v="340" actId="478"/>
+          <ac:graphicFrameMkLst>
+            <pc:docMk/>
+            <pc:sldMk cId="3965085750" sldId="597"/>
+            <ac:graphicFrameMk id="7" creationId="{9C8DCF5E-623B-6E2B-67D8-604815773EA5}"/>
+          </ac:graphicFrameMkLst>
+        </pc:graphicFrameChg>
+        <pc:graphicFrameChg chg="add mod">
+          <ac:chgData name="Vempi Satriya" userId="c28fa87cdebdc656" providerId="LiveId" clId="{63E91B12-6D81-43DC-90EF-03735CFC9BF7}" dt="2026-08-22T23:57:22.667" v="346" actId="1076"/>
+          <ac:graphicFrameMkLst>
+            <pc:docMk/>
+            <pc:sldMk cId="3965085750" sldId="597"/>
+            <ac:graphicFrameMk id="18437" creationId="{00000000-0000-0000-0000-000000000000}"/>
+          </ac:graphicFrameMkLst>
+        </pc:graphicFrameChg>
+        <pc:graphicFrameChg chg="add mod">
+          <ac:chgData name="Vempi Satriya" userId="c28fa87cdebdc656" providerId="LiveId" clId="{63E91B12-6D81-43DC-90EF-03735CFC9BF7}" dt="2026-08-22T23:57:25.793" v="347" actId="1076"/>
+          <ac:graphicFrameMkLst>
+            <pc:docMk/>
+            <pc:sldMk cId="3965085750" sldId="597"/>
+            <ac:graphicFrameMk id="18439" creationId="{00000000-0000-0000-0000-000000000000}"/>
+          </ac:graphicFrameMkLst>
+        </pc:graphicFrameChg>
+        <pc:graphicFrameChg chg="add mod">
+          <ac:chgData name="Vempi Satriya" userId="c28fa87cdebdc656" providerId="LiveId" clId="{63E91B12-6D81-43DC-90EF-03735CFC9BF7}" dt="2026-08-22T23:57:19.374" v="345" actId="1076"/>
+          <ac:graphicFrameMkLst>
+            <pc:docMk/>
+            <pc:sldMk cId="3965085750" sldId="597"/>
+            <ac:graphicFrameMk id="18446" creationId="{00000000-0000-0000-0000-000000000000}"/>
+          </ac:graphicFrameMkLst>
+        </pc:graphicFrameChg>
+      </pc:sldChg>
+      <pc:sldChg chg="modSp add del">
+        <pc:chgData name="Vempi Satriya" userId="c28fa87cdebdc656" providerId="LiveId" clId="{63E91B12-6D81-43DC-90EF-03735CFC9BF7}" dt="2026-08-22T23:50:01.946" v="205"/>
+        <pc:sldMkLst>
+          <pc:docMk/>
+          <pc:sldMk cId="0" sldId="598"/>
+        </pc:sldMkLst>
+        <pc:spChg chg="mod">
+          <ac:chgData name="Vempi Satriya" userId="c28fa87cdebdc656" providerId="LiveId" clId="{63E91B12-6D81-43DC-90EF-03735CFC9BF7}" dt="2026-08-22T23:50:00.885" v="199"/>
+          <ac:spMkLst>
+            <pc:docMk/>
+            <pc:sldMk cId="0" sldId="598"/>
+            <ac:spMk id="12" creationId="{00000000-0000-0000-0000-000000000000}"/>
+          </ac:spMkLst>
+        </pc:spChg>
+      </pc:sldChg>
+      <pc:sldChg chg="addSp delSp modSp add mod">
+        <pc:chgData name="Vempi Satriya" userId="c28fa87cdebdc656" providerId="LiveId" clId="{63E91B12-6D81-43DC-90EF-03735CFC9BF7}" dt="2026-08-23T17:23:56.800" v="822" actId="20577"/>
+        <pc:sldMkLst>
+          <pc:docMk/>
+          <pc:sldMk cId="3288209097" sldId="598"/>
+        </pc:sldMkLst>
+        <pc:spChg chg="add mod">
+          <ac:chgData name="Vempi Satriya" userId="c28fa87cdebdc656" providerId="LiveId" clId="{63E91B12-6D81-43DC-90EF-03735CFC9BF7}" dt="2026-08-23T17:23:56.800" v="822" actId="20577"/>
+          <ac:spMkLst>
+            <pc:docMk/>
+            <pc:sldMk cId="3288209097" sldId="598"/>
+            <ac:spMk id="2" creationId="{00000000-0000-0000-0000-000000000000}"/>
+          </ac:spMkLst>
+        </pc:spChg>
+        <pc:spChg chg="mod">
+          <ac:chgData name="Vempi Satriya" userId="c28fa87cdebdc656" providerId="LiveId" clId="{63E91B12-6D81-43DC-90EF-03735CFC9BF7}" dt="2026-08-23T13:41:59.194" v="667"/>
+          <ac:spMkLst>
+            <pc:docMk/>
+            <pc:sldMk cId="3288209097" sldId="598"/>
+            <ac:spMk id="3" creationId="{6AE44CD9-C33A-66E0-4CC5-52E53C9F706E}"/>
+          </ac:spMkLst>
+        </pc:spChg>
+        <pc:spChg chg="mod">
+          <ac:chgData name="Vempi Satriya" userId="c28fa87cdebdc656" providerId="LiveId" clId="{63E91B12-6D81-43DC-90EF-03735CFC9BF7}" dt="2026-08-22T23:58:12.458" v="358" actId="404"/>
+          <ac:spMkLst>
+            <pc:docMk/>
+            <pc:sldMk cId="3288209097" sldId="598"/>
+            <ac:spMk id="4" creationId="{CDA0F584-7185-5F25-2BF4-D3ED60F07514}"/>
+          </ac:spMkLst>
+        </pc:spChg>
+        <pc:spChg chg="add mod">
+          <ac:chgData name="Vempi Satriya" userId="c28fa87cdebdc656" providerId="LiveId" clId="{63E91B12-6D81-43DC-90EF-03735CFC9BF7}" dt="2026-08-22T23:58:56.801" v="377" actId="1076"/>
+          <ac:spMkLst>
+            <pc:docMk/>
+            <pc:sldMk cId="3288209097" sldId="598"/>
+            <ac:spMk id="6" creationId="{E80FEEA9-2FD2-EB66-385F-6D4485F1A6B4}"/>
+          </ac:spMkLst>
+        </pc:spChg>
+        <pc:spChg chg="add mod">
+          <ac:chgData name="Vempi Satriya" userId="c28fa87cdebdc656" providerId="LiveId" clId="{63E91B12-6D81-43DC-90EF-03735CFC9BF7}" dt="2026-08-22T23:59:00.825" v="379" actId="1076"/>
+          <ac:spMkLst>
+            <pc:docMk/>
+            <pc:sldMk cId="3288209097" sldId="598"/>
+            <ac:spMk id="7" creationId="{00000000-0000-0000-0000-000000000000}"/>
+          </ac:spMkLst>
+        </pc:spChg>
+        <pc:spChg chg="del">
+          <ac:chgData name="Vempi Satriya" userId="c28fa87cdebdc656" providerId="LiveId" clId="{63E91B12-6D81-43DC-90EF-03735CFC9BF7}" dt="2026-08-22T23:57:38.698" v="350" actId="478"/>
+          <ac:spMkLst>
+            <pc:docMk/>
+            <pc:sldMk cId="3288209097" sldId="598"/>
+            <ac:spMk id="8" creationId="{4904725F-21E1-5C98-6C50-E73116668D9C}"/>
+          </ac:spMkLst>
+        </pc:spChg>
+        <pc:spChg chg="mod">
+          <ac:chgData name="Vempi Satriya" userId="c28fa87cdebdc656" providerId="LiveId" clId="{63E91B12-6D81-43DC-90EF-03735CFC9BF7}" dt="2026-08-22T23:58:12.458" v="358" actId="404"/>
+          <ac:spMkLst>
+            <pc:docMk/>
+            <pc:sldMk cId="3288209097" sldId="598"/>
+            <ac:spMk id="18434" creationId="{8592370A-E457-F6CE-FEC2-614D6EC6BBCD}"/>
+          </ac:spMkLst>
+        </pc:spChg>
+        <pc:spChg chg="mod">
+          <ac:chgData name="Vempi Satriya" userId="c28fa87cdebdc656" providerId="LiveId" clId="{63E91B12-6D81-43DC-90EF-03735CFC9BF7}" dt="2026-08-22T23:58:12.458" v="358" actId="404"/>
+          <ac:spMkLst>
+            <pc:docMk/>
+            <pc:sldMk cId="3288209097" sldId="598"/>
+            <ac:spMk id="18438" creationId="{D311C9F9-B2DF-E943-53C5-1142C3B11F8D}"/>
+          </ac:spMkLst>
+        </pc:spChg>
+        <pc:spChg chg="mod">
+          <ac:chgData name="Vempi Satriya" userId="c28fa87cdebdc656" providerId="LiveId" clId="{63E91B12-6D81-43DC-90EF-03735CFC9BF7}" dt="2026-08-22T23:58:12.458" v="358" actId="404"/>
+          <ac:spMkLst>
+            <pc:docMk/>
+            <pc:sldMk cId="3288209097" sldId="598"/>
+            <ac:spMk id="18440" creationId="{5D1C5F3F-EF8D-095C-C8FD-C208839DCEA6}"/>
+          </ac:spMkLst>
+        </pc:spChg>
+        <pc:graphicFrameChg chg="del">
+          <ac:chgData name="Vempi Satriya" userId="c28fa87cdebdc656" providerId="LiveId" clId="{63E91B12-6D81-43DC-90EF-03735CFC9BF7}" dt="2026-08-22T23:57:38.698" v="350" actId="478"/>
+          <ac:graphicFrameMkLst>
+            <pc:docMk/>
+            <pc:sldMk cId="3288209097" sldId="598"/>
+            <ac:graphicFrameMk id="18437" creationId="{897AFE20-093D-B8D7-8371-98F852DF7505}"/>
+          </ac:graphicFrameMkLst>
+        </pc:graphicFrameChg>
+        <pc:graphicFrameChg chg="del">
+          <ac:chgData name="Vempi Satriya" userId="c28fa87cdebdc656" providerId="LiveId" clId="{63E91B12-6D81-43DC-90EF-03735CFC9BF7}" dt="2026-08-22T23:57:38.698" v="350" actId="478"/>
+          <ac:graphicFrameMkLst>
+            <pc:docMk/>
+            <pc:sldMk cId="3288209097" sldId="598"/>
+            <ac:graphicFrameMk id="18439" creationId="{53A73A2D-4E2A-3D67-49D4-986129FA8530}"/>
+          </ac:graphicFrameMkLst>
+        </pc:graphicFrameChg>
+        <pc:graphicFrameChg chg="del">
+          <ac:chgData name="Vempi Satriya" userId="c28fa87cdebdc656" providerId="LiveId" clId="{63E91B12-6D81-43DC-90EF-03735CFC9BF7}" dt="2026-08-22T23:57:38.698" v="350" actId="478"/>
+          <ac:graphicFrameMkLst>
+            <pc:docMk/>
+            <pc:sldMk cId="3288209097" sldId="598"/>
+            <ac:graphicFrameMk id="18446" creationId="{F1935C02-734A-5A90-474A-44A6F87C83FE}"/>
+          </ac:graphicFrameMkLst>
+        </pc:graphicFrameChg>
+        <pc:graphicFrameChg chg="add mod">
+          <ac:chgData name="Vempi Satriya" userId="c28fa87cdebdc656" providerId="LiveId" clId="{63E91B12-6D81-43DC-90EF-03735CFC9BF7}" dt="2026-08-22T23:58:36.102" v="367" actId="1076"/>
+          <ac:graphicFrameMkLst>
+            <pc:docMk/>
+            <pc:sldMk cId="3288209097" sldId="598"/>
+            <ac:graphicFrameMk id="23554" creationId="{00000000-0000-0000-0000-000000000000}"/>
+          </ac:graphicFrameMkLst>
+        </pc:graphicFrameChg>
+        <pc:graphicFrameChg chg="add mod">
+          <ac:chgData name="Vempi Satriya" userId="c28fa87cdebdc656" providerId="LiveId" clId="{63E91B12-6D81-43DC-90EF-03735CFC9BF7}" dt="2026-08-22T23:58:02.436" v="354" actId="1076"/>
+          <ac:graphicFrameMkLst>
+            <pc:docMk/>
+            <pc:sldMk cId="3288209097" sldId="598"/>
+            <ac:graphicFrameMk id="23556" creationId="{00000000-0000-0000-0000-000000000000}"/>
+          </ac:graphicFrameMkLst>
+        </pc:graphicFrameChg>
+      </pc:sldChg>
+      <pc:sldChg chg="modSp add del mod">
+        <pc:chgData name="Vempi Satriya" userId="c28fa87cdebdc656" providerId="LiveId" clId="{63E91B12-6D81-43DC-90EF-03735CFC9BF7}" dt="2026-08-22T23:50:01.946" v="205"/>
+        <pc:sldMkLst>
+          <pc:docMk/>
+          <pc:sldMk cId="0" sldId="599"/>
+        </pc:sldMkLst>
+        <pc:spChg chg="mod">
+          <ac:chgData name="Vempi Satriya" userId="c28fa87cdebdc656" providerId="LiveId" clId="{63E91B12-6D81-43DC-90EF-03735CFC9BF7}" dt="2026-08-22T23:50:01.946" v="205"/>
+          <ac:spMkLst>
+            <pc:docMk/>
+            <pc:sldMk cId="0" sldId="599"/>
+            <ac:spMk id="3" creationId="{00000000-0000-0000-0000-000000000000}"/>
+          </ac:spMkLst>
+        </pc:spChg>
+        <pc:spChg chg="mod">
+          <ac:chgData name="Vempi Satriya" userId="c28fa87cdebdc656" providerId="LiveId" clId="{63E91B12-6D81-43DC-90EF-03735CFC9BF7}" dt="2026-08-22T23:50:00.885" v="199"/>
+          <ac:spMkLst>
+            <pc:docMk/>
+            <pc:sldMk cId="0" sldId="599"/>
+            <ac:spMk id="4" creationId="{00000000-0000-0000-0000-000000000000}"/>
+          </ac:spMkLst>
+        </pc:spChg>
+      </pc:sldChg>
+      <pc:sldChg chg="addSp delSp modSp add mod">
+        <pc:chgData name="Vempi Satriya" userId="c28fa87cdebdc656" providerId="LiveId" clId="{63E91B12-6D81-43DC-90EF-03735CFC9BF7}" dt="2026-08-23T17:25:21.346" v="838" actId="1076"/>
+        <pc:sldMkLst>
+          <pc:docMk/>
+          <pc:sldMk cId="1658994099" sldId="599"/>
+        </pc:sldMkLst>
+        <pc:spChg chg="del">
+          <ac:chgData name="Vempi Satriya" userId="c28fa87cdebdc656" providerId="LiveId" clId="{63E91B12-6D81-43DC-90EF-03735CFC9BF7}" dt="2026-08-22T23:59:12.396" v="382" actId="478"/>
+          <ac:spMkLst>
+            <pc:docMk/>
+            <pc:sldMk cId="1658994099" sldId="599"/>
+            <ac:spMk id="2" creationId="{B1287533-577B-0CE4-6BF0-0CBF53FBE0E7}"/>
+          </ac:spMkLst>
+        </pc:spChg>
+        <pc:spChg chg="mod">
+          <ac:chgData name="Vempi Satriya" userId="c28fa87cdebdc656" providerId="LiveId" clId="{63E91B12-6D81-43DC-90EF-03735CFC9BF7}" dt="2026-08-23T13:42:34.461" v="699" actId="20577"/>
+          <ac:spMkLst>
+            <pc:docMk/>
+            <pc:sldMk cId="1658994099" sldId="599"/>
+            <ac:spMk id="3" creationId="{ECA84B56-4FEE-8431-99D9-0882C27F9253}"/>
+          </ac:spMkLst>
+        </pc:spChg>
+        <pc:spChg chg="del">
+          <ac:chgData name="Vempi Satriya" userId="c28fa87cdebdc656" providerId="LiveId" clId="{63E91B12-6D81-43DC-90EF-03735CFC9BF7}" dt="2026-08-22T23:59:12.396" v="382" actId="478"/>
+          <ac:spMkLst>
+            <pc:docMk/>
+            <pc:sldMk cId="1658994099" sldId="599"/>
+            <ac:spMk id="6" creationId="{14703FD4-24FC-B5C2-6763-E20A7A6C71C4}"/>
+          </ac:spMkLst>
+        </pc:spChg>
+        <pc:spChg chg="add mod">
+          <ac:chgData name="Vempi Satriya" userId="c28fa87cdebdc656" providerId="LiveId" clId="{63E91B12-6D81-43DC-90EF-03735CFC9BF7}" dt="2026-08-23T17:25:21.346" v="838" actId="1076"/>
+          <ac:spMkLst>
+            <pc:docMk/>
+            <pc:sldMk cId="1658994099" sldId="599"/>
+            <ac:spMk id="6" creationId="{773FDF8C-64D1-6885-D824-744B0434B4BF}"/>
+          </ac:spMkLst>
+        </pc:spChg>
+        <pc:spChg chg="del">
+          <ac:chgData name="Vempi Satriya" userId="c28fa87cdebdc656" providerId="LiveId" clId="{63E91B12-6D81-43DC-90EF-03735CFC9BF7}" dt="2026-08-22T23:59:12.396" v="382" actId="478"/>
+          <ac:spMkLst>
+            <pc:docMk/>
+            <pc:sldMk cId="1658994099" sldId="599"/>
+            <ac:spMk id="7" creationId="{553E0697-4895-3CFD-E466-777FC17345E4}"/>
+          </ac:spMkLst>
+        </pc:spChg>
+        <pc:spChg chg="add del mod">
+          <ac:chgData name="Vempi Satriya" userId="c28fa87cdebdc656" providerId="LiveId" clId="{63E91B12-6D81-43DC-90EF-03735CFC9BF7}" dt="2026-08-22T23:59:14.533" v="383" actId="478"/>
+          <ac:spMkLst>
+            <pc:docMk/>
+            <pc:sldMk cId="1658994099" sldId="599"/>
+            <ac:spMk id="8" creationId="{972CC7CD-BDA1-B7B9-0136-55D853D1BA96}"/>
+          </ac:spMkLst>
+        </pc:spChg>
+        <pc:spChg chg="add mod">
+          <ac:chgData name="Vempi Satriya" userId="c28fa87cdebdc656" providerId="LiveId" clId="{63E91B12-6D81-43DC-90EF-03735CFC9BF7}" dt="2026-08-23T17:25:14.882" v="834" actId="21"/>
+          <ac:spMkLst>
+            <pc:docMk/>
+            <pc:sldMk cId="1658994099" sldId="599"/>
+            <ac:spMk id="9" creationId="{00000000-0000-0000-0000-000000000000}"/>
+          </ac:spMkLst>
+        </pc:spChg>
+        <pc:graphicFrameChg chg="del">
+          <ac:chgData name="Vempi Satriya" userId="c28fa87cdebdc656" providerId="LiveId" clId="{63E91B12-6D81-43DC-90EF-03735CFC9BF7}" dt="2026-08-22T23:59:12.396" v="382" actId="478"/>
+          <ac:graphicFrameMkLst>
+            <pc:docMk/>
+            <pc:sldMk cId="1658994099" sldId="599"/>
+            <ac:graphicFrameMk id="23554" creationId="{9FAA8AD0-D69D-3E28-30CC-DA187FE60DA1}"/>
+          </ac:graphicFrameMkLst>
+        </pc:graphicFrameChg>
+        <pc:graphicFrameChg chg="del">
+          <ac:chgData name="Vempi Satriya" userId="c28fa87cdebdc656" providerId="LiveId" clId="{63E91B12-6D81-43DC-90EF-03735CFC9BF7}" dt="2026-08-22T23:59:12.396" v="382" actId="478"/>
+          <ac:graphicFrameMkLst>
+            <pc:docMk/>
+            <pc:sldMk cId="1658994099" sldId="599"/>
+            <ac:graphicFrameMk id="23556" creationId="{AFFF07A1-9180-7171-1F1A-FEC3732E1787}"/>
+          </ac:graphicFrameMkLst>
+        </pc:graphicFrameChg>
+        <pc:picChg chg="add mod ord modCrop">
+          <ac:chgData name="Vempi Satriya" userId="c28fa87cdebdc656" providerId="LiveId" clId="{63E91B12-6D81-43DC-90EF-03735CFC9BF7}" dt="2026-08-23T17:25:08.944" v="831" actId="1076"/>
+          <ac:picMkLst>
+            <pc:docMk/>
+            <pc:sldMk cId="1658994099" sldId="599"/>
+            <ac:picMk id="5" creationId="{AE288904-A380-B942-7A6B-A978BBBF2B1F}"/>
+          </ac:picMkLst>
+        </pc:picChg>
+      </pc:sldChg>
+      <pc:sldChg chg="modSp add del">
+        <pc:chgData name="Vempi Satriya" userId="c28fa87cdebdc656" providerId="LiveId" clId="{63E91B12-6D81-43DC-90EF-03735CFC9BF7}" dt="2026-08-22T23:50:01.946" v="205"/>
+        <pc:sldMkLst>
+          <pc:docMk/>
+          <pc:sldMk cId="0" sldId="600"/>
+        </pc:sldMkLst>
+        <pc:spChg chg="mod">
+          <ac:chgData name="Vempi Satriya" userId="c28fa87cdebdc656" providerId="LiveId" clId="{63E91B12-6D81-43DC-90EF-03735CFC9BF7}" dt="2026-08-22T23:50:00.885" v="199"/>
+          <ac:spMkLst>
+            <pc:docMk/>
+            <pc:sldMk cId="0" sldId="600"/>
+            <ac:spMk id="6" creationId="{00000000-0000-0000-0000-000000000000}"/>
+          </ac:spMkLst>
+        </pc:spChg>
+      </pc:sldChg>
+      <pc:sldChg chg="addSp delSp modSp add mod">
+        <pc:chgData name="Vempi Satriya" userId="c28fa87cdebdc656" providerId="LiveId" clId="{63E91B12-6D81-43DC-90EF-03735CFC9BF7}" dt="2026-08-23T13:42:38.742" v="700"/>
+        <pc:sldMkLst>
+          <pc:docMk/>
+          <pc:sldMk cId="1360397227" sldId="600"/>
+        </pc:sldMkLst>
+        <pc:spChg chg="mod">
+          <ac:chgData name="Vempi Satriya" userId="c28fa87cdebdc656" providerId="LiveId" clId="{63E91B12-6D81-43DC-90EF-03735CFC9BF7}" dt="2026-08-23T13:42:38.742" v="700"/>
+          <ac:spMkLst>
+            <pc:docMk/>
+            <pc:sldMk cId="1360397227" sldId="600"/>
+            <ac:spMk id="3" creationId="{E440986D-7655-BB6F-1669-941071BEE58E}"/>
+          </ac:spMkLst>
+        </pc:spChg>
+        <pc:spChg chg="add del mod">
+          <ac:chgData name="Vempi Satriya" userId="c28fa87cdebdc656" providerId="LiveId" clId="{63E91B12-6D81-43DC-90EF-03735CFC9BF7}" dt="2026-08-22T23:59:41.645" v="393" actId="478"/>
+          <ac:spMkLst>
+            <pc:docMk/>
+            <pc:sldMk cId="1360397227" sldId="600"/>
+            <ac:spMk id="5" creationId="{CB679DDC-6C15-B507-B7F9-4BC6FD5783C6}"/>
+          </ac:spMkLst>
+        </pc:spChg>
+        <pc:spChg chg="add mod">
+          <ac:chgData name="Vempi Satriya" userId="c28fa87cdebdc656" providerId="LiveId" clId="{63E91B12-6D81-43DC-90EF-03735CFC9BF7}" dt="2026-08-22T23:59:57.705" v="401" actId="20577"/>
+          <ac:spMkLst>
+            <pc:docMk/>
+            <pc:sldMk cId="1360397227" sldId="600"/>
+            <ac:spMk id="6" creationId="{00000000-0000-0000-0000-000000000000}"/>
+          </ac:spMkLst>
+        </pc:spChg>
+        <pc:spChg chg="del">
+          <ac:chgData name="Vempi Satriya" userId="c28fa87cdebdc656" providerId="LiveId" clId="{63E91B12-6D81-43DC-90EF-03735CFC9BF7}" dt="2026-08-22T23:59:34.567" v="392" actId="478"/>
+          <ac:spMkLst>
+            <pc:docMk/>
+            <pc:sldMk cId="1360397227" sldId="600"/>
+            <ac:spMk id="9" creationId="{3A58C062-723C-EA47-A4D7-98329E2D1941}"/>
+          </ac:spMkLst>
+        </pc:spChg>
+        <pc:graphicFrameChg chg="add mod">
+          <ac:chgData name="Vempi Satriya" userId="c28fa87cdebdc656" providerId="LiveId" clId="{63E91B12-6D81-43DC-90EF-03735CFC9BF7}" dt="2026-08-23T00:00:02.251" v="403" actId="1076"/>
+          <ac:graphicFrameMkLst>
+            <pc:docMk/>
+            <pc:sldMk cId="1360397227" sldId="600"/>
+            <ac:graphicFrameMk id="25602" creationId="{00000000-0000-0000-0000-000000000000}"/>
+          </ac:graphicFrameMkLst>
+        </pc:graphicFrameChg>
+        <pc:graphicFrameChg chg="add mod">
+          <ac:chgData name="Vempi Satriya" userId="c28fa87cdebdc656" providerId="LiveId" clId="{63E91B12-6D81-43DC-90EF-03735CFC9BF7}" dt="2026-08-23T00:00:00.457" v="402" actId="1076"/>
+          <ac:graphicFrameMkLst>
+            <pc:docMk/>
+            <pc:sldMk cId="1360397227" sldId="600"/>
+            <ac:graphicFrameMk id="25603" creationId="{00000000-0000-0000-0000-000000000000}"/>
+          </ac:graphicFrameMkLst>
+        </pc:graphicFrameChg>
+      </pc:sldChg>
+      <pc:sldChg chg="modSp add del">
+        <pc:chgData name="Vempi Satriya" userId="c28fa87cdebdc656" providerId="LiveId" clId="{63E91B12-6D81-43DC-90EF-03735CFC9BF7}" dt="2026-08-22T23:50:01.946" v="205"/>
+        <pc:sldMkLst>
+          <pc:docMk/>
+          <pc:sldMk cId="0" sldId="601"/>
+        </pc:sldMkLst>
+        <pc:spChg chg="mod">
+          <ac:chgData name="Vempi Satriya" userId="c28fa87cdebdc656" providerId="LiveId" clId="{63E91B12-6D81-43DC-90EF-03735CFC9BF7}" dt="2026-08-22T23:50:00.885" v="199"/>
+          <ac:spMkLst>
+            <pc:docMk/>
+            <pc:sldMk cId="0" sldId="601"/>
+            <ac:spMk id="4" creationId="{00000000-0000-0000-0000-000000000000}"/>
+          </ac:spMkLst>
+        </pc:spChg>
+      </pc:sldChg>
+      <pc:sldChg chg="addSp delSp modSp add mod">
+        <pc:chgData name="Vempi Satriya" userId="c28fa87cdebdc656" providerId="LiveId" clId="{63E91B12-6D81-43DC-90EF-03735CFC9BF7}" dt="2026-08-23T17:23:23.054" v="821" actId="113"/>
+        <pc:sldMkLst>
+          <pc:docMk/>
+          <pc:sldMk cId="838614127" sldId="601"/>
+        </pc:sldMkLst>
+        <pc:spChg chg="add del mod">
+          <ac:chgData name="Vempi Satriya" userId="c28fa87cdebdc656" providerId="LiveId" clId="{63E91B12-6D81-43DC-90EF-03735CFC9BF7}" dt="2026-08-23T00:00:19.089" v="408" actId="478"/>
+          <ac:spMkLst>
+            <pc:docMk/>
+            <pc:sldMk cId="838614127" sldId="601"/>
+            <ac:spMk id="5" creationId="{A3F3ABB8-1A15-EE39-EA84-E7823E609667}"/>
+          </ac:spMkLst>
+        </pc:spChg>
+        <pc:spChg chg="del">
+          <ac:chgData name="Vempi Satriya" userId="c28fa87cdebdc656" providerId="LiveId" clId="{63E91B12-6D81-43DC-90EF-03735CFC9BF7}" dt="2026-08-23T00:00:16.010" v="405" actId="478"/>
+          <ac:spMkLst>
+            <pc:docMk/>
+            <pc:sldMk cId="838614127" sldId="601"/>
+            <ac:spMk id="6" creationId="{5597063A-4EEA-C421-5442-65FCAD0D4805}"/>
+          </ac:spMkLst>
+        </pc:spChg>
+        <pc:spChg chg="add mod">
+          <ac:chgData name="Vempi Satriya" userId="c28fa87cdebdc656" providerId="LiveId" clId="{63E91B12-6D81-43DC-90EF-03735CFC9BF7}" dt="2026-08-23T17:23:23.054" v="821" actId="113"/>
+          <ac:spMkLst>
+            <pc:docMk/>
+            <pc:sldMk cId="838614127" sldId="601"/>
+            <ac:spMk id="8" creationId="{00000000-0000-0000-0000-000000000000}"/>
+          </ac:spMkLst>
+        </pc:spChg>
+        <pc:graphicFrameChg chg="del">
+          <ac:chgData name="Vempi Satriya" userId="c28fa87cdebdc656" providerId="LiveId" clId="{63E91B12-6D81-43DC-90EF-03735CFC9BF7}" dt="2026-08-23T00:00:16.010" v="405" actId="478"/>
+          <ac:graphicFrameMkLst>
+            <pc:docMk/>
+            <pc:sldMk cId="838614127" sldId="601"/>
+            <ac:graphicFrameMk id="25602" creationId="{6C94E2BA-5C86-2216-2D42-E5E47A269278}"/>
+          </ac:graphicFrameMkLst>
+        </pc:graphicFrameChg>
+        <pc:graphicFrameChg chg="del">
+          <ac:chgData name="Vempi Satriya" userId="c28fa87cdebdc656" providerId="LiveId" clId="{63E91B12-6D81-43DC-90EF-03735CFC9BF7}" dt="2026-08-23T00:00:16.010" v="405" actId="478"/>
+          <ac:graphicFrameMkLst>
+            <pc:docMk/>
+            <pc:sldMk cId="838614127" sldId="601"/>
+            <ac:graphicFrameMk id="25603" creationId="{C411B742-D6CA-E190-C537-7E135E24BF79}"/>
+          </ac:graphicFrameMkLst>
+        </pc:graphicFrameChg>
+        <pc:picChg chg="add mod ord modCrop">
+          <ac:chgData name="Vempi Satriya" userId="c28fa87cdebdc656" providerId="LiveId" clId="{63E91B12-6D81-43DC-90EF-03735CFC9BF7}" dt="2026-08-23T17:23:05.116" v="816" actId="167"/>
+          <ac:picMkLst>
+            <pc:docMk/>
+            <pc:sldMk cId="838614127" sldId="601"/>
+            <ac:picMk id="5" creationId="{894F2841-AE65-1233-9D4A-A06D50AAD71F}"/>
+          </ac:picMkLst>
+        </pc:picChg>
+        <pc:picChg chg="add del mod ord">
+          <ac:chgData name="Vempi Satriya" userId="c28fa87cdebdc656" providerId="LiveId" clId="{63E91B12-6D81-43DC-90EF-03735CFC9BF7}" dt="2026-08-23T00:00:17.985" v="407" actId="34307"/>
+          <ac:picMkLst>
+            <pc:docMk/>
+            <pc:sldMk cId="838614127" sldId="601"/>
+            <ac:picMk id="7" creationId="{16496341-2215-C544-4A81-6A985B18E3AB}"/>
+          </ac:picMkLst>
+        </pc:picChg>
+      </pc:sldChg>
+      <pc:sldChg chg="modSp add del mod">
+        <pc:chgData name="Vempi Satriya" userId="c28fa87cdebdc656" providerId="LiveId" clId="{63E91B12-6D81-43DC-90EF-03735CFC9BF7}" dt="2026-08-22T23:50:01.946" v="205"/>
+        <pc:sldMkLst>
+          <pc:docMk/>
+          <pc:sldMk cId="0" sldId="602"/>
+        </pc:sldMkLst>
+        <pc:spChg chg="mod">
+          <ac:chgData name="Vempi Satriya" userId="c28fa87cdebdc656" providerId="LiveId" clId="{63E91B12-6D81-43DC-90EF-03735CFC9BF7}" dt="2026-08-22T23:50:01.946" v="205"/>
+          <ac:spMkLst>
+            <pc:docMk/>
+            <pc:sldMk cId="0" sldId="602"/>
+            <ac:spMk id="3" creationId="{00000000-0000-0000-0000-000000000000}"/>
+          </ac:spMkLst>
+        </pc:spChg>
+        <pc:spChg chg="mod">
+          <ac:chgData name="Vempi Satriya" userId="c28fa87cdebdc656" providerId="LiveId" clId="{63E91B12-6D81-43DC-90EF-03735CFC9BF7}" dt="2026-08-22T23:50:00.885" v="199"/>
+          <ac:spMkLst>
+            <pc:docMk/>
+            <pc:sldMk cId="0" sldId="602"/>
+            <ac:spMk id="4" creationId="{00000000-0000-0000-0000-000000000000}"/>
+          </ac:spMkLst>
+        </pc:spChg>
+      </pc:sldChg>
+      <pc:sldChg chg="addSp delSp modSp add mod">
+        <pc:chgData name="Vempi Satriya" userId="c28fa87cdebdc656" providerId="LiveId" clId="{63E91B12-6D81-43DC-90EF-03735CFC9BF7}" dt="2026-08-23T17:26:22.109" v="844" actId="1076"/>
+        <pc:sldMkLst>
+          <pc:docMk/>
+          <pc:sldMk cId="2076696762" sldId="602"/>
+        </pc:sldMkLst>
+        <pc:spChg chg="mod">
+          <ac:chgData name="Vempi Satriya" userId="c28fa87cdebdc656" providerId="LiveId" clId="{63E91B12-6D81-43DC-90EF-03735CFC9BF7}" dt="2026-08-23T13:43:14.171" v="709" actId="20577"/>
+          <ac:spMkLst>
+            <pc:docMk/>
+            <pc:sldMk cId="2076696762" sldId="602"/>
+            <ac:spMk id="3" creationId="{9F092D4A-BD60-6B3C-AADE-751048C23332}"/>
+          </ac:spMkLst>
+        </pc:spChg>
+        <pc:spChg chg="add del mod">
+          <ac:chgData name="Vempi Satriya" userId="c28fa87cdebdc656" providerId="LiveId" clId="{63E91B12-6D81-43DC-90EF-03735CFC9BF7}" dt="2026-08-23T00:00:40.177" v="416" actId="478"/>
+          <ac:spMkLst>
+            <pc:docMk/>
+            <pc:sldMk cId="2076696762" sldId="602"/>
+            <ac:spMk id="5" creationId="{497058C2-FA2E-36EA-DFB3-601837F140EF}"/>
+          </ac:spMkLst>
+        </pc:spChg>
+        <pc:spChg chg="add mod">
+          <ac:chgData name="Vempi Satriya" userId="c28fa87cdebdc656" providerId="LiveId" clId="{63E91B12-6D81-43DC-90EF-03735CFC9BF7}" dt="2026-08-23T17:25:34.348" v="841" actId="20577"/>
+          <ac:spMkLst>
+            <pc:docMk/>
+            <pc:sldMk cId="2076696762" sldId="602"/>
+            <ac:spMk id="6" creationId="{00000000-0000-0000-0000-000000000000}"/>
+          </ac:spMkLst>
+        </pc:spChg>
+        <pc:spChg chg="add mod">
+          <ac:chgData name="Vempi Satriya" userId="c28fa87cdebdc656" providerId="LiveId" clId="{63E91B12-6D81-43DC-90EF-03735CFC9BF7}" dt="2026-08-23T17:26:22.109" v="844" actId="1076"/>
+          <ac:spMkLst>
+            <pc:docMk/>
+            <pc:sldMk cId="2076696762" sldId="602"/>
+            <ac:spMk id="7" creationId="{436DD134-9BF9-5518-32EB-D3CFBFDA5CC7}"/>
+          </ac:spMkLst>
+        </pc:spChg>
+        <pc:spChg chg="del">
+          <ac:chgData name="Vempi Satriya" userId="c28fa87cdebdc656" providerId="LiveId" clId="{63E91B12-6D81-43DC-90EF-03735CFC9BF7}" dt="2026-08-23T00:00:38.114" v="415" actId="478"/>
+          <ac:spMkLst>
+            <pc:docMk/>
+            <pc:sldMk cId="2076696762" sldId="602"/>
+            <ac:spMk id="8" creationId="{D3983FAD-1FC2-979E-2008-92513AD7CA3A}"/>
+          </ac:spMkLst>
+        </pc:spChg>
+      </pc:sldChg>
+      <pc:sldChg chg="modSp add del">
+        <pc:chgData name="Vempi Satriya" userId="c28fa87cdebdc656" providerId="LiveId" clId="{63E91B12-6D81-43DC-90EF-03735CFC9BF7}" dt="2026-08-22T23:50:01.946" v="205"/>
+        <pc:sldMkLst>
+          <pc:docMk/>
+          <pc:sldMk cId="0" sldId="603"/>
+        </pc:sldMkLst>
+        <pc:spChg chg="mod">
+          <ac:chgData name="Vempi Satriya" userId="c28fa87cdebdc656" providerId="LiveId" clId="{63E91B12-6D81-43DC-90EF-03735CFC9BF7}" dt="2026-08-22T23:50:00.885" v="199"/>
+          <ac:spMkLst>
+            <pc:docMk/>
+            <pc:sldMk cId="0" sldId="603"/>
+            <ac:spMk id="4" creationId="{00000000-0000-0000-0000-000000000000}"/>
+          </ac:spMkLst>
+        </pc:spChg>
+      </pc:sldChg>
+      <pc:sldChg chg="addSp delSp modSp add mod">
+        <pc:chgData name="Vempi Satriya" userId="c28fa87cdebdc656" providerId="LiveId" clId="{63E91B12-6D81-43DC-90EF-03735CFC9BF7}" dt="2026-08-23T13:43:41.653" v="734" actId="20577"/>
+        <pc:sldMkLst>
+          <pc:docMk/>
+          <pc:sldMk cId="908832390" sldId="603"/>
+        </pc:sldMkLst>
+        <pc:spChg chg="mod">
+          <ac:chgData name="Vempi Satriya" userId="c28fa87cdebdc656" providerId="LiveId" clId="{63E91B12-6D81-43DC-90EF-03735CFC9BF7}" dt="2026-08-23T13:43:21.236" v="723" actId="20577"/>
+          <ac:spMkLst>
+            <pc:docMk/>
+            <pc:sldMk cId="908832390" sldId="603"/>
+            <ac:spMk id="3" creationId="{F391BFCF-CEBA-BC46-42A9-F24674804D9E}"/>
+          </ac:spMkLst>
+        </pc:spChg>
+        <pc:spChg chg="add del mod">
+          <ac:chgData name="Vempi Satriya" userId="c28fa87cdebdc656" providerId="LiveId" clId="{63E91B12-6D81-43DC-90EF-03735CFC9BF7}" dt="2026-08-23T00:02:01.509" v="445" actId="478"/>
+          <ac:spMkLst>
+            <pc:docMk/>
+            <pc:sldMk cId="908832390" sldId="603"/>
+            <ac:spMk id="5" creationId="{8876AA1A-D6D8-4F35-A020-7370A7F2415B}"/>
+          </ac:spMkLst>
+        </pc:spChg>
+        <pc:spChg chg="del">
+          <ac:chgData name="Vempi Satriya" userId="c28fa87cdebdc656" providerId="LiveId" clId="{63E91B12-6D81-43DC-90EF-03735CFC9BF7}" dt="2026-08-23T00:01:58.080" v="443" actId="478"/>
+          <ac:spMkLst>
+            <pc:docMk/>
+            <pc:sldMk cId="908832390" sldId="603"/>
+            <ac:spMk id="6" creationId="{0924BA41-40CE-F4AB-B43A-57212FE09AED}"/>
+          </ac:spMkLst>
+        </pc:spChg>
+        <pc:spChg chg="del">
+          <ac:chgData name="Vempi Satriya" userId="c28fa87cdebdc656" providerId="LiveId" clId="{63E91B12-6D81-43DC-90EF-03735CFC9BF7}" dt="2026-08-23T00:02:00.405" v="444" actId="478"/>
+          <ac:spMkLst>
+            <pc:docMk/>
+            <pc:sldMk cId="908832390" sldId="603"/>
+            <ac:spMk id="7" creationId="{A2CDDCA1-D852-9649-95F1-29845510ABEF}"/>
+          </ac:spMkLst>
+        </pc:spChg>
+        <pc:spChg chg="add mod">
+          <ac:chgData name="Vempi Satriya" userId="c28fa87cdebdc656" providerId="LiveId" clId="{63E91B12-6D81-43DC-90EF-03735CFC9BF7}" dt="2026-08-23T13:43:41.653" v="734" actId="20577"/>
+          <ac:spMkLst>
+            <pc:docMk/>
+            <pc:sldMk cId="908832390" sldId="603"/>
+            <ac:spMk id="8" creationId="{00000000-0000-0000-0000-000000000000}"/>
+          </ac:spMkLst>
+        </pc:spChg>
+      </pc:sldChg>
+      <pc:sldChg chg="modSp add del">
+        <pc:chgData name="Vempi Satriya" userId="c28fa87cdebdc656" providerId="LiveId" clId="{63E91B12-6D81-43DC-90EF-03735CFC9BF7}" dt="2026-08-22T23:50:01.946" v="205"/>
+        <pc:sldMkLst>
+          <pc:docMk/>
+          <pc:sldMk cId="0" sldId="604"/>
+        </pc:sldMkLst>
+        <pc:spChg chg="mod">
+          <ac:chgData name="Vempi Satriya" userId="c28fa87cdebdc656" providerId="LiveId" clId="{63E91B12-6D81-43DC-90EF-03735CFC9BF7}" dt="2026-08-22T23:50:00.885" v="199"/>
+          <ac:spMkLst>
+            <pc:docMk/>
+            <pc:sldMk cId="0" sldId="604"/>
+            <ac:spMk id="4" creationId="{00000000-0000-0000-0000-000000000000}"/>
+          </ac:spMkLst>
+        </pc:spChg>
+      </pc:sldChg>
+      <pc:sldChg chg="addSp delSp modSp add mod">
+        <pc:chgData name="Vempi Satriya" userId="c28fa87cdebdc656" providerId="LiveId" clId="{63E91B12-6D81-43DC-90EF-03735CFC9BF7}" dt="2026-08-23T13:44:00.955" v="746" actId="20577"/>
+        <pc:sldMkLst>
+          <pc:docMk/>
+          <pc:sldMk cId="54976208" sldId="604"/>
+        </pc:sldMkLst>
+        <pc:spChg chg="mod">
+          <ac:chgData name="Vempi Satriya" userId="c28fa87cdebdc656" providerId="LiveId" clId="{63E91B12-6D81-43DC-90EF-03735CFC9BF7}" dt="2026-08-23T00:02:33.993" v="456" actId="20577"/>
+          <ac:spMkLst>
+            <pc:docMk/>
+            <pc:sldMk cId="54976208" sldId="604"/>
+            <ac:spMk id="3" creationId="{8B621453-71EF-CDCA-C821-BAA8FA3B71F9}"/>
+          </ac:spMkLst>
+        </pc:spChg>
+        <pc:spChg chg="add del mod">
+          <ac:chgData name="Vempi Satriya" userId="c28fa87cdebdc656" providerId="LiveId" clId="{63E91B12-6D81-43DC-90EF-03735CFC9BF7}" dt="2026-08-23T00:02:42.051" v="460" actId="478"/>
+          <ac:spMkLst>
+            <pc:docMk/>
+            <pc:sldMk cId="54976208" sldId="604"/>
+            <ac:spMk id="5" creationId="{32E2EF4C-5209-CEC5-0652-DCAAEFBE7671}"/>
+          </ac:spMkLst>
+        </pc:spChg>
+        <pc:spChg chg="add mod">
+          <ac:chgData name="Vempi Satriya" userId="c28fa87cdebdc656" providerId="LiveId" clId="{63E91B12-6D81-43DC-90EF-03735CFC9BF7}" dt="2026-08-23T13:44:00.955" v="746" actId="20577"/>
+          <ac:spMkLst>
+            <pc:docMk/>
+            <pc:sldMk cId="54976208" sldId="604"/>
+            <ac:spMk id="6" creationId="{00000000-0000-0000-0000-000000000000}"/>
+          </ac:spMkLst>
+        </pc:spChg>
+        <pc:spChg chg="del">
+          <ac:chgData name="Vempi Satriya" userId="c28fa87cdebdc656" providerId="LiveId" clId="{63E91B12-6D81-43DC-90EF-03735CFC9BF7}" dt="2026-08-23T00:02:39.850" v="458" actId="478"/>
+          <ac:spMkLst>
+            <pc:docMk/>
+            <pc:sldMk cId="54976208" sldId="604"/>
+            <ac:spMk id="8" creationId="{42D95736-80F2-2200-8D21-C7BAB6D50E20}"/>
+          </ac:spMkLst>
+        </pc:spChg>
+        <pc:graphicFrameChg chg="add mod">
+          <ac:chgData name="Vempi Satriya" userId="c28fa87cdebdc656" providerId="LiveId" clId="{63E91B12-6D81-43DC-90EF-03735CFC9BF7}" dt="2026-08-23T00:02:40.152" v="459"/>
+          <ac:graphicFrameMkLst>
+            <pc:docMk/>
+            <pc:sldMk cId="54976208" sldId="604"/>
+            <ac:graphicFrameMk id="26625" creationId="{00000000-0000-0000-0000-000000000000}"/>
+          </ac:graphicFrameMkLst>
+        </pc:graphicFrameChg>
+      </pc:sldChg>
+      <pc:sldChg chg="modSp add del">
+        <pc:chgData name="Vempi Satriya" userId="c28fa87cdebdc656" providerId="LiveId" clId="{63E91B12-6D81-43DC-90EF-03735CFC9BF7}" dt="2026-08-22T23:50:01.946" v="205"/>
+        <pc:sldMkLst>
+          <pc:docMk/>
+          <pc:sldMk cId="0" sldId="605"/>
+        </pc:sldMkLst>
+        <pc:spChg chg="mod">
+          <ac:chgData name="Vempi Satriya" userId="c28fa87cdebdc656" providerId="LiveId" clId="{63E91B12-6D81-43DC-90EF-03735CFC9BF7}" dt="2026-08-22T23:50:00.885" v="199"/>
+          <ac:spMkLst>
+            <pc:docMk/>
+            <pc:sldMk cId="0" sldId="605"/>
+            <ac:spMk id="4" creationId="{00000000-0000-0000-0000-000000000000}"/>
+          </ac:spMkLst>
+        </pc:spChg>
+      </pc:sldChg>
+      <pc:sldChg chg="addSp modSp add mod ord">
+        <pc:chgData name="Vempi Satriya" userId="c28fa87cdebdc656" providerId="LiveId" clId="{63E91B12-6D81-43DC-90EF-03735CFC9BF7}" dt="2026-08-23T17:19:33.675" v="795" actId="732"/>
+        <pc:sldMkLst>
+          <pc:docMk/>
+          <pc:sldMk cId="1004775700" sldId="605"/>
+        </pc:sldMkLst>
+        <pc:spChg chg="mod">
+          <ac:chgData name="Vempi Satriya" userId="c28fa87cdebdc656" providerId="LiveId" clId="{63E91B12-6D81-43DC-90EF-03735CFC9BF7}" dt="2026-08-23T17:16:47.962" v="776" actId="113"/>
+          <ac:spMkLst>
+            <pc:docMk/>
+            <pc:sldMk cId="1004775700" sldId="605"/>
+            <ac:spMk id="7" creationId="{4A09EA07-2AB6-5E08-C632-F87CC147CB42}"/>
+          </ac:spMkLst>
+        </pc:spChg>
+        <pc:picChg chg="add mod modCrop">
+          <ac:chgData name="Vempi Satriya" userId="c28fa87cdebdc656" providerId="LiveId" clId="{63E91B12-6D81-43DC-90EF-03735CFC9BF7}" dt="2026-08-23T17:19:33.675" v="795" actId="732"/>
+          <ac:picMkLst>
+            <pc:docMk/>
+            <pc:sldMk cId="1004775700" sldId="605"/>
+            <ac:picMk id="5" creationId="{7811F7B7-43DD-A0F0-6779-71206B8C52ED}"/>
+          </ac:picMkLst>
+        </pc:picChg>
+      </pc:sldChg>
+      <pc:sldChg chg="modSp add del">
+        <pc:chgData name="Vempi Satriya" userId="c28fa87cdebdc656" providerId="LiveId" clId="{63E91B12-6D81-43DC-90EF-03735CFC9BF7}" dt="2026-08-22T23:50:01.946" v="205"/>
+        <pc:sldMkLst>
+          <pc:docMk/>
+          <pc:sldMk cId="0" sldId="606"/>
+        </pc:sldMkLst>
+        <pc:spChg chg="mod">
+          <ac:chgData name="Vempi Satriya" userId="c28fa87cdebdc656" providerId="LiveId" clId="{63E91B12-6D81-43DC-90EF-03735CFC9BF7}" dt="2026-08-22T23:50:00.885" v="199"/>
+          <ac:spMkLst>
+            <pc:docMk/>
+            <pc:sldMk cId="0" sldId="606"/>
+            <ac:spMk id="4" creationId="{00000000-0000-0000-0000-000000000000}"/>
+          </ac:spMkLst>
+        </pc:spChg>
+      </pc:sldChg>
+      <pc:sldChg chg="modSp add del">
+        <pc:chgData name="Vempi Satriya" userId="c28fa87cdebdc656" providerId="LiveId" clId="{63E91B12-6D81-43DC-90EF-03735CFC9BF7}" dt="2026-08-22T23:50:01.946" v="205"/>
+        <pc:sldMkLst>
+          <pc:docMk/>
+          <pc:sldMk cId="0" sldId="607"/>
+        </pc:sldMkLst>
+        <pc:spChg chg="mod">
+          <ac:chgData name="Vempi Satriya" userId="c28fa87cdebdc656" providerId="LiveId" clId="{63E91B12-6D81-43DC-90EF-03735CFC9BF7}" dt="2026-08-22T23:50:00.885" v="199"/>
+          <ac:spMkLst>
+            <pc:docMk/>
+            <pc:sldMk cId="0" sldId="607"/>
+            <ac:spMk id="4" creationId="{00000000-0000-0000-0000-000000000000}"/>
+          </ac:spMkLst>
+        </pc:spChg>
+      </pc:sldChg>
+      <pc:sldChg chg="modSp add del">
+        <pc:chgData name="Vempi Satriya" userId="c28fa87cdebdc656" providerId="LiveId" clId="{63E91B12-6D81-43DC-90EF-03735CFC9BF7}" dt="2026-08-22T23:50:01.946" v="205"/>
+        <pc:sldMkLst>
+          <pc:docMk/>
+          <pc:sldMk cId="0" sldId="608"/>
+        </pc:sldMkLst>
+        <pc:spChg chg="mod">
+          <ac:chgData name="Vempi Satriya" userId="c28fa87cdebdc656" providerId="LiveId" clId="{63E91B12-6D81-43DC-90EF-03735CFC9BF7}" dt="2026-08-22T23:50:00.885" v="199"/>
+          <ac:spMkLst>
+            <pc:docMk/>
+            <pc:sldMk cId="0" sldId="608"/>
+            <ac:spMk id="4" creationId="{00000000-0000-0000-0000-000000000000}"/>
+          </ac:spMkLst>
+        </pc:spChg>
+      </pc:sldChg>
+      <pc:sldChg chg="modSp add del">
+        <pc:chgData name="Vempi Satriya" userId="c28fa87cdebdc656" providerId="LiveId" clId="{63E91B12-6D81-43DC-90EF-03735CFC9BF7}" dt="2026-08-22T23:50:01.946" v="205"/>
+        <pc:sldMkLst>
+          <pc:docMk/>
+          <pc:sldMk cId="0" sldId="609"/>
+        </pc:sldMkLst>
+        <pc:spChg chg="mod">
+          <ac:chgData name="Vempi Satriya" userId="c28fa87cdebdc656" providerId="LiveId" clId="{63E91B12-6D81-43DC-90EF-03735CFC9BF7}" dt="2026-08-22T23:50:00.885" v="199"/>
+          <ac:spMkLst>
+            <pc:docMk/>
+            <pc:sldMk cId="0" sldId="609"/>
+            <ac:spMk id="4" creationId="{00000000-0000-0000-0000-000000000000}"/>
+          </ac:spMkLst>
+        </pc:spChg>
+      </pc:sldChg>
+      <pc:sldChg chg="modSp add del">
+        <pc:chgData name="Vempi Satriya" userId="c28fa87cdebdc656" providerId="LiveId" clId="{63E91B12-6D81-43DC-90EF-03735CFC9BF7}" dt="2026-08-22T23:50:01.946" v="205"/>
+        <pc:sldMkLst>
+          <pc:docMk/>
+          <pc:sldMk cId="0" sldId="610"/>
+        </pc:sldMkLst>
+        <pc:spChg chg="mod">
+          <ac:chgData name="Vempi Satriya" userId="c28fa87cdebdc656" providerId="LiveId" clId="{63E91B12-6D81-43DC-90EF-03735CFC9BF7}" dt="2026-08-22T23:50:00.885" v="199"/>
+          <ac:spMkLst>
+            <pc:docMk/>
+            <pc:sldMk cId="0" sldId="610"/>
+            <ac:spMk id="4" creationId="{00000000-0000-0000-0000-000000000000}"/>
+          </ac:spMkLst>
+        </pc:spChg>
+      </pc:sldChg>
+      <pc:sldChg chg="modSp add del">
+        <pc:chgData name="Vempi Satriya" userId="c28fa87cdebdc656" providerId="LiveId" clId="{63E91B12-6D81-43DC-90EF-03735CFC9BF7}" dt="2026-08-22T23:50:01.946" v="205"/>
+        <pc:sldMkLst>
+          <pc:docMk/>
+          <pc:sldMk cId="0" sldId="611"/>
+        </pc:sldMkLst>
+        <pc:spChg chg="mod">
+          <ac:chgData name="Vempi Satriya" userId="c28fa87cdebdc656" providerId="LiveId" clId="{63E91B12-6D81-43DC-90EF-03735CFC9BF7}" dt="2026-08-22T23:50:00.885" v="199"/>
+          <ac:spMkLst>
+            <pc:docMk/>
+            <pc:sldMk cId="0" sldId="611"/>
+            <ac:spMk id="4" creationId="{00000000-0000-0000-0000-000000000000}"/>
+          </ac:spMkLst>
+        </pc:spChg>
+      </pc:sldChg>
+      <pc:sldChg chg="modSp add del">
+        <pc:chgData name="Vempi Satriya" userId="c28fa87cdebdc656" providerId="LiveId" clId="{63E91B12-6D81-43DC-90EF-03735CFC9BF7}" dt="2026-08-22T23:50:01.946" v="205"/>
+        <pc:sldMkLst>
+          <pc:docMk/>
+          <pc:sldMk cId="0" sldId="612"/>
+        </pc:sldMkLst>
+        <pc:spChg chg="mod">
+          <ac:chgData name="Vempi Satriya" userId="c28fa87cdebdc656" providerId="LiveId" clId="{63E91B12-6D81-43DC-90EF-03735CFC9BF7}" dt="2026-08-22T23:50:00.885" v="199"/>
+          <ac:spMkLst>
+            <pc:docMk/>
+            <pc:sldMk cId="0" sldId="612"/>
+            <ac:spMk id="4" creationId="{00000000-0000-0000-0000-000000000000}"/>
+          </ac:spMkLst>
+        </pc:spChg>
+      </pc:sldChg>
+      <pc:sldChg chg="modSp add del mod ord">
+        <pc:chgData name="Vempi Satriya" userId="c28fa87cdebdc656" providerId="LiveId" clId="{63E91B12-6D81-43DC-90EF-03735CFC9BF7}" dt="2026-08-22T23:45:26.015" v="52" actId="47"/>
+        <pc:sldMkLst>
+          <pc:docMk/>
+          <pc:sldMk cId="2566782280" sldId="675"/>
+        </pc:sldMkLst>
+        <pc:spChg chg="mod">
+          <ac:chgData name="Vempi Satriya" userId="c28fa87cdebdc656" providerId="LiveId" clId="{63E91B12-6D81-43DC-90EF-03735CFC9BF7}" dt="2026-08-22T23:45:16.153" v="51" actId="20577"/>
+          <ac:spMkLst>
+            <pc:docMk/>
+            <pc:sldMk cId="2566782280" sldId="675"/>
+            <ac:spMk id="2" creationId="{49F57B89-E735-2445-E211-2F43000213C9}"/>
           </ac:spMkLst>
         </pc:spChg>
       </pc:sldChg>
@@ -349,7 +2966,7 @@
           <a:p>
             <a:fld id="{E738AAE6-B219-4749-AA81-4CD678541CFD}" type="datetimeFigureOut">
               <a:rPr lang="en-US" smtClean="0"/>
-              <a:t>8/27/2026</a:t>
+              <a:t>8/24/2026</a:t>
             </a:fld>
             <a:endParaRPr lang="en-US"/>
           </a:p>
@@ -765,7 +3382,7 @@
           <a:p>
             <a:fld id="{1D8BD707-D9CF-40AE-B4C6-C98DA3205C09}" type="datetimeFigureOut">
               <a:rPr lang="en-US"/>
-              <a:t>8/27/2026</a:t>
+              <a:t>8/24/2026</a:t>
             </a:fld>
             <a:endParaRPr lang="en-US"/>
           </a:p>
@@ -940,7 +3557,7 @@
           <a:p>
             <a:fld id="{1D8BD707-D9CF-40AE-B4C6-C98DA3205C09}" type="datetimeFigureOut">
               <a:rPr lang="en-US"/>
-              <a:t>8/27/2026</a:t>
+              <a:t>8/24/2026</a:t>
             </a:fld>
             <a:endParaRPr lang="en-US"/>
           </a:p>
@@ -1154,7 +3771,7 @@
           <a:p>
             <a:fld id="{1D8BD707-D9CF-40AE-B4C6-C98DA3205C09}" type="datetimeFigureOut">
               <a:rPr lang="en-US"/>
-              <a:t>8/27/2026</a:t>
+              <a:t>8/24/2026</a:t>
             </a:fld>
             <a:endParaRPr lang="en-US"/>
           </a:p>
@@ -1302,7 +3919,7 @@
           <a:p>
             <a:fld id="{1D8BD707-D9CF-40AE-B4C6-C98DA3205C09}" type="datetimeFigureOut">
               <a:rPr lang="en-US"/>
-              <a:t>8/27/2026</a:t>
+              <a:t>8/24/2026</a:t>
             </a:fld>
             <a:endParaRPr lang="en-US"/>
           </a:p>
@@ -1421,7 +4038,7 @@
           <a:p>
             <a:fld id="{1D8BD707-D9CF-40AE-B4C6-C98DA3205C09}" type="datetimeFigureOut">
               <a:rPr lang="en-US"/>
-              <a:t>8/27/2026</a:t>
+              <a:t>8/24/2026</a:t>
             </a:fld>
             <a:endParaRPr lang="en-US"/>
           </a:p>
@@ -4178,7 +6795,7 @@
           <a:p>
             <a:fld id="{1D8BD707-D9CF-40AE-B4C6-C98DA3205C09}" type="datetimeFigureOut">
               <a:rPr lang="en-US"/>
-              <a:t>8/27/2026</a:t>
+              <a:t>8/24/2026</a:t>
             </a:fld>
             <a:endParaRPr lang="en-US"/>
           </a:p>
@@ -4385,7 +7002,7 @@
 </file>
 
 <file path=ppt/slides/slide1.xml><?xml version="1.0" encoding="utf-8"?>
-<p:sld xmlns:a="http://schemas.openxmlformats.org/drawingml/2006/main" xmlns:r="http://schemas.openxmlformats.org/officeDocument/2006/relationships" xmlns:p="http://schemas.openxmlformats.org/presentationml/2006/main">
+<p:sld xmlns:a="http://schemas.openxmlformats.org/drawingml/2006/main" xmlns:p="http://schemas.openxmlformats.org/presentationml/2006/main" xmlns:r="http://schemas.openxmlformats.org/officeDocument/2006/relationships">
   <p:cSld>
     <p:spTree>
       <p:nvGrpSpPr>
@@ -4393,14 +7010,7 @@
         <p:cNvGrpSpPr/>
         <p:nvPr/>
       </p:nvGrpSpPr>
-      <p:grpSpPr>
-        <a:xfrm>
-          <a:off x="0" y="0"/>
-          <a:ext cx="0" cy="0"/>
-          <a:chOff x="0" y="0"/>
-          <a:chExt cx="0" cy="0"/>
-        </a:xfrm>
-      </p:grpSpPr>
+      <p:grpSpPr/>
       <p:sp>
         <p:nvSpPr>
           <p:cNvPr id="2" name="Title 1"/>
@@ -4411,12 +7021,7 @@
             <p:ph type="ctrTitle"/>
           </p:nvPr>
         </p:nvSpPr>
-        <p:spPr>
-          <a:xfrm>
-            <a:off x="590551" y="641205"/>
-            <a:ext cx="7116536" cy="454028"/>
-          </a:xfrm>
-        </p:spPr>
+        <p:spPr/>
         <p:txBody>
           <a:bodyPr/>
           <a:lstStyle/>
@@ -4427,14 +7032,12 @@
               </a:lnSpc>
             </a:pPr>
             <a:r>
-              <a:rPr lang="en-US" sz="2800" dirty="0"/>
+              <a:rPr sz="3400"/>
               <a:t>Algorithms and Computer Programming</a:t>
             </a:r>
-            <a:br>
-              <a:rPr dirty="0"/>
-            </a:br>
-            <a:r>
-              <a:rPr sz="1900" b="0" i="1" dirty="0">
+            <a:br/>
+            <a:r>
+              <a:rPr sz="1900" i="1" b="0">
                 <a:solidFill>
                   <a:srgbClr val="000000"/>
                 </a:solidFill>
@@ -4451,7 +7054,7 @@
             <a:spLocks noGrp="1"/>
           </p:cNvSpPr>
           <p:nvPr>
-            <p:ph type="body" sz="quarter" idx="13"/>
+            <p:ph type="body" idx="13" sz="quarter"/>
           </p:nvPr>
         </p:nvSpPr>
         <p:spPr/>
@@ -4472,7 +7075,7 @@
             <a:spLocks noGrp="1"/>
           </p:cNvSpPr>
           <p:nvPr>
-            <p:ph type="body" sz="quarter" idx="14"/>
+            <p:ph type="body" idx="14" sz="quarter"/>
           </p:nvPr>
         </p:nvSpPr>
         <p:spPr/>
@@ -4493,7 +7096,7 @@
             <a:spLocks noGrp="1"/>
           </p:cNvSpPr>
           <p:nvPr>
-            <p:ph type="body" sz="quarter" idx="15"/>
+            <p:ph type="body" idx="15" sz="quarter"/>
           </p:nvPr>
         </p:nvSpPr>
         <p:spPr/>
@@ -4519,7 +7122,7 @@
             <a:spLocks noGrp="1"/>
           </p:cNvSpPr>
           <p:nvPr>
-            <p:ph type="body" sz="quarter" idx="16"/>
+            <p:ph type="body" idx="16" sz="quarter"/>
           </p:nvPr>
         </p:nvSpPr>
         <p:spPr/>
@@ -4547,7 +7150,7 @@
 </file>
 
 <file path=ppt/slides/slide10.xml><?xml version="1.0" encoding="utf-8"?>
-<p:sld xmlns:a="http://schemas.openxmlformats.org/drawingml/2006/main" xmlns:r="http://schemas.openxmlformats.org/officeDocument/2006/relationships" xmlns:p="http://schemas.openxmlformats.org/presentationml/2006/main">
+<p:sld xmlns:a="http://schemas.openxmlformats.org/drawingml/2006/main" xmlns:p="http://schemas.openxmlformats.org/presentationml/2006/main" xmlns:r="http://schemas.openxmlformats.org/officeDocument/2006/relationships">
   <p:cSld>
     <p:spTree>
       <p:nvGrpSpPr>
@@ -4555,14 +7158,7 @@
         <p:cNvGrpSpPr/>
         <p:nvPr/>
       </p:nvGrpSpPr>
-      <p:grpSpPr>
-        <a:xfrm>
-          <a:off x="0" y="0"/>
-          <a:ext cx="0" cy="0"/>
-          <a:chOff x="0" y="0"/>
-          <a:chExt cx="0" cy="0"/>
-        </a:xfrm>
-      </p:grpSpPr>
+      <p:grpSpPr/>
       <p:sp>
         <p:nvSpPr>
           <p:cNvPr id="2" name="Content Placeholder 1"/>
@@ -4577,9 +7173,7 @@
         <p:txBody>
           <a:bodyPr/>
           <a:lstStyle/>
-          <a:p>
-            <a:endParaRPr/>
-          </a:p>
+          <a:p/>
         </p:txBody>
       </p:sp>
       <p:sp>
@@ -4589,7 +7183,7 @@
             <a:spLocks noGrp="1"/>
           </p:cNvSpPr>
           <p:nvPr>
-            <p:ph type="body" sz="quarter" idx="13"/>
+            <p:ph type="body" idx="13" sz="quarter"/>
           </p:nvPr>
         </p:nvSpPr>
         <p:spPr/>
@@ -4612,7 +7206,7 @@
 </file>
 
 <file path=ppt/slides/slide11.xml><?xml version="1.0" encoding="utf-8"?>
-<p:sld xmlns:a="http://schemas.openxmlformats.org/drawingml/2006/main" xmlns:r="http://schemas.openxmlformats.org/officeDocument/2006/relationships" xmlns:p="http://schemas.openxmlformats.org/presentationml/2006/main">
+<p:sld xmlns:a="http://schemas.openxmlformats.org/drawingml/2006/main" xmlns:p="http://schemas.openxmlformats.org/presentationml/2006/main" xmlns:r="http://schemas.openxmlformats.org/officeDocument/2006/relationships">
   <p:cSld>
     <p:spTree>
       <p:nvGrpSpPr>
@@ -4620,14 +7214,7 @@
         <p:cNvGrpSpPr/>
         <p:nvPr/>
       </p:nvGrpSpPr>
-      <p:grpSpPr>
-        <a:xfrm>
-          <a:off x="0" y="0"/>
-          <a:ext cx="0" cy="0"/>
-          <a:chOff x="0" y="0"/>
-          <a:chExt cx="0" cy="0"/>
-        </a:xfrm>
-      </p:grpSpPr>
+      <p:grpSpPr/>
       <p:sp>
         <p:nvSpPr>
           <p:cNvPr id="2" name="Content Placeholder 1"/>
@@ -4670,7 +7257,7 @@
             <a:spLocks noGrp="1"/>
           </p:cNvSpPr>
           <p:nvPr>
-            <p:ph type="body" sz="quarter" idx="13"/>
+            <p:ph type="body" idx="13" sz="quarter"/>
           </p:nvPr>
         </p:nvSpPr>
         <p:spPr/>
@@ -4723,8 +7310,27 @@
           </a:fontRef>
         </p:style>
         <p:txBody>
-          <a:bodyPr wrap="square" lIns="137160" tIns="91440" rIns="137160" bIns="91440" rtlCol="0" anchor="ctr"/>
+          <a:bodyPr rtlCol="0" anchor="ctr" wrap="square" lIns="137160" rIns="137160" tIns="91440" bIns="91440"/>
           <a:lstStyle/>
+          <a:p>
+            <a:pPr algn="l" marL="0" indent="0">
+              <a:spcBef>
+                <a:spcPts val="200"/>
+              </a:spcBef>
+              <a:spcAft>
+                <a:spcPts val="200"/>
+              </a:spcAft>
+              <a:buNone/>
+            </a:pPr>
+            <a:r>
+              <a:rPr sz="1050">
+                <a:solidFill>
+                  <a:srgbClr val="404040"/>
+                </a:solidFill>
+              </a:rPr>
+              <a:t>Option Explicit</a:t>
+            </a:r>
+          </a:p>
           <a:p>
             <a:pPr marL="0" indent="0" algn="l">
               <a:spcBef>
@@ -4735,30 +7341,6 @@
               </a:spcAft>
               <a:buNone/>
             </a:pPr>
-            <a:r>
-              <a:rPr sz="1050">
-                <a:solidFill>
-                  <a:srgbClr val="404040"/>
-                </a:solidFill>
-              </a:rPr>
-              <a:t>Option Explicit</a:t>
-            </a:r>
-          </a:p>
-          <a:p>
-            <a:pPr marL="0" indent="0" algn="l">
-              <a:spcBef>
-                <a:spcPts val="200"/>
-              </a:spcBef>
-              <a:spcAft>
-                <a:spcPts val="200"/>
-              </a:spcAft>
-              <a:buNone/>
-            </a:pPr>
-            <a:endParaRPr sz="1050">
-              <a:solidFill>
-                <a:srgbClr val="404040"/>
-              </a:solidFill>
-            </a:endParaRPr>
           </a:p>
           <a:p>
             <a:pPr marL="0" indent="0" algn="l">
@@ -4953,10 +7535,10 @@
           </a:fontRef>
         </p:style>
         <p:txBody>
-          <a:bodyPr wrap="square" lIns="137160" tIns="91440" rIns="137160" bIns="91440" rtlCol="0" anchor="ctr"/>
+          <a:bodyPr rtlCol="0" anchor="ctr" wrap="square" lIns="137160" rIns="137160" tIns="91440" bIns="91440"/>
           <a:lstStyle/>
           <a:p>
-            <a:pPr marL="0" indent="0" algn="l">
+            <a:pPr algn="l" marL="0" indent="0">
               <a:spcBef>
                 <a:spcPts val="200"/>
               </a:spcBef>
@@ -4985,7 +7567,7 @@
 </file>
 
 <file path=ppt/slides/slide12.xml><?xml version="1.0" encoding="utf-8"?>
-<p:sld xmlns:a="http://schemas.openxmlformats.org/drawingml/2006/main" xmlns:r="http://schemas.openxmlformats.org/officeDocument/2006/relationships" xmlns:p="http://schemas.openxmlformats.org/presentationml/2006/main">
+<p:sld xmlns:a="http://schemas.openxmlformats.org/drawingml/2006/main" xmlns:p="http://schemas.openxmlformats.org/presentationml/2006/main" xmlns:r="http://schemas.openxmlformats.org/officeDocument/2006/relationships">
   <p:cSld>
     <p:spTree>
       <p:nvGrpSpPr>
@@ -4993,14 +7575,7 @@
         <p:cNvGrpSpPr/>
         <p:nvPr/>
       </p:nvGrpSpPr>
-      <p:grpSpPr>
-        <a:xfrm>
-          <a:off x="0" y="0"/>
-          <a:ext cx="0" cy="0"/>
-          <a:chOff x="0" y="0"/>
-          <a:chExt cx="0" cy="0"/>
-        </a:xfrm>
-      </p:grpSpPr>
+      <p:grpSpPr/>
       <p:sp>
         <p:nvSpPr>
           <p:cNvPr id="2" name="Content Placeholder 1"/>
@@ -5072,7 +7647,7 @@
             <a:spLocks noGrp="1"/>
           </p:cNvSpPr>
           <p:nvPr>
-            <p:ph type="body" sz="quarter" idx="13"/>
+            <p:ph type="body" idx="13" sz="quarter"/>
           </p:nvPr>
         </p:nvSpPr>
         <p:spPr/>
@@ -5095,7 +7670,7 @@
 </file>
 
 <file path=ppt/slides/slide13.xml><?xml version="1.0" encoding="utf-8"?>
-<p:sld xmlns:a="http://schemas.openxmlformats.org/drawingml/2006/main" xmlns:r="http://schemas.openxmlformats.org/officeDocument/2006/relationships" xmlns:p="http://schemas.openxmlformats.org/presentationml/2006/main">
+<p:sld xmlns:a="http://schemas.openxmlformats.org/drawingml/2006/main" xmlns:p="http://schemas.openxmlformats.org/presentationml/2006/main" xmlns:r="http://schemas.openxmlformats.org/officeDocument/2006/relationships">
   <p:cSld>
     <p:spTree>
       <p:nvGrpSpPr>
@@ -5103,14 +7678,7 @@
         <p:cNvGrpSpPr/>
         <p:nvPr/>
       </p:nvGrpSpPr>
-      <p:grpSpPr>
-        <a:xfrm>
-          <a:off x="0" y="0"/>
-          <a:ext cx="0" cy="0"/>
-          <a:chOff x="0" y="0"/>
-          <a:chExt cx="0" cy="0"/>
-        </a:xfrm>
-      </p:grpSpPr>
+      <p:grpSpPr/>
       <p:sp>
         <p:nvSpPr>
           <p:cNvPr id="2" name="Content Placeholder 1"/>
@@ -5156,7 +7724,7 @@
             </a:pPr>
             <a:r>
               <a:rPr sz="1450"/>
-              <a:t>Convert binary 10110 to decimal and show the weight of every digit.</a:t>
+              <a:t>If a user fills B1 and B2 then runs ExcelDemo, order the flow through input, Excel, VBA, CPU/memory, worksheet, and output.</a:t>
             </a:r>
           </a:p>
           <a:p>
@@ -5198,7 +7766,7 @@
             <a:spLocks noGrp="1"/>
           </p:cNvSpPr>
           <p:nvPr>
-            <p:ph type="body" sz="quarter" idx="13"/>
+            <p:ph type="body" idx="13" sz="quarter"/>
           </p:nvPr>
         </p:nvSpPr>
         <p:spPr/>
@@ -5207,7 +7775,7 @@
           <a:lstStyle/>
           <a:p>
             <a:r>
-              <a:t>Short Quiz</a:t>
+              <a:t>Short Exercise</a:t>
             </a:r>
           </a:p>
         </p:txBody>
@@ -5221,7 +7789,7 @@
 </file>
 
 <file path=ppt/slides/slide14.xml><?xml version="1.0" encoding="utf-8"?>
-<p:sld xmlns:a="http://schemas.openxmlformats.org/drawingml/2006/main" xmlns:r="http://schemas.openxmlformats.org/officeDocument/2006/relationships" xmlns:p="http://schemas.openxmlformats.org/presentationml/2006/main">
+<p:sld xmlns:a="http://schemas.openxmlformats.org/drawingml/2006/main" xmlns:p="http://schemas.openxmlformats.org/presentationml/2006/main" xmlns:r="http://schemas.openxmlformats.org/officeDocument/2006/relationships">
   <p:cSld>
     <p:spTree>
       <p:nvGrpSpPr>
@@ -5229,14 +7797,7 @@
         <p:cNvGrpSpPr/>
         <p:nvPr/>
       </p:nvGrpSpPr>
-      <p:grpSpPr>
-        <a:xfrm>
-          <a:off x="0" y="0"/>
-          <a:ext cx="0" cy="0"/>
-          <a:chOff x="0" y="0"/>
-          <a:chExt cx="0" cy="0"/>
-        </a:xfrm>
-      </p:grpSpPr>
+      <p:grpSpPr/>
       <p:sp>
         <p:nvSpPr>
           <p:cNvPr id="2" name="Content Placeholder 1"/>
@@ -5308,7 +7869,7 @@
             <a:spLocks noGrp="1"/>
           </p:cNvSpPr>
           <p:nvPr>
-            <p:ph type="body" sz="quarter" idx="13"/>
+            <p:ph type="body" idx="13" sz="quarter"/>
           </p:nvPr>
         </p:nvSpPr>
         <p:spPr/>
@@ -5331,7 +7892,7 @@
 </file>
 
 <file path=ppt/slides/slide15.xml><?xml version="1.0" encoding="utf-8"?>
-<p:sld xmlns:a="http://schemas.openxmlformats.org/drawingml/2006/main" xmlns:r="http://schemas.openxmlformats.org/officeDocument/2006/relationships" xmlns:p="http://schemas.openxmlformats.org/presentationml/2006/main">
+<p:sld xmlns:a="http://schemas.openxmlformats.org/drawingml/2006/main" xmlns:p="http://schemas.openxmlformats.org/presentationml/2006/main" xmlns:r="http://schemas.openxmlformats.org/officeDocument/2006/relationships">
   <p:cSld>
     <p:spTree>
       <p:nvGrpSpPr>
@@ -5339,14 +7900,7 @@
         <p:cNvGrpSpPr/>
         <p:nvPr/>
       </p:nvGrpSpPr>
-      <p:grpSpPr>
-        <a:xfrm>
-          <a:off x="0" y="0"/>
-          <a:ext cx="0" cy="0"/>
-          <a:chOff x="0" y="0"/>
-          <a:chExt cx="0" cy="0"/>
-        </a:xfrm>
-      </p:grpSpPr>
+      <p:grpSpPr/>
       <p:sp>
         <p:nvSpPr>
           <p:cNvPr id="2" name="Content Placeholder 1"/>
@@ -5390,7 +7944,7 @@
             <a:spLocks noGrp="1"/>
           </p:cNvSpPr>
           <p:nvPr>
-            <p:ph type="body" sz="quarter" idx="13"/>
+            <p:ph type="body" idx="13" sz="quarter"/>
           </p:nvPr>
         </p:nvSpPr>
         <p:spPr/>
@@ -5413,7 +7967,7 @@
 </file>
 
 <file path=ppt/slides/slide2.xml><?xml version="1.0" encoding="utf-8"?>
-<p:sld xmlns:a="http://schemas.openxmlformats.org/drawingml/2006/main" xmlns:r="http://schemas.openxmlformats.org/officeDocument/2006/relationships" xmlns:p="http://schemas.openxmlformats.org/presentationml/2006/main">
+<p:sld xmlns:a="http://schemas.openxmlformats.org/drawingml/2006/main" xmlns:p="http://schemas.openxmlformats.org/presentationml/2006/main" xmlns:r="http://schemas.openxmlformats.org/officeDocument/2006/relationships">
   <p:cSld>
     <p:spTree>
       <p:nvGrpSpPr>
@@ -5421,14 +7975,7 @@
         <p:cNvGrpSpPr/>
         <p:nvPr/>
       </p:nvGrpSpPr>
-      <p:grpSpPr>
-        <a:xfrm>
-          <a:off x="0" y="0"/>
-          <a:ext cx="0" cy="0"/>
-          <a:chOff x="0" y="0"/>
-          <a:chExt cx="0" cy="0"/>
-        </a:xfrm>
-      </p:grpSpPr>
+      <p:grpSpPr/>
       <p:sp>
         <p:nvSpPr>
           <p:cNvPr id="2" name="Content Placeholder 1"/>
@@ -5527,7 +8074,7 @@
             <a:spLocks noGrp="1"/>
           </p:cNvSpPr>
           <p:nvPr>
-            <p:ph type="body" sz="quarter" idx="13"/>
+            <p:ph type="body" idx="13" sz="quarter"/>
           </p:nvPr>
         </p:nvSpPr>
         <p:spPr/>
@@ -5550,7 +8097,7 @@
 </file>
 
 <file path=ppt/slides/slide3.xml><?xml version="1.0" encoding="utf-8"?>
-<p:sld xmlns:a="http://schemas.openxmlformats.org/drawingml/2006/main" xmlns:r="http://schemas.openxmlformats.org/officeDocument/2006/relationships" xmlns:p="http://schemas.openxmlformats.org/presentationml/2006/main">
+<p:sld xmlns:a="http://schemas.openxmlformats.org/drawingml/2006/main" xmlns:p="http://schemas.openxmlformats.org/presentationml/2006/main" xmlns:r="http://schemas.openxmlformats.org/officeDocument/2006/relationships">
   <p:cSld>
     <p:spTree>
       <p:nvGrpSpPr>
@@ -5558,14 +8105,7 @@
         <p:cNvGrpSpPr/>
         <p:nvPr/>
       </p:nvGrpSpPr>
-      <p:grpSpPr>
-        <a:xfrm>
-          <a:off x="0" y="0"/>
-          <a:ext cx="0" cy="0"/>
-          <a:chOff x="0" y="0"/>
-          <a:chExt cx="0" cy="0"/>
-        </a:xfrm>
-      </p:grpSpPr>
+      <p:grpSpPr/>
       <p:sp>
         <p:nvSpPr>
           <p:cNvPr id="2" name="Content Placeholder 1"/>
@@ -5649,7 +8189,7 @@
             <a:spLocks noGrp="1"/>
           </p:cNvSpPr>
           <p:nvPr>
-            <p:ph type="body" sz="quarter" idx="13"/>
+            <p:ph type="body" idx="13" sz="quarter"/>
           </p:nvPr>
         </p:nvSpPr>
         <p:spPr/>
@@ -5672,7 +8212,7 @@
 </file>
 
 <file path=ppt/slides/slide4.xml><?xml version="1.0" encoding="utf-8"?>
-<p:sld xmlns:a="http://schemas.openxmlformats.org/drawingml/2006/main" xmlns:r="http://schemas.openxmlformats.org/officeDocument/2006/relationships" xmlns:p="http://schemas.openxmlformats.org/presentationml/2006/main">
+<p:sld xmlns:a="http://schemas.openxmlformats.org/drawingml/2006/main" xmlns:p="http://schemas.openxmlformats.org/presentationml/2006/main" xmlns:r="http://schemas.openxmlformats.org/officeDocument/2006/relationships">
   <p:cSld>
     <p:spTree>
       <p:nvGrpSpPr>
@@ -5680,14 +8220,7 @@
         <p:cNvGrpSpPr/>
         <p:nvPr/>
       </p:nvGrpSpPr>
-      <p:grpSpPr>
-        <a:xfrm>
-          <a:off x="0" y="0"/>
-          <a:ext cx="0" cy="0"/>
-          <a:chOff x="0" y="0"/>
-          <a:chExt cx="0" cy="0"/>
-        </a:xfrm>
-      </p:grpSpPr>
+      <p:grpSpPr/>
       <p:sp>
         <p:nvSpPr>
           <p:cNvPr id="2" name="Content Placeholder 1"/>
@@ -5730,7 +8263,7 @@
             <a:spLocks noGrp="1"/>
           </p:cNvSpPr>
           <p:nvPr>
-            <p:ph type="body" sz="quarter" idx="13"/>
+            <p:ph type="body" idx="13" sz="quarter"/>
           </p:nvPr>
         </p:nvSpPr>
         <p:spPr/>
@@ -5763,27 +8296,9 @@
                 <a:tableStyleId>{5C22544A-7EE6-4342-B048-85BDC9FD1C3A}</a:tableStyleId>
               </a:tblPr>
               <a:tblGrid>
-                <a:gridCol w="1051560">
-                  <a:extLst>
-                    <a:ext uri="{9D8B030D-6E8A-4147-A177-3AD203B41FA5}">
-                      <a16:colId xmlns:a16="http://schemas.microsoft.com/office/drawing/2014/main" val="20000"/>
-                    </a:ext>
-                  </a:extLst>
-                </a:gridCol>
-                <a:gridCol w="3794760">
-                  <a:extLst>
-                    <a:ext uri="{9D8B030D-6E8A-4147-A177-3AD203B41FA5}">
-                      <a16:colId xmlns:a16="http://schemas.microsoft.com/office/drawing/2014/main" val="20001"/>
-                    </a:ext>
-                  </a:extLst>
-                </a:gridCol>
-                <a:gridCol w="2971800">
-                  <a:extLst>
-                    <a:ext uri="{9D8B030D-6E8A-4147-A177-3AD203B41FA5}">
-                      <a16:colId xmlns:a16="http://schemas.microsoft.com/office/drawing/2014/main" val="20002"/>
-                    </a:ext>
-                  </a:extLst>
-                </a:gridCol>
+                <a:gridCol w="1051560"/>
+                <a:gridCol w="3794760"/>
+                <a:gridCol w="2971800"/>
               </a:tblGrid>
               <a:tr h="337185">
                 <a:tc>
@@ -5852,11 +8367,6 @@
                     </a:solidFill>
                   </a:tcPr>
                 </a:tc>
-                <a:extLst>
-                  <a:ext uri="{0D108BD9-81ED-4DB2-BD59-A6C34878D82A}">
-                    <a16:rowId xmlns:a16="http://schemas.microsoft.com/office/drawing/2014/main" val="10000"/>
-                  </a:ext>
-                </a:extLst>
               </a:tr>
               <a:tr h="337185">
                 <a:tc>
@@ -5925,11 +8435,6 @@
                     </a:solidFill>
                   </a:tcPr>
                 </a:tc>
-                <a:extLst>
-                  <a:ext uri="{0D108BD9-81ED-4DB2-BD59-A6C34878D82A}">
-                    <a16:rowId xmlns:a16="http://schemas.microsoft.com/office/drawing/2014/main" val="10001"/>
-                  </a:ext>
-                </a:extLst>
               </a:tr>
               <a:tr h="337185">
                 <a:tc>
@@ -5998,11 +8503,6 @@
                     </a:solidFill>
                   </a:tcPr>
                 </a:tc>
-                <a:extLst>
-                  <a:ext uri="{0D108BD9-81ED-4DB2-BD59-A6C34878D82A}">
-                    <a16:rowId xmlns:a16="http://schemas.microsoft.com/office/drawing/2014/main" val="10002"/>
-                  </a:ext>
-                </a:extLst>
               </a:tr>
               <a:tr h="337185">
                 <a:tc>
@@ -6071,11 +8571,6 @@
                     </a:solidFill>
                   </a:tcPr>
                 </a:tc>
-                <a:extLst>
-                  <a:ext uri="{0D108BD9-81ED-4DB2-BD59-A6C34878D82A}">
-                    <a16:rowId xmlns:a16="http://schemas.microsoft.com/office/drawing/2014/main" val="10003"/>
-                  </a:ext>
-                </a:extLst>
               </a:tr>
               <a:tr h="337185">
                 <a:tc>
@@ -6144,11 +8639,6 @@
                     </a:solidFill>
                   </a:tcPr>
                 </a:tc>
-                <a:extLst>
-                  <a:ext uri="{0D108BD9-81ED-4DB2-BD59-A6C34878D82A}">
-                    <a16:rowId xmlns:a16="http://schemas.microsoft.com/office/drawing/2014/main" val="10004"/>
-                  </a:ext>
-                </a:extLst>
               </a:tr>
               <a:tr h="337185">
                 <a:tc>
@@ -6217,11 +8707,6 @@
                     </a:solidFill>
                   </a:tcPr>
                 </a:tc>
-                <a:extLst>
-                  <a:ext uri="{0D108BD9-81ED-4DB2-BD59-A6C34878D82A}">
-                    <a16:rowId xmlns:a16="http://schemas.microsoft.com/office/drawing/2014/main" val="10005"/>
-                  </a:ext>
-                </a:extLst>
               </a:tr>
               <a:tr h="337185">
                 <a:tc>
@@ -6290,11 +8775,6 @@
                     </a:solidFill>
                   </a:tcPr>
                 </a:tc>
-                <a:extLst>
-                  <a:ext uri="{0D108BD9-81ED-4DB2-BD59-A6C34878D82A}">
-                    <a16:rowId xmlns:a16="http://schemas.microsoft.com/office/drawing/2014/main" val="10006"/>
-                  </a:ext>
-                </a:extLst>
               </a:tr>
               <a:tr h="337185">
                 <a:tc>
@@ -6331,7 +8811,7 @@
                             <a:srgbClr val="404040"/>
                           </a:solidFill>
                         </a:rPr>
-                        <a:t>Quiz, discussion, exit ticket</a:t>
+                        <a:t>Exercise, discussion, exit ticket</a:t>
                       </a:r>
                     </a:p>
                   </a:txBody>
@@ -6363,11 +8843,6 @@
                     </a:solidFill>
                   </a:tcPr>
                 </a:tc>
-                <a:extLst>
-                  <a:ext uri="{0D108BD9-81ED-4DB2-BD59-A6C34878D82A}">
-                    <a16:rowId xmlns:a16="http://schemas.microsoft.com/office/drawing/2014/main" val="10007"/>
-                  </a:ext>
-                </a:extLst>
               </a:tr>
             </a:tbl>
           </a:graphicData>
@@ -6382,7 +8857,7 @@
 </file>
 
 <file path=ppt/slides/slide5.xml><?xml version="1.0" encoding="utf-8"?>
-<p:sld xmlns:a="http://schemas.openxmlformats.org/drawingml/2006/main" xmlns:r="http://schemas.openxmlformats.org/officeDocument/2006/relationships" xmlns:p="http://schemas.openxmlformats.org/presentationml/2006/main">
+<p:sld xmlns:a="http://schemas.openxmlformats.org/drawingml/2006/main" xmlns:p="http://schemas.openxmlformats.org/presentationml/2006/main" xmlns:r="http://schemas.openxmlformats.org/officeDocument/2006/relationships">
   <p:cSld>
     <p:spTree>
       <p:nvGrpSpPr>
@@ -6390,14 +8865,7 @@
         <p:cNvGrpSpPr/>
         <p:nvPr/>
       </p:nvGrpSpPr>
-      <p:grpSpPr>
-        <a:xfrm>
-          <a:off x="0" y="0"/>
-          <a:ext cx="0" cy="0"/>
-          <a:chOff x="0" y="0"/>
-          <a:chExt cx="0" cy="0"/>
-        </a:xfrm>
-      </p:grpSpPr>
+      <p:grpSpPr/>
       <p:sp>
         <p:nvSpPr>
           <p:cNvPr id="2" name="Content Placeholder 1"/>
@@ -6412,9 +8880,7 @@
         <p:txBody>
           <a:bodyPr/>
           <a:lstStyle/>
-          <a:p>
-            <a:endParaRPr/>
-          </a:p>
+          <a:p/>
         </p:txBody>
       </p:sp>
       <p:sp>
@@ -6424,7 +8890,7 @@
             <a:spLocks noGrp="1"/>
           </p:cNvSpPr>
           <p:nvPr>
-            <p:ph type="body" sz="quarter" idx="13"/>
+            <p:ph type="body" idx="13" sz="quarter"/>
           </p:nvPr>
         </p:nvSpPr>
         <p:spPr/>
@@ -6447,7 +8913,7 @@
 </file>
 
 <file path=ppt/slides/slide6.xml><?xml version="1.0" encoding="utf-8"?>
-<p:sld xmlns:a="http://schemas.openxmlformats.org/drawingml/2006/main" xmlns:r="http://schemas.openxmlformats.org/officeDocument/2006/relationships" xmlns:p="http://schemas.openxmlformats.org/presentationml/2006/main">
+<p:sld xmlns:a="http://schemas.openxmlformats.org/drawingml/2006/main" xmlns:p="http://schemas.openxmlformats.org/presentationml/2006/main" xmlns:r="http://schemas.openxmlformats.org/officeDocument/2006/relationships">
   <p:cSld>
     <p:spTree>
       <p:nvGrpSpPr>
@@ -6455,14 +8921,7 @@
         <p:cNvGrpSpPr/>
         <p:nvPr/>
       </p:nvGrpSpPr>
-      <p:grpSpPr>
-        <a:xfrm>
-          <a:off x="0" y="0"/>
-          <a:ext cx="0" cy="0"/>
-          <a:chOff x="0" y="0"/>
-          <a:chExt cx="0" cy="0"/>
-        </a:xfrm>
-      </p:grpSpPr>
+      <p:grpSpPr/>
       <p:sp>
         <p:nvSpPr>
           <p:cNvPr id="2" name="Content Placeholder 1"/>
@@ -6574,7 +9033,7 @@
             <a:spLocks noGrp="1"/>
           </p:cNvSpPr>
           <p:nvPr>
-            <p:ph type="body" sz="quarter" idx="13"/>
+            <p:ph type="body" idx="13" sz="quarter"/>
           </p:nvPr>
         </p:nvSpPr>
         <p:spPr/>
@@ -6597,7 +9056,7 @@
 </file>
 
 <file path=ppt/slides/slide7.xml><?xml version="1.0" encoding="utf-8"?>
-<p:sld xmlns:a="http://schemas.openxmlformats.org/drawingml/2006/main" xmlns:r="http://schemas.openxmlformats.org/officeDocument/2006/relationships" xmlns:p="http://schemas.openxmlformats.org/presentationml/2006/main">
+<p:sld xmlns:a="http://schemas.openxmlformats.org/drawingml/2006/main" xmlns:p="http://schemas.openxmlformats.org/presentationml/2006/main" xmlns:r="http://schemas.openxmlformats.org/officeDocument/2006/relationships">
   <p:cSld>
     <p:spTree>
       <p:nvGrpSpPr>
@@ -6605,14 +9064,7 @@
         <p:cNvGrpSpPr/>
         <p:nvPr/>
       </p:nvGrpSpPr>
-      <p:grpSpPr>
-        <a:xfrm>
-          <a:off x="0" y="0"/>
-          <a:ext cx="0" cy="0"/>
-          <a:chOff x="0" y="0"/>
-          <a:chExt cx="0" cy="0"/>
-        </a:xfrm>
-      </p:grpSpPr>
+      <p:grpSpPr/>
       <p:sp>
         <p:nvSpPr>
           <p:cNvPr id="2" name="Content Placeholder 1"/>
@@ -6700,7 +9152,7 @@
             <a:spLocks noGrp="1"/>
           </p:cNvSpPr>
           <p:nvPr>
-            <p:ph type="body" sz="quarter" idx="13"/>
+            <p:ph type="body" idx="13" sz="quarter"/>
           </p:nvPr>
         </p:nvSpPr>
         <p:spPr/>
@@ -6723,7 +9175,7 @@
 </file>
 
 <file path=ppt/slides/slide8.xml><?xml version="1.0" encoding="utf-8"?>
-<p:sld xmlns:a="http://schemas.openxmlformats.org/drawingml/2006/main" xmlns:r="http://schemas.openxmlformats.org/officeDocument/2006/relationships" xmlns:p="http://schemas.openxmlformats.org/presentationml/2006/main">
+<p:sld xmlns:a="http://schemas.openxmlformats.org/drawingml/2006/main" xmlns:p="http://schemas.openxmlformats.org/presentationml/2006/main" xmlns:r="http://schemas.openxmlformats.org/officeDocument/2006/relationships">
   <p:cSld>
     <p:spTree>
       <p:nvGrpSpPr>
@@ -6731,14 +9183,7 @@
         <p:cNvGrpSpPr/>
         <p:nvPr/>
       </p:nvGrpSpPr>
-      <p:grpSpPr>
-        <a:xfrm>
-          <a:off x="0" y="0"/>
-          <a:ext cx="0" cy="0"/>
-          <a:chOff x="0" y="0"/>
-          <a:chExt cx="0" cy="0"/>
-        </a:xfrm>
-      </p:grpSpPr>
+      <p:grpSpPr/>
       <p:sp>
         <p:nvSpPr>
           <p:cNvPr id="2" name="Content Placeholder 1"/>
@@ -6826,7 +9271,7 @@
             <a:spLocks noGrp="1"/>
           </p:cNvSpPr>
           <p:nvPr>
-            <p:ph type="body" sz="quarter" idx="13"/>
+            <p:ph type="body" idx="13" sz="quarter"/>
           </p:nvPr>
         </p:nvSpPr>
         <p:spPr/>
@@ -6849,7 +9294,7 @@
 </file>
 
 <file path=ppt/slides/slide9.xml><?xml version="1.0" encoding="utf-8"?>
-<p:sld xmlns:a="http://schemas.openxmlformats.org/drawingml/2006/main" xmlns:r="http://schemas.openxmlformats.org/officeDocument/2006/relationships" xmlns:p="http://schemas.openxmlformats.org/presentationml/2006/main">
+<p:sld xmlns:a="http://schemas.openxmlformats.org/drawingml/2006/main" xmlns:p="http://schemas.openxmlformats.org/presentationml/2006/main" xmlns:r="http://schemas.openxmlformats.org/officeDocument/2006/relationships">
   <p:cSld>
     <p:spTree>
       <p:nvGrpSpPr>
@@ -6857,14 +9302,7 @@
         <p:cNvGrpSpPr/>
         <p:nvPr/>
       </p:nvGrpSpPr>
-      <p:grpSpPr>
-        <a:xfrm>
-          <a:off x="0" y="0"/>
-          <a:ext cx="0" cy="0"/>
-          <a:chOff x="0" y="0"/>
-          <a:chExt cx="0" cy="0"/>
-        </a:xfrm>
-      </p:grpSpPr>
+      <p:grpSpPr/>
       <p:sp>
         <p:nvSpPr>
           <p:cNvPr id="2" name="Content Placeholder 1"/>
@@ -6952,7 +9390,7 @@
             <a:spLocks noGrp="1"/>
           </p:cNvSpPr>
           <p:nvPr>
-            <p:ph type="body" sz="quarter" idx="13"/>
+            <p:ph type="body" idx="13" sz="quarter"/>
           </p:nvPr>
         </p:nvSpPr>
         <p:spPr/>

</xml_diff>